<commit_message>
feat: harden LLM path with .env loading, safe caching, and grounding fixes
- Load ANTHROPIC_API_KEY from poc/.env; warn in sidebar when the LLM path
  can't work (missing dotenv or unset key)
- Replace @st.cache_data with a session-scoped cache that only stores
  successful `llm` briefings, so transient template fallbacks aren't stuck
- Grounding guard: ignore digits inside SKU codes/unit descriptors, pull
  numbers from strings (dates), and instruct the model to cite supplier
  po_value instead of summing items
- Rebuild Atlas_AI_Solution_Proposal.pptx

Co-Authored-By: Claude Opus 4.8 (1M context) <noreply@anthropic.com>
</commit_message>
<xml_diff>
--- a/proposal/Atlas_AI_Solution_Proposal.pptx
+++ b/proposal/Atlas_AI_Solution_Proposal.pptx
@@ -5,34 +5,34 @@
     <p:sldMasterId id="2147483648" r:id="rId1"/>
   </p:sldMasterIdLst>
   <p:sldIdLst>
-    <p:sldId id="256" r:id="rId7"/>
-    <p:sldId id="257" r:id="rId8"/>
-    <p:sldId id="258" r:id="rId9"/>
-    <p:sldId id="259" r:id="rId10"/>
-    <p:sldId id="260" r:id="rId11"/>
-    <p:sldId id="261" r:id="rId12"/>
-    <p:sldId id="262" r:id="rId13"/>
-    <p:sldId id="263" r:id="rId14"/>
-    <p:sldId id="264" r:id="rId15"/>
-    <p:sldId id="265" r:id="rId16"/>
-    <p:sldId id="266" r:id="rId17"/>
-    <p:sldId id="267" r:id="rId18"/>
-    <p:sldId id="268" r:id="rId19"/>
-    <p:sldId id="269" r:id="rId20"/>
-    <p:sldId id="270" r:id="rId21"/>
-    <p:sldId id="271" r:id="rId22"/>
-    <p:sldId id="272" r:id="rId23"/>
-    <p:sldId id="273" r:id="rId24"/>
-    <p:sldId id="274" r:id="rId25"/>
-    <p:sldId id="275" r:id="rId26"/>
-    <p:sldId id="276" r:id="rId27"/>
-    <p:sldId id="277" r:id="rId28"/>
-    <p:sldId id="278" r:id="rId29"/>
-    <p:sldId id="279" r:id="rId30"/>
-    <p:sldId id="280" r:id="rId31"/>
-    <p:sldId id="281" r:id="rId32"/>
+    <p:sldId id="256" r:id="rId2"/>
+    <p:sldId id="257" r:id="rId3"/>
+    <p:sldId id="258" r:id="rId4"/>
+    <p:sldId id="259" r:id="rId5"/>
+    <p:sldId id="260" r:id="rId6"/>
+    <p:sldId id="261" r:id="rId7"/>
+    <p:sldId id="262" r:id="rId8"/>
+    <p:sldId id="263" r:id="rId9"/>
+    <p:sldId id="264" r:id="rId10"/>
+    <p:sldId id="265" r:id="rId11"/>
+    <p:sldId id="266" r:id="rId12"/>
+    <p:sldId id="267" r:id="rId13"/>
+    <p:sldId id="268" r:id="rId14"/>
+    <p:sldId id="269" r:id="rId15"/>
+    <p:sldId id="270" r:id="rId16"/>
+    <p:sldId id="271" r:id="rId17"/>
+    <p:sldId id="272" r:id="rId18"/>
+    <p:sldId id="273" r:id="rId19"/>
+    <p:sldId id="274" r:id="rId20"/>
+    <p:sldId id="275" r:id="rId21"/>
+    <p:sldId id="276" r:id="rId22"/>
+    <p:sldId id="277" r:id="rId23"/>
+    <p:sldId id="278" r:id="rId24"/>
+    <p:sldId id="279" r:id="rId25"/>
+    <p:sldId id="280" r:id="rId26"/>
+    <p:sldId id="281" r:id="rId27"/>
   </p:sldIdLst>
-  <p:sldSz cx="12191695" cy="6858000" type="screen4x3"/>
+  <p:sldSz cx="12192000" cy="6858000"/>
   <p:notesSz cx="6858000" cy="9144000"/>
   <p:defaultTextStyle>
     <a:defPPr>
@@ -129,6 +129,22 @@
       </a:defRPr>
     </a:lvl9pPr>
   </p:defaultTextStyle>
+  <p:extLst>
+    <p:ext uri="{EFAFB233-063F-42B5-8137-9DF3F51BA10A}">
+      <p15:sldGuideLst xmlns:p15="http://schemas.microsoft.com/office/powerpoint/2012/main">
+        <p15:guide id="1" orient="horz" pos="2160">
+          <p15:clr>
+            <a:srgbClr val="A4A3A4"/>
+          </p15:clr>
+        </p15:guide>
+        <p15:guide id="2" pos="2880">
+          <p15:clr>
+            <a:srgbClr val="A4A3A4"/>
+          </p15:clr>
+        </p15:guide>
+      </p15:sldGuideLst>
+    </p:ext>
+  </p:extLst>
 </p:presentation>
 </file>
 
@@ -170,10 +186,9 @@
           <a:lstStyle/>
           <a:p>
             <a:r>
-              <a:rPr lang="en-US" smtClean="0"/>
+              <a:rPr lang="en-US"/>
               <a:t>Click to edit Master title style</a:t>
             </a:r>
-            <a:endParaRPr lang="en-US"/>
           </a:p>
         </p:txBody>
       </p:sp>
@@ -289,10 +304,9 @@
           </a:lstStyle>
           <a:p>
             <a:r>
-              <a:rPr lang="en-US" smtClean="0"/>
+              <a:rPr lang="en-US"/>
               <a:t>Click to edit Master subtitle style</a:t>
             </a:r>
-            <a:endParaRPr lang="en-US"/>
           </a:p>
         </p:txBody>
       </p:sp>
@@ -313,7 +327,7 @@
           <a:p>
             <a:fld id="{5BCAD085-E8A6-8845-BD4E-CB4CCA059FC4}" type="datetimeFigureOut">
               <a:rPr lang="en-US" smtClean="0"/>
-              <a:t>1/27/13</a:t>
+              <a:t>5/26/26</a:t>
             </a:fld>
             <a:endParaRPr lang="en-US"/>
           </a:p>
@@ -407,10 +421,9 @@
           <a:lstStyle/>
           <a:p>
             <a:r>
-              <a:rPr lang="en-US" smtClean="0"/>
+              <a:rPr lang="en-US"/>
               <a:t>Click to edit Master title style</a:t>
             </a:r>
-            <a:endParaRPr lang="en-US"/>
           </a:p>
         </p:txBody>
       </p:sp>
@@ -431,38 +444,37 @@
           <a:p>
             <a:pPr lvl="0"/>
             <a:r>
-              <a:rPr lang="en-US" smtClean="0"/>
+              <a:rPr lang="en-US"/>
               <a:t>Click to edit Master text styles</a:t>
             </a:r>
           </a:p>
           <a:p>
             <a:pPr lvl="1"/>
             <a:r>
-              <a:rPr lang="en-US" smtClean="0"/>
+              <a:rPr lang="en-US"/>
               <a:t>Second level</a:t>
             </a:r>
           </a:p>
           <a:p>
             <a:pPr lvl="2"/>
             <a:r>
-              <a:rPr lang="en-US" smtClean="0"/>
+              <a:rPr lang="en-US"/>
               <a:t>Third level</a:t>
             </a:r>
           </a:p>
           <a:p>
             <a:pPr lvl="3"/>
             <a:r>
-              <a:rPr lang="en-US" smtClean="0"/>
+              <a:rPr lang="en-US"/>
               <a:t>Fourth level</a:t>
             </a:r>
           </a:p>
           <a:p>
             <a:pPr lvl="4"/>
             <a:r>
-              <a:rPr lang="en-US" smtClean="0"/>
+              <a:rPr lang="en-US"/>
               <a:t>Fifth level</a:t>
             </a:r>
-            <a:endParaRPr lang="en-US"/>
           </a:p>
         </p:txBody>
       </p:sp>
@@ -483,7 +495,7 @@
           <a:p>
             <a:fld id="{5BCAD085-E8A6-8845-BD4E-CB4CCA059FC4}" type="datetimeFigureOut">
               <a:rPr lang="en-US" smtClean="0"/>
-              <a:t>1/27/13</a:t>
+              <a:t>5/26/26</a:t>
             </a:fld>
             <a:endParaRPr lang="en-US"/>
           </a:p>
@@ -582,10 +594,9 @@
           <a:lstStyle/>
           <a:p>
             <a:r>
-              <a:rPr lang="en-US" smtClean="0"/>
+              <a:rPr lang="en-US"/>
               <a:t>Click to edit Master title style</a:t>
             </a:r>
-            <a:endParaRPr lang="en-US"/>
           </a:p>
         </p:txBody>
       </p:sp>
@@ -611,38 +622,37 @@
           <a:p>
             <a:pPr lvl="0"/>
             <a:r>
-              <a:rPr lang="en-US" smtClean="0"/>
+              <a:rPr lang="en-US"/>
               <a:t>Click to edit Master text styles</a:t>
             </a:r>
           </a:p>
           <a:p>
             <a:pPr lvl="1"/>
             <a:r>
-              <a:rPr lang="en-US" smtClean="0"/>
+              <a:rPr lang="en-US"/>
               <a:t>Second level</a:t>
             </a:r>
           </a:p>
           <a:p>
             <a:pPr lvl="2"/>
             <a:r>
-              <a:rPr lang="en-US" smtClean="0"/>
+              <a:rPr lang="en-US"/>
               <a:t>Third level</a:t>
             </a:r>
           </a:p>
           <a:p>
             <a:pPr lvl="3"/>
             <a:r>
-              <a:rPr lang="en-US" smtClean="0"/>
+              <a:rPr lang="en-US"/>
               <a:t>Fourth level</a:t>
             </a:r>
           </a:p>
           <a:p>
             <a:pPr lvl="4"/>
             <a:r>
-              <a:rPr lang="en-US" smtClean="0"/>
+              <a:rPr lang="en-US"/>
               <a:t>Fifth level</a:t>
             </a:r>
-            <a:endParaRPr lang="en-US"/>
           </a:p>
         </p:txBody>
       </p:sp>
@@ -663,7 +673,7 @@
           <a:p>
             <a:fld id="{5BCAD085-E8A6-8845-BD4E-CB4CCA059FC4}" type="datetimeFigureOut">
               <a:rPr lang="en-US" smtClean="0"/>
-              <a:t>1/27/13</a:t>
+              <a:t>5/26/26</a:t>
             </a:fld>
             <a:endParaRPr lang="en-US"/>
           </a:p>
@@ -757,10 +767,9 @@
           <a:lstStyle/>
           <a:p>
             <a:r>
-              <a:rPr lang="en-US" smtClean="0"/>
+              <a:rPr lang="en-US"/>
               <a:t>Click to edit Master title style</a:t>
             </a:r>
-            <a:endParaRPr lang="en-US"/>
           </a:p>
         </p:txBody>
       </p:sp>
@@ -781,38 +790,37 @@
           <a:p>
             <a:pPr lvl="0"/>
             <a:r>
-              <a:rPr lang="en-US" smtClean="0"/>
+              <a:rPr lang="en-US"/>
               <a:t>Click to edit Master text styles</a:t>
             </a:r>
           </a:p>
           <a:p>
             <a:pPr lvl="1"/>
             <a:r>
-              <a:rPr lang="en-US" smtClean="0"/>
+              <a:rPr lang="en-US"/>
               <a:t>Second level</a:t>
             </a:r>
           </a:p>
           <a:p>
             <a:pPr lvl="2"/>
             <a:r>
-              <a:rPr lang="en-US" smtClean="0"/>
+              <a:rPr lang="en-US"/>
               <a:t>Third level</a:t>
             </a:r>
           </a:p>
           <a:p>
             <a:pPr lvl="3"/>
             <a:r>
-              <a:rPr lang="en-US" smtClean="0"/>
+              <a:rPr lang="en-US"/>
               <a:t>Fourth level</a:t>
             </a:r>
           </a:p>
           <a:p>
             <a:pPr lvl="4"/>
             <a:r>
-              <a:rPr lang="en-US" smtClean="0"/>
+              <a:rPr lang="en-US"/>
               <a:t>Fifth level</a:t>
             </a:r>
-            <a:endParaRPr lang="en-US"/>
           </a:p>
         </p:txBody>
       </p:sp>
@@ -833,7 +841,7 @@
           <a:p>
             <a:fld id="{5BCAD085-E8A6-8845-BD4E-CB4CCA059FC4}" type="datetimeFigureOut">
               <a:rPr lang="en-US" smtClean="0"/>
-              <a:t>1/27/13</a:t>
+              <a:t>5/26/26</a:t>
             </a:fld>
             <a:endParaRPr lang="en-US"/>
           </a:p>
@@ -936,10 +944,9 @@
           </a:lstStyle>
           <a:p>
             <a:r>
-              <a:rPr lang="en-US" smtClean="0"/>
+              <a:rPr lang="en-US"/>
               <a:t>Click to edit Master title style</a:t>
             </a:r>
-            <a:endParaRPr lang="en-US"/>
           </a:p>
         </p:txBody>
       </p:sp>
@@ -1056,7 +1063,7 @@
           <a:p>
             <a:pPr lvl="0"/>
             <a:r>
-              <a:rPr lang="en-US" smtClean="0"/>
+              <a:rPr lang="en-US"/>
               <a:t>Click to edit Master text styles</a:t>
             </a:r>
           </a:p>
@@ -1079,7 +1086,7 @@
           <a:p>
             <a:fld id="{5BCAD085-E8A6-8845-BD4E-CB4CCA059FC4}" type="datetimeFigureOut">
               <a:rPr lang="en-US" smtClean="0"/>
-              <a:t>1/27/13</a:t>
+              <a:t>5/26/26</a:t>
             </a:fld>
             <a:endParaRPr lang="en-US"/>
           </a:p>
@@ -1173,10 +1180,9 @@
           <a:lstStyle/>
           <a:p>
             <a:r>
-              <a:rPr lang="en-US" smtClean="0"/>
+              <a:rPr lang="en-US"/>
               <a:t>Click to edit Master title style</a:t>
             </a:r>
-            <a:endParaRPr lang="en-US"/>
           </a:p>
         </p:txBody>
       </p:sp>
@@ -1230,38 +1236,37 @@
           <a:p>
             <a:pPr lvl="0"/>
             <a:r>
-              <a:rPr lang="en-US" smtClean="0"/>
+              <a:rPr lang="en-US"/>
               <a:t>Click to edit Master text styles</a:t>
             </a:r>
           </a:p>
           <a:p>
             <a:pPr lvl="1"/>
             <a:r>
-              <a:rPr lang="en-US" smtClean="0"/>
+              <a:rPr lang="en-US"/>
               <a:t>Second level</a:t>
             </a:r>
           </a:p>
           <a:p>
             <a:pPr lvl="2"/>
             <a:r>
-              <a:rPr lang="en-US" smtClean="0"/>
+              <a:rPr lang="en-US"/>
               <a:t>Third level</a:t>
             </a:r>
           </a:p>
           <a:p>
             <a:pPr lvl="3"/>
             <a:r>
-              <a:rPr lang="en-US" smtClean="0"/>
+              <a:rPr lang="en-US"/>
               <a:t>Fourth level</a:t>
             </a:r>
           </a:p>
           <a:p>
             <a:pPr lvl="4"/>
             <a:r>
-              <a:rPr lang="en-US" smtClean="0"/>
+              <a:rPr lang="en-US"/>
               <a:t>Fifth level</a:t>
             </a:r>
-            <a:endParaRPr lang="en-US"/>
           </a:p>
         </p:txBody>
       </p:sp>
@@ -1315,38 +1320,37 @@
           <a:p>
             <a:pPr lvl="0"/>
             <a:r>
-              <a:rPr lang="en-US" smtClean="0"/>
+              <a:rPr lang="en-US"/>
               <a:t>Click to edit Master text styles</a:t>
             </a:r>
           </a:p>
           <a:p>
             <a:pPr lvl="1"/>
             <a:r>
-              <a:rPr lang="en-US" smtClean="0"/>
+              <a:rPr lang="en-US"/>
               <a:t>Second level</a:t>
             </a:r>
           </a:p>
           <a:p>
             <a:pPr lvl="2"/>
             <a:r>
-              <a:rPr lang="en-US" smtClean="0"/>
+              <a:rPr lang="en-US"/>
               <a:t>Third level</a:t>
             </a:r>
           </a:p>
           <a:p>
             <a:pPr lvl="3"/>
             <a:r>
-              <a:rPr lang="en-US" smtClean="0"/>
+              <a:rPr lang="en-US"/>
               <a:t>Fourth level</a:t>
             </a:r>
           </a:p>
           <a:p>
             <a:pPr lvl="4"/>
             <a:r>
-              <a:rPr lang="en-US" smtClean="0"/>
+              <a:rPr lang="en-US"/>
               <a:t>Fifth level</a:t>
             </a:r>
-            <a:endParaRPr lang="en-US"/>
           </a:p>
         </p:txBody>
       </p:sp>
@@ -1367,7 +1371,7 @@
           <a:p>
             <a:fld id="{5BCAD085-E8A6-8845-BD4E-CB4CCA059FC4}" type="datetimeFigureOut">
               <a:rPr lang="en-US" smtClean="0"/>
-              <a:t>1/27/13</a:t>
+              <a:t>5/26/26</a:t>
             </a:fld>
             <a:endParaRPr lang="en-US"/>
           </a:p>
@@ -1465,10 +1469,9 @@
           </a:lstStyle>
           <a:p>
             <a:r>
-              <a:rPr lang="en-US" smtClean="0"/>
+              <a:rPr lang="en-US"/>
               <a:t>Click to edit Master title style</a:t>
             </a:r>
-            <a:endParaRPr lang="en-US"/>
           </a:p>
         </p:txBody>
       </p:sp>
@@ -1531,7 +1534,7 @@
           <a:p>
             <a:pPr lvl="0"/>
             <a:r>
-              <a:rPr lang="en-US" smtClean="0"/>
+              <a:rPr lang="en-US"/>
               <a:t>Click to edit Master text styles</a:t>
             </a:r>
           </a:p>
@@ -1587,38 +1590,37 @@
           <a:p>
             <a:pPr lvl="0"/>
             <a:r>
-              <a:rPr lang="en-US" smtClean="0"/>
+              <a:rPr lang="en-US"/>
               <a:t>Click to edit Master text styles</a:t>
             </a:r>
           </a:p>
           <a:p>
             <a:pPr lvl="1"/>
             <a:r>
-              <a:rPr lang="en-US" smtClean="0"/>
+              <a:rPr lang="en-US"/>
               <a:t>Second level</a:t>
             </a:r>
           </a:p>
           <a:p>
             <a:pPr lvl="2"/>
             <a:r>
-              <a:rPr lang="en-US" smtClean="0"/>
+              <a:rPr lang="en-US"/>
               <a:t>Third level</a:t>
             </a:r>
           </a:p>
           <a:p>
             <a:pPr lvl="3"/>
             <a:r>
-              <a:rPr lang="en-US" smtClean="0"/>
+              <a:rPr lang="en-US"/>
               <a:t>Fourth level</a:t>
             </a:r>
           </a:p>
           <a:p>
             <a:pPr lvl="4"/>
             <a:r>
-              <a:rPr lang="en-US" smtClean="0"/>
+              <a:rPr lang="en-US"/>
               <a:t>Fifth level</a:t>
             </a:r>
-            <a:endParaRPr lang="en-US"/>
           </a:p>
         </p:txBody>
       </p:sp>
@@ -1681,7 +1683,7 @@
           <a:p>
             <a:pPr lvl="0"/>
             <a:r>
-              <a:rPr lang="en-US" smtClean="0"/>
+              <a:rPr lang="en-US"/>
               <a:t>Click to edit Master text styles</a:t>
             </a:r>
           </a:p>
@@ -1737,38 +1739,37 @@
           <a:p>
             <a:pPr lvl="0"/>
             <a:r>
-              <a:rPr lang="en-US" smtClean="0"/>
+              <a:rPr lang="en-US"/>
               <a:t>Click to edit Master text styles</a:t>
             </a:r>
           </a:p>
           <a:p>
             <a:pPr lvl="1"/>
             <a:r>
-              <a:rPr lang="en-US" smtClean="0"/>
+              <a:rPr lang="en-US"/>
               <a:t>Second level</a:t>
             </a:r>
           </a:p>
           <a:p>
             <a:pPr lvl="2"/>
             <a:r>
-              <a:rPr lang="en-US" smtClean="0"/>
+              <a:rPr lang="en-US"/>
               <a:t>Third level</a:t>
             </a:r>
           </a:p>
           <a:p>
             <a:pPr lvl="3"/>
             <a:r>
-              <a:rPr lang="en-US" smtClean="0"/>
+              <a:rPr lang="en-US"/>
               <a:t>Fourth level</a:t>
             </a:r>
           </a:p>
           <a:p>
             <a:pPr lvl="4"/>
             <a:r>
-              <a:rPr lang="en-US" smtClean="0"/>
+              <a:rPr lang="en-US"/>
               <a:t>Fifth level</a:t>
             </a:r>
-            <a:endParaRPr lang="en-US"/>
           </a:p>
         </p:txBody>
       </p:sp>
@@ -1789,7 +1790,7 @@
           <a:p>
             <a:fld id="{5BCAD085-E8A6-8845-BD4E-CB4CCA059FC4}" type="datetimeFigureOut">
               <a:rPr lang="en-US" smtClean="0"/>
-              <a:t>1/27/13</a:t>
+              <a:t>5/26/26</a:t>
             </a:fld>
             <a:endParaRPr lang="en-US"/>
           </a:p>
@@ -1883,10 +1884,9 @@
           <a:lstStyle/>
           <a:p>
             <a:r>
-              <a:rPr lang="en-US" smtClean="0"/>
+              <a:rPr lang="en-US"/>
               <a:t>Click to edit Master title style</a:t>
             </a:r>
-            <a:endParaRPr lang="en-US"/>
           </a:p>
         </p:txBody>
       </p:sp>
@@ -1907,7 +1907,7 @@
           <a:p>
             <a:fld id="{5BCAD085-E8A6-8845-BD4E-CB4CCA059FC4}" type="datetimeFigureOut">
               <a:rPr lang="en-US" smtClean="0"/>
-              <a:t>1/27/13</a:t>
+              <a:t>5/26/26</a:t>
             </a:fld>
             <a:endParaRPr lang="en-US"/>
           </a:p>
@@ -2002,7 +2002,7 @@
           <a:p>
             <a:fld id="{5BCAD085-E8A6-8845-BD4E-CB4CCA059FC4}" type="datetimeFigureOut">
               <a:rPr lang="en-US" smtClean="0"/>
-              <a:t>1/27/13</a:t>
+              <a:t>5/26/26</a:t>
             </a:fld>
             <a:endParaRPr lang="en-US"/>
           </a:p>
@@ -2105,10 +2105,9 @@
           </a:lstStyle>
           <a:p>
             <a:r>
-              <a:rPr lang="en-US" smtClean="0"/>
+              <a:rPr lang="en-US"/>
               <a:t>Click to edit Master title style</a:t>
             </a:r>
-            <a:endParaRPr lang="en-US"/>
           </a:p>
         </p:txBody>
       </p:sp>
@@ -2162,38 +2161,37 @@
           <a:p>
             <a:pPr lvl="0"/>
             <a:r>
-              <a:rPr lang="en-US" smtClean="0"/>
+              <a:rPr lang="en-US"/>
               <a:t>Click to edit Master text styles</a:t>
             </a:r>
           </a:p>
           <a:p>
             <a:pPr lvl="1"/>
             <a:r>
-              <a:rPr lang="en-US" smtClean="0"/>
+              <a:rPr lang="en-US"/>
               <a:t>Second level</a:t>
             </a:r>
           </a:p>
           <a:p>
             <a:pPr lvl="2"/>
             <a:r>
-              <a:rPr lang="en-US" smtClean="0"/>
+              <a:rPr lang="en-US"/>
               <a:t>Third level</a:t>
             </a:r>
           </a:p>
           <a:p>
             <a:pPr lvl="3"/>
             <a:r>
-              <a:rPr lang="en-US" smtClean="0"/>
+              <a:rPr lang="en-US"/>
               <a:t>Fourth level</a:t>
             </a:r>
           </a:p>
           <a:p>
             <a:pPr lvl="4"/>
             <a:r>
-              <a:rPr lang="en-US" smtClean="0"/>
+              <a:rPr lang="en-US"/>
               <a:t>Fifth level</a:t>
             </a:r>
-            <a:endParaRPr lang="en-US"/>
           </a:p>
         </p:txBody>
       </p:sp>
@@ -2256,7 +2254,7 @@
           <a:p>
             <a:pPr lvl="0"/>
             <a:r>
-              <a:rPr lang="en-US" smtClean="0"/>
+              <a:rPr lang="en-US"/>
               <a:t>Click to edit Master text styles</a:t>
             </a:r>
           </a:p>
@@ -2279,7 +2277,7 @@
           <a:p>
             <a:fld id="{5BCAD085-E8A6-8845-BD4E-CB4CCA059FC4}" type="datetimeFigureOut">
               <a:rPr lang="en-US" smtClean="0"/>
-              <a:t>1/27/13</a:t>
+              <a:t>5/26/26</a:t>
             </a:fld>
             <a:endParaRPr lang="en-US"/>
           </a:p>
@@ -2382,10 +2380,9 @@
           </a:lstStyle>
           <a:p>
             <a:r>
-              <a:rPr lang="en-US" smtClean="0"/>
+              <a:rPr lang="en-US"/>
               <a:t>Click to edit Master title style</a:t>
             </a:r>
-            <a:endParaRPr lang="en-US"/>
           </a:p>
         </p:txBody>
       </p:sp>
@@ -2509,7 +2506,7 @@
           <a:p>
             <a:pPr lvl="0"/>
             <a:r>
-              <a:rPr lang="en-US" smtClean="0"/>
+              <a:rPr lang="en-US"/>
               <a:t>Click to edit Master text styles</a:t>
             </a:r>
           </a:p>
@@ -2532,7 +2529,7 @@
           <a:p>
             <a:fld id="{5BCAD085-E8A6-8845-BD4E-CB4CCA059FC4}" type="datetimeFigureOut">
               <a:rPr lang="en-US" smtClean="0"/>
-              <a:t>1/27/13</a:t>
+              <a:t>5/26/26</a:t>
             </a:fld>
             <a:endParaRPr lang="en-US"/>
           </a:p>
@@ -2641,10 +2638,9 @@
           <a:lstStyle/>
           <a:p>
             <a:r>
-              <a:rPr lang="en-US" smtClean="0"/>
+              <a:rPr lang="en-US"/>
               <a:t>Click to edit Master title style</a:t>
             </a:r>
-            <a:endParaRPr lang="en-US"/>
           </a:p>
         </p:txBody>
       </p:sp>
@@ -2675,38 +2671,37 @@
           <a:p>
             <a:pPr lvl="0"/>
             <a:r>
-              <a:rPr lang="en-US" smtClean="0"/>
+              <a:rPr lang="en-US"/>
               <a:t>Click to edit Master text styles</a:t>
             </a:r>
           </a:p>
           <a:p>
             <a:pPr lvl="1"/>
             <a:r>
-              <a:rPr lang="en-US" smtClean="0"/>
+              <a:rPr lang="en-US"/>
               <a:t>Second level</a:t>
             </a:r>
           </a:p>
           <a:p>
             <a:pPr lvl="2"/>
             <a:r>
-              <a:rPr lang="en-US" smtClean="0"/>
+              <a:rPr lang="en-US"/>
               <a:t>Third level</a:t>
             </a:r>
           </a:p>
           <a:p>
             <a:pPr lvl="3"/>
             <a:r>
-              <a:rPr lang="en-US" smtClean="0"/>
+              <a:rPr lang="en-US"/>
               <a:t>Fourth level</a:t>
             </a:r>
           </a:p>
           <a:p>
             <a:pPr lvl="4"/>
             <a:r>
-              <a:rPr lang="en-US" smtClean="0"/>
+              <a:rPr lang="en-US"/>
               <a:t>Fifth level</a:t>
             </a:r>
-            <a:endParaRPr lang="en-US"/>
           </a:p>
         </p:txBody>
       </p:sp>
@@ -2745,7 +2740,7 @@
           <a:p>
             <a:fld id="{5BCAD085-E8A6-8845-BD4E-CB4CCA059FC4}" type="datetimeFigureOut">
               <a:rPr lang="en-US" smtClean="0"/>
-              <a:t>1/27/13</a:t>
+              <a:t>5/26/26</a:t>
             </a:fld>
             <a:endParaRPr lang="en-US"/>
           </a:p>
@@ -3104,7 +3099,7 @@
 </file>
 
 <file path=ppt/slides/slide1.xml><?xml version="1.0" encoding="utf-8"?>
-<p:sld xmlns:a="http://schemas.openxmlformats.org/drawingml/2006/main" xmlns:p="http://schemas.openxmlformats.org/presentationml/2006/main" xmlns:r="http://schemas.openxmlformats.org/officeDocument/2006/relationships">
+<p:sld xmlns:a="http://schemas.openxmlformats.org/drawingml/2006/main" xmlns:r="http://schemas.openxmlformats.org/officeDocument/2006/relationships" xmlns:p="http://schemas.openxmlformats.org/presentationml/2006/main">
   <p:cSld>
     <p:spTree>
       <p:nvGrpSpPr>
@@ -3112,7 +3107,14 @@
         <p:cNvGrpSpPr/>
         <p:nvPr/>
       </p:nvGrpSpPr>
-      <p:grpSpPr/>
+      <p:grpSpPr>
+        <a:xfrm>
+          <a:off x="0" y="0"/>
+          <a:ext cx="0" cy="0"/>
+          <a:chOff x="0" y="0"/>
+          <a:chExt cx="0" cy="0"/>
+        </a:xfrm>
+      </p:grpSpPr>
       <p:sp>
         <p:nvSpPr>
           <p:cNvPr id="2" name="Rectangle 1"/>
@@ -3154,6 +3156,7 @@
           <a:lstStyle/>
           <a:p>
             <a:pPr algn="ctr"/>
+            <a:endParaRPr/>
           </a:p>
         </p:txBody>
       </p:sp>
@@ -3198,6 +3201,7 @@
           <a:lstStyle/>
           <a:p>
             <a:pPr algn="ctr"/>
+            <a:endParaRPr/>
           </a:p>
         </p:txBody>
       </p:sp>
@@ -3224,7 +3228,7 @@
           <a:lstStyle/>
           <a:p>
             <a:r>
-              <a:rPr b="1" sz="4400">
+              <a:rPr sz="4400" b="1">
                 <a:solidFill>
                   <a:srgbClr val="FFFFFF"/>
                 </a:solidFill>
@@ -3307,7 +3311,7 @@
 </file>
 
 <file path=ppt/slides/slide10.xml><?xml version="1.0" encoding="utf-8"?>
-<p:sld xmlns:a="http://schemas.openxmlformats.org/drawingml/2006/main" xmlns:p="http://schemas.openxmlformats.org/presentationml/2006/main" xmlns:r="http://schemas.openxmlformats.org/officeDocument/2006/relationships">
+<p:sld xmlns:a="http://schemas.openxmlformats.org/drawingml/2006/main" xmlns:r="http://schemas.openxmlformats.org/officeDocument/2006/relationships" xmlns:p="http://schemas.openxmlformats.org/presentationml/2006/main">
   <p:cSld>
     <p:spTree>
       <p:nvGrpSpPr>
@@ -3315,7 +3319,14 @@
         <p:cNvGrpSpPr/>
         <p:nvPr/>
       </p:nvGrpSpPr>
-      <p:grpSpPr/>
+      <p:grpSpPr>
+        <a:xfrm>
+          <a:off x="0" y="0"/>
+          <a:ext cx="0" cy="0"/>
+          <a:chOff x="0" y="0"/>
+          <a:chExt cx="0" cy="0"/>
+        </a:xfrm>
+      </p:grpSpPr>
       <p:sp>
         <p:nvSpPr>
           <p:cNvPr id="2" name="Rectangle 1"/>
@@ -3357,6 +3368,7 @@
           <a:lstStyle/>
           <a:p>
             <a:pPr algn="ctr"/>
+            <a:endParaRPr/>
           </a:p>
         </p:txBody>
       </p:sp>
@@ -3401,6 +3413,7 @@
           <a:lstStyle/>
           <a:p>
             <a:pPr algn="ctr"/>
+            <a:endParaRPr/>
           </a:p>
         </p:txBody>
       </p:sp>
@@ -3427,7 +3440,7 @@
           <a:lstStyle/>
           <a:p>
             <a:r>
-              <a:rPr b="1" sz="2400">
+              <a:rPr sz="2400" b="1">
                 <a:solidFill>
                   <a:srgbClr val="FFFFFF"/>
                 </a:solidFill>
@@ -3603,7 +3616,7 @@
 </file>
 
 <file path=ppt/slides/slide11.xml><?xml version="1.0" encoding="utf-8"?>
-<p:sld xmlns:a="http://schemas.openxmlformats.org/drawingml/2006/main" xmlns:p="http://schemas.openxmlformats.org/presentationml/2006/main" xmlns:r="http://schemas.openxmlformats.org/officeDocument/2006/relationships">
+<p:sld xmlns:a="http://schemas.openxmlformats.org/drawingml/2006/main" xmlns:r="http://schemas.openxmlformats.org/officeDocument/2006/relationships" xmlns:p="http://schemas.openxmlformats.org/presentationml/2006/main">
   <p:cSld>
     <p:spTree>
       <p:nvGrpSpPr>
@@ -3611,7 +3624,14 @@
         <p:cNvGrpSpPr/>
         <p:nvPr/>
       </p:nvGrpSpPr>
-      <p:grpSpPr/>
+      <p:grpSpPr>
+        <a:xfrm>
+          <a:off x="0" y="0"/>
+          <a:ext cx="0" cy="0"/>
+          <a:chOff x="0" y="0"/>
+          <a:chExt cx="0" cy="0"/>
+        </a:xfrm>
+      </p:grpSpPr>
       <p:sp>
         <p:nvSpPr>
           <p:cNvPr id="2" name="Rectangle 1"/>
@@ -3653,6 +3673,7 @@
           <a:lstStyle/>
           <a:p>
             <a:pPr algn="ctr"/>
+            <a:endParaRPr/>
           </a:p>
         </p:txBody>
       </p:sp>
@@ -3697,6 +3718,7 @@
           <a:lstStyle/>
           <a:p>
             <a:pPr algn="ctr"/>
+            <a:endParaRPr/>
           </a:p>
         </p:txBody>
       </p:sp>
@@ -3723,7 +3745,7 @@
           <a:lstStyle/>
           <a:p>
             <a:r>
-              <a:rPr b="1" sz="2400">
+              <a:rPr sz="2400" b="1">
                 <a:solidFill>
                   <a:srgbClr val="FFFFFF"/>
                 </a:solidFill>
@@ -3884,7 +3906,7 @@
 </file>
 
 <file path=ppt/slides/slide12.xml><?xml version="1.0" encoding="utf-8"?>
-<p:sld xmlns:a="http://schemas.openxmlformats.org/drawingml/2006/main" xmlns:p="http://schemas.openxmlformats.org/presentationml/2006/main" xmlns:r="http://schemas.openxmlformats.org/officeDocument/2006/relationships">
+<p:sld xmlns:a="http://schemas.openxmlformats.org/drawingml/2006/main" xmlns:r="http://schemas.openxmlformats.org/officeDocument/2006/relationships" xmlns:p="http://schemas.openxmlformats.org/presentationml/2006/main">
   <p:cSld>
     <p:spTree>
       <p:nvGrpSpPr>
@@ -3892,7 +3914,14 @@
         <p:cNvGrpSpPr/>
         <p:nvPr/>
       </p:nvGrpSpPr>
-      <p:grpSpPr/>
+      <p:grpSpPr>
+        <a:xfrm>
+          <a:off x="0" y="0"/>
+          <a:ext cx="0" cy="0"/>
+          <a:chOff x="0" y="0"/>
+          <a:chExt cx="0" cy="0"/>
+        </a:xfrm>
+      </p:grpSpPr>
       <p:sp>
         <p:nvSpPr>
           <p:cNvPr id="2" name="Rectangle 1"/>
@@ -3934,6 +3963,7 @@
           <a:lstStyle/>
           <a:p>
             <a:pPr algn="ctr"/>
+            <a:endParaRPr/>
           </a:p>
         </p:txBody>
       </p:sp>
@@ -3978,6 +4008,7 @@
           <a:lstStyle/>
           <a:p>
             <a:pPr algn="ctr"/>
+            <a:endParaRPr/>
           </a:p>
         </p:txBody>
       </p:sp>
@@ -4004,7 +4035,7 @@
           <a:lstStyle/>
           <a:p>
             <a:r>
-              <a:rPr b="1" sz="2400">
+              <a:rPr sz="2400" b="1">
                 <a:solidFill>
                   <a:srgbClr val="FFFFFF"/>
                 </a:solidFill>
@@ -4303,6 +4334,7 @@
           <a:lstStyle/>
           <a:p>
             <a:pPr algn="ctr"/>
+            <a:endParaRPr/>
           </a:p>
         </p:txBody>
       </p:sp>
@@ -4394,7 +4426,7 @@
 </file>
 
 <file path=ppt/slides/slide13.xml><?xml version="1.0" encoding="utf-8"?>
-<p:sld xmlns:a="http://schemas.openxmlformats.org/drawingml/2006/main" xmlns:p="http://schemas.openxmlformats.org/presentationml/2006/main" xmlns:r="http://schemas.openxmlformats.org/officeDocument/2006/relationships">
+<p:sld xmlns:a="http://schemas.openxmlformats.org/drawingml/2006/main" xmlns:r="http://schemas.openxmlformats.org/officeDocument/2006/relationships" xmlns:p="http://schemas.openxmlformats.org/presentationml/2006/main">
   <p:cSld>
     <p:spTree>
       <p:nvGrpSpPr>
@@ -4402,7 +4434,14 @@
         <p:cNvGrpSpPr/>
         <p:nvPr/>
       </p:nvGrpSpPr>
-      <p:grpSpPr/>
+      <p:grpSpPr>
+        <a:xfrm>
+          <a:off x="0" y="0"/>
+          <a:ext cx="0" cy="0"/>
+          <a:chOff x="0" y="0"/>
+          <a:chExt cx="0" cy="0"/>
+        </a:xfrm>
+      </p:grpSpPr>
       <p:sp>
         <p:nvSpPr>
           <p:cNvPr id="2" name="Rectangle 1"/>
@@ -4444,6 +4483,7 @@
           <a:lstStyle/>
           <a:p>
             <a:pPr algn="ctr"/>
+            <a:endParaRPr/>
           </a:p>
         </p:txBody>
       </p:sp>
@@ -4488,6 +4528,7 @@
           <a:lstStyle/>
           <a:p>
             <a:pPr algn="ctr"/>
+            <a:endParaRPr/>
           </a:p>
         </p:txBody>
       </p:sp>
@@ -4514,7 +4555,7 @@
           <a:lstStyle/>
           <a:p>
             <a:r>
-              <a:rPr b="1" sz="2400">
+              <a:rPr sz="2400" b="1">
                 <a:solidFill>
                   <a:srgbClr val="FFFFFF"/>
                 </a:solidFill>
@@ -4586,9 +4627,27 @@
                 <a:tableStyleId>{5C22544A-7EE6-4342-B048-85BDC9FD1C3A}</a:tableStyleId>
               </a:tblPr>
               <a:tblGrid>
-                <a:gridCol w="3749040"/>
-                <a:gridCol w="3749040"/>
-                <a:gridCol w="3749040"/>
+                <a:gridCol w="3749040">
+                  <a:extLst>
+                    <a:ext uri="{9D8B030D-6E8A-4147-A177-3AD203B41FA5}">
+                      <a16:colId xmlns:a16="http://schemas.microsoft.com/office/drawing/2014/main" val="20000"/>
+                    </a:ext>
+                  </a:extLst>
+                </a:gridCol>
+                <a:gridCol w="3749040">
+                  <a:extLst>
+                    <a:ext uri="{9D8B030D-6E8A-4147-A177-3AD203B41FA5}">
+                      <a16:colId xmlns:a16="http://schemas.microsoft.com/office/drawing/2014/main" val="20001"/>
+                    </a:ext>
+                  </a:extLst>
+                </a:gridCol>
+                <a:gridCol w="3749040">
+                  <a:extLst>
+                    <a:ext uri="{9D8B030D-6E8A-4147-A177-3AD203B41FA5}">
+                      <a16:colId xmlns:a16="http://schemas.microsoft.com/office/drawing/2014/main" val="20002"/>
+                    </a:ext>
+                  </a:extLst>
+                </a:gridCol>
               </a:tblGrid>
               <a:tr h="365760">
                 <a:tc>
@@ -4654,6 +4713,11 @@
                     </a:solidFill>
                   </a:tcPr>
                 </a:tc>
+                <a:extLst>
+                  <a:ext uri="{0D108BD9-81ED-4DB2-BD59-A6C34878D82A}">
+                    <a16:rowId xmlns:a16="http://schemas.microsoft.com/office/drawing/2014/main" val="10000"/>
+                  </a:ext>
+                </a:extLst>
               </a:tr>
               <a:tr h="365760">
                 <a:tc>
@@ -4719,6 +4783,11 @@
                     </a:solidFill>
                   </a:tcPr>
                 </a:tc>
+                <a:extLst>
+                  <a:ext uri="{0D108BD9-81ED-4DB2-BD59-A6C34878D82A}">
+                    <a16:rowId xmlns:a16="http://schemas.microsoft.com/office/drawing/2014/main" val="10001"/>
+                  </a:ext>
+                </a:extLst>
               </a:tr>
               <a:tr h="365760">
                 <a:tc>
@@ -4784,6 +4853,11 @@
                     </a:solidFill>
                   </a:tcPr>
                 </a:tc>
+                <a:extLst>
+                  <a:ext uri="{0D108BD9-81ED-4DB2-BD59-A6C34878D82A}">
+                    <a16:rowId xmlns:a16="http://schemas.microsoft.com/office/drawing/2014/main" val="10002"/>
+                  </a:ext>
+                </a:extLst>
               </a:tr>
               <a:tr h="365760">
                 <a:tc>
@@ -4849,6 +4923,11 @@
                     </a:solidFill>
                   </a:tcPr>
                 </a:tc>
+                <a:extLst>
+                  <a:ext uri="{0D108BD9-81ED-4DB2-BD59-A6C34878D82A}">
+                    <a16:rowId xmlns:a16="http://schemas.microsoft.com/office/drawing/2014/main" val="10003"/>
+                  </a:ext>
+                </a:extLst>
               </a:tr>
               <a:tr h="365760">
                 <a:tc>
@@ -4914,6 +4993,11 @@
                     </a:solidFill>
                   </a:tcPr>
                 </a:tc>
+                <a:extLst>
+                  <a:ext uri="{0D108BD9-81ED-4DB2-BD59-A6C34878D82A}">
+                    <a16:rowId xmlns:a16="http://schemas.microsoft.com/office/drawing/2014/main" val="10004"/>
+                  </a:ext>
+                </a:extLst>
               </a:tr>
               <a:tr h="365760">
                 <a:tc>
@@ -4979,6 +5063,11 @@
                     </a:solidFill>
                   </a:tcPr>
                 </a:tc>
+                <a:extLst>
+                  <a:ext uri="{0D108BD9-81ED-4DB2-BD59-A6C34878D82A}">
+                    <a16:rowId xmlns:a16="http://schemas.microsoft.com/office/drawing/2014/main" val="10005"/>
+                  </a:ext>
+                </a:extLst>
               </a:tr>
             </a:tbl>
           </a:graphicData>
@@ -5184,7 +5273,7 @@
 </file>
 
 <file path=ppt/slides/slide14.xml><?xml version="1.0" encoding="utf-8"?>
-<p:sld xmlns:a="http://schemas.openxmlformats.org/drawingml/2006/main" xmlns:p="http://schemas.openxmlformats.org/presentationml/2006/main" xmlns:r="http://schemas.openxmlformats.org/officeDocument/2006/relationships">
+<p:sld xmlns:a="http://schemas.openxmlformats.org/drawingml/2006/main" xmlns:r="http://schemas.openxmlformats.org/officeDocument/2006/relationships" xmlns:p="http://schemas.openxmlformats.org/presentationml/2006/main">
   <p:cSld>
     <p:spTree>
       <p:nvGrpSpPr>
@@ -5192,7 +5281,14 @@
         <p:cNvGrpSpPr/>
         <p:nvPr/>
       </p:nvGrpSpPr>
-      <p:grpSpPr/>
+      <p:grpSpPr>
+        <a:xfrm>
+          <a:off x="0" y="0"/>
+          <a:ext cx="0" cy="0"/>
+          <a:chOff x="0" y="0"/>
+          <a:chExt cx="0" cy="0"/>
+        </a:xfrm>
+      </p:grpSpPr>
       <p:sp>
         <p:nvSpPr>
           <p:cNvPr id="2" name="Rectangle 1"/>
@@ -5234,6 +5330,7 @@
           <a:lstStyle/>
           <a:p>
             <a:pPr algn="ctr"/>
+            <a:endParaRPr/>
           </a:p>
         </p:txBody>
       </p:sp>
@@ -5278,6 +5375,7 @@
           <a:lstStyle/>
           <a:p>
             <a:pPr algn="ctr"/>
+            <a:endParaRPr/>
           </a:p>
         </p:txBody>
       </p:sp>
@@ -5304,7 +5402,7 @@
           <a:lstStyle/>
           <a:p>
             <a:r>
-              <a:rPr b="1" sz="2400">
+              <a:rPr sz="2400" b="1">
                 <a:solidFill>
                   <a:srgbClr val="FFFFFF"/>
                 </a:solidFill>
@@ -5343,9 +5441,27 @@
                 <a:tableStyleId>{5C22544A-7EE6-4342-B048-85BDC9FD1C3A}</a:tableStyleId>
               </a:tblPr>
               <a:tblGrid>
-                <a:gridCol w="3810000"/>
-                <a:gridCol w="3810000"/>
-                <a:gridCol w="3810000"/>
+                <a:gridCol w="3810000">
+                  <a:extLst>
+                    <a:ext uri="{9D8B030D-6E8A-4147-A177-3AD203B41FA5}">
+                      <a16:colId xmlns:a16="http://schemas.microsoft.com/office/drawing/2014/main" val="20000"/>
+                    </a:ext>
+                  </a:extLst>
+                </a:gridCol>
+                <a:gridCol w="3810000">
+                  <a:extLst>
+                    <a:ext uri="{9D8B030D-6E8A-4147-A177-3AD203B41FA5}">
+                      <a16:colId xmlns:a16="http://schemas.microsoft.com/office/drawing/2014/main" val="20001"/>
+                    </a:ext>
+                  </a:extLst>
+                </a:gridCol>
+                <a:gridCol w="3810000">
+                  <a:extLst>
+                    <a:ext uri="{9D8B030D-6E8A-4147-A177-3AD203B41FA5}">
+                      <a16:colId xmlns:a16="http://schemas.microsoft.com/office/drawing/2014/main" val="20002"/>
+                    </a:ext>
+                  </a:extLst>
+                </a:gridCol>
               </a:tblGrid>
               <a:tr h="640080">
                 <a:tc>
@@ -5411,6 +5527,11 @@
                     </a:solidFill>
                   </a:tcPr>
                 </a:tc>
+                <a:extLst>
+                  <a:ext uri="{0D108BD9-81ED-4DB2-BD59-A6C34878D82A}">
+                    <a16:rowId xmlns:a16="http://schemas.microsoft.com/office/drawing/2014/main" val="10000"/>
+                  </a:ext>
+                </a:extLst>
               </a:tr>
               <a:tr h="640080">
                 <a:tc>
@@ -5476,6 +5597,11 @@
                     </a:solidFill>
                   </a:tcPr>
                 </a:tc>
+                <a:extLst>
+                  <a:ext uri="{0D108BD9-81ED-4DB2-BD59-A6C34878D82A}">
+                    <a16:rowId xmlns:a16="http://schemas.microsoft.com/office/drawing/2014/main" val="10001"/>
+                  </a:ext>
+                </a:extLst>
               </a:tr>
               <a:tr h="640080">
                 <a:tc>
@@ -5541,6 +5667,11 @@
                     </a:solidFill>
                   </a:tcPr>
                 </a:tc>
+                <a:extLst>
+                  <a:ext uri="{0D108BD9-81ED-4DB2-BD59-A6C34878D82A}">
+                    <a16:rowId xmlns:a16="http://schemas.microsoft.com/office/drawing/2014/main" val="10002"/>
+                  </a:ext>
+                </a:extLst>
               </a:tr>
               <a:tr h="640080">
                 <a:tc>
@@ -5606,6 +5737,11 @@
                     </a:solidFill>
                   </a:tcPr>
                 </a:tc>
+                <a:extLst>
+                  <a:ext uri="{0D108BD9-81ED-4DB2-BD59-A6C34878D82A}">
+                    <a16:rowId xmlns:a16="http://schemas.microsoft.com/office/drawing/2014/main" val="10003"/>
+                  </a:ext>
+                </a:extLst>
               </a:tr>
               <a:tr h="640080">
                 <a:tc>
@@ -5671,6 +5807,11 @@
                     </a:solidFill>
                   </a:tcPr>
                 </a:tc>
+                <a:extLst>
+                  <a:ext uri="{0D108BD9-81ED-4DB2-BD59-A6C34878D82A}">
+                    <a16:rowId xmlns:a16="http://schemas.microsoft.com/office/drawing/2014/main" val="10004"/>
+                  </a:ext>
+                </a:extLst>
               </a:tr>
               <a:tr h="640080">
                 <a:tc>
@@ -5736,6 +5877,11 @@
                     </a:solidFill>
                   </a:tcPr>
                 </a:tc>
+                <a:extLst>
+                  <a:ext uri="{0D108BD9-81ED-4DB2-BD59-A6C34878D82A}">
+                    <a16:rowId xmlns:a16="http://schemas.microsoft.com/office/drawing/2014/main" val="10005"/>
+                  </a:ext>
+                </a:extLst>
               </a:tr>
               <a:tr h="640080">
                 <a:tc>
@@ -5801,6 +5947,11 @@
                     </a:solidFill>
                   </a:tcPr>
                 </a:tc>
+                <a:extLst>
+                  <a:ext uri="{0D108BD9-81ED-4DB2-BD59-A6C34878D82A}">
+                    <a16:rowId xmlns:a16="http://schemas.microsoft.com/office/drawing/2014/main" val="10006"/>
+                  </a:ext>
+                </a:extLst>
               </a:tr>
               <a:tr h="640080">
                 <a:tc>
@@ -5866,6 +6017,11 @@
                     </a:solidFill>
                   </a:tcPr>
                 </a:tc>
+                <a:extLst>
+                  <a:ext uri="{0D108BD9-81ED-4DB2-BD59-A6C34878D82A}">
+                    <a16:rowId xmlns:a16="http://schemas.microsoft.com/office/drawing/2014/main" val="10007"/>
+                  </a:ext>
+                </a:extLst>
               </a:tr>
             </a:tbl>
           </a:graphicData>
@@ -5914,7 +6070,7 @@
 </file>
 
 <file path=ppt/slides/slide15.xml><?xml version="1.0" encoding="utf-8"?>
-<p:sld xmlns:a="http://schemas.openxmlformats.org/drawingml/2006/main" xmlns:p="http://schemas.openxmlformats.org/presentationml/2006/main" xmlns:r="http://schemas.openxmlformats.org/officeDocument/2006/relationships">
+<p:sld xmlns:a="http://schemas.openxmlformats.org/drawingml/2006/main" xmlns:r="http://schemas.openxmlformats.org/officeDocument/2006/relationships" xmlns:p="http://schemas.openxmlformats.org/presentationml/2006/main">
   <p:cSld>
     <p:spTree>
       <p:nvGrpSpPr>
@@ -5922,7 +6078,14 @@
         <p:cNvGrpSpPr/>
         <p:nvPr/>
       </p:nvGrpSpPr>
-      <p:grpSpPr/>
+      <p:grpSpPr>
+        <a:xfrm>
+          <a:off x="0" y="0"/>
+          <a:ext cx="0" cy="0"/>
+          <a:chOff x="0" y="0"/>
+          <a:chExt cx="0" cy="0"/>
+        </a:xfrm>
+      </p:grpSpPr>
       <p:sp>
         <p:nvSpPr>
           <p:cNvPr id="2" name="Rectangle 1"/>
@@ -5964,6 +6127,7 @@
           <a:lstStyle/>
           <a:p>
             <a:pPr algn="ctr"/>
+            <a:endParaRPr/>
           </a:p>
         </p:txBody>
       </p:sp>
@@ -6008,6 +6172,7 @@
           <a:lstStyle/>
           <a:p>
             <a:pPr algn="ctr"/>
+            <a:endParaRPr/>
           </a:p>
         </p:txBody>
       </p:sp>
@@ -6034,7 +6199,7 @@
           <a:lstStyle/>
           <a:p>
             <a:r>
-              <a:rPr b="1" sz="2400">
+              <a:rPr sz="2400" b="1">
                 <a:solidFill>
                   <a:srgbClr val="FFFFFF"/>
                 </a:solidFill>
@@ -6073,9 +6238,27 @@
                 <a:tableStyleId>{5C22544A-7EE6-4342-B048-85BDC9FD1C3A}</a:tableStyleId>
               </a:tblPr>
               <a:tblGrid>
-                <a:gridCol w="3810000"/>
-                <a:gridCol w="3810000"/>
-                <a:gridCol w="3810000"/>
+                <a:gridCol w="3810000">
+                  <a:extLst>
+                    <a:ext uri="{9D8B030D-6E8A-4147-A177-3AD203B41FA5}">
+                      <a16:colId xmlns:a16="http://schemas.microsoft.com/office/drawing/2014/main" val="20000"/>
+                    </a:ext>
+                  </a:extLst>
+                </a:gridCol>
+                <a:gridCol w="3810000">
+                  <a:extLst>
+                    <a:ext uri="{9D8B030D-6E8A-4147-A177-3AD203B41FA5}">
+                      <a16:colId xmlns:a16="http://schemas.microsoft.com/office/drawing/2014/main" val="20001"/>
+                    </a:ext>
+                  </a:extLst>
+                </a:gridCol>
+                <a:gridCol w="3810000">
+                  <a:extLst>
+                    <a:ext uri="{9D8B030D-6E8A-4147-A177-3AD203B41FA5}">
+                      <a16:colId xmlns:a16="http://schemas.microsoft.com/office/drawing/2014/main" val="20002"/>
+                    </a:ext>
+                  </a:extLst>
+                </a:gridCol>
               </a:tblGrid>
               <a:tr h="731520">
                 <a:tc>
@@ -6141,6 +6324,11 @@
                     </a:solidFill>
                   </a:tcPr>
                 </a:tc>
+                <a:extLst>
+                  <a:ext uri="{0D108BD9-81ED-4DB2-BD59-A6C34878D82A}">
+                    <a16:rowId xmlns:a16="http://schemas.microsoft.com/office/drawing/2014/main" val="10000"/>
+                  </a:ext>
+                </a:extLst>
               </a:tr>
               <a:tr h="731520">
                 <a:tc>
@@ -6206,6 +6394,11 @@
                     </a:solidFill>
                   </a:tcPr>
                 </a:tc>
+                <a:extLst>
+                  <a:ext uri="{0D108BD9-81ED-4DB2-BD59-A6C34878D82A}">
+                    <a16:rowId xmlns:a16="http://schemas.microsoft.com/office/drawing/2014/main" val="10001"/>
+                  </a:ext>
+                </a:extLst>
               </a:tr>
               <a:tr h="731520">
                 <a:tc>
@@ -6271,6 +6464,11 @@
                     </a:solidFill>
                   </a:tcPr>
                 </a:tc>
+                <a:extLst>
+                  <a:ext uri="{0D108BD9-81ED-4DB2-BD59-A6C34878D82A}">
+                    <a16:rowId xmlns:a16="http://schemas.microsoft.com/office/drawing/2014/main" val="10002"/>
+                  </a:ext>
+                </a:extLst>
               </a:tr>
               <a:tr h="731520">
                 <a:tc>
@@ -6336,6 +6534,11 @@
                     </a:solidFill>
                   </a:tcPr>
                 </a:tc>
+                <a:extLst>
+                  <a:ext uri="{0D108BD9-81ED-4DB2-BD59-A6C34878D82A}">
+                    <a16:rowId xmlns:a16="http://schemas.microsoft.com/office/drawing/2014/main" val="10003"/>
+                  </a:ext>
+                </a:extLst>
               </a:tr>
               <a:tr h="731520">
                 <a:tc>
@@ -6401,6 +6604,11 @@
                     </a:solidFill>
                   </a:tcPr>
                 </a:tc>
+                <a:extLst>
+                  <a:ext uri="{0D108BD9-81ED-4DB2-BD59-A6C34878D82A}">
+                    <a16:rowId xmlns:a16="http://schemas.microsoft.com/office/drawing/2014/main" val="10004"/>
+                  </a:ext>
+                </a:extLst>
               </a:tr>
               <a:tr h="731520">
                 <a:tc>
@@ -6466,6 +6674,11 @@
                     </a:solidFill>
                   </a:tcPr>
                 </a:tc>
+                <a:extLst>
+                  <a:ext uri="{0D108BD9-81ED-4DB2-BD59-A6C34878D82A}">
+                    <a16:rowId xmlns:a16="http://schemas.microsoft.com/office/drawing/2014/main" val="10005"/>
+                  </a:ext>
+                </a:extLst>
               </a:tr>
             </a:tbl>
           </a:graphicData>
@@ -6547,7 +6760,7 @@
 </file>
 
 <file path=ppt/slides/slide16.xml><?xml version="1.0" encoding="utf-8"?>
-<p:sld xmlns:a="http://schemas.openxmlformats.org/drawingml/2006/main" xmlns:p="http://schemas.openxmlformats.org/presentationml/2006/main" xmlns:r="http://schemas.openxmlformats.org/officeDocument/2006/relationships">
+<p:sld xmlns:a="http://schemas.openxmlformats.org/drawingml/2006/main" xmlns:r="http://schemas.openxmlformats.org/officeDocument/2006/relationships" xmlns:p="http://schemas.openxmlformats.org/presentationml/2006/main">
   <p:cSld>
     <p:spTree>
       <p:nvGrpSpPr>
@@ -6555,7 +6768,14 @@
         <p:cNvGrpSpPr/>
         <p:nvPr/>
       </p:nvGrpSpPr>
-      <p:grpSpPr/>
+      <p:grpSpPr>
+        <a:xfrm>
+          <a:off x="0" y="0"/>
+          <a:ext cx="0" cy="0"/>
+          <a:chOff x="0" y="0"/>
+          <a:chExt cx="0" cy="0"/>
+        </a:xfrm>
+      </p:grpSpPr>
       <p:sp>
         <p:nvSpPr>
           <p:cNvPr id="2" name="Rectangle 1"/>
@@ -6597,6 +6817,7 @@
           <a:lstStyle/>
           <a:p>
             <a:pPr algn="ctr"/>
+            <a:endParaRPr/>
           </a:p>
         </p:txBody>
       </p:sp>
@@ -6641,6 +6862,7 @@
           <a:lstStyle/>
           <a:p>
             <a:pPr algn="ctr"/>
+            <a:endParaRPr/>
           </a:p>
         </p:txBody>
       </p:sp>
@@ -6667,7 +6889,7 @@
           <a:lstStyle/>
           <a:p>
             <a:r>
-              <a:rPr b="1" sz="4800">
+              <a:rPr sz="4800" b="1">
                 <a:solidFill>
                   <a:srgbClr val="FFFFFF"/>
                 </a:solidFill>
@@ -6686,7 +6908,7 @@
 </file>
 
 <file path=ppt/slides/slide17.xml><?xml version="1.0" encoding="utf-8"?>
-<p:sld xmlns:a="http://schemas.openxmlformats.org/drawingml/2006/main" xmlns:p="http://schemas.openxmlformats.org/presentationml/2006/main" xmlns:r="http://schemas.openxmlformats.org/officeDocument/2006/relationships">
+<p:sld xmlns:a="http://schemas.openxmlformats.org/drawingml/2006/main" xmlns:r="http://schemas.openxmlformats.org/officeDocument/2006/relationships" xmlns:p="http://schemas.openxmlformats.org/presentationml/2006/main">
   <p:cSld>
     <p:spTree>
       <p:nvGrpSpPr>
@@ -6694,7 +6916,14 @@
         <p:cNvGrpSpPr/>
         <p:nvPr/>
       </p:nvGrpSpPr>
-      <p:grpSpPr/>
+      <p:grpSpPr>
+        <a:xfrm>
+          <a:off x="0" y="0"/>
+          <a:ext cx="0" cy="0"/>
+          <a:chOff x="0" y="0"/>
+          <a:chExt cx="0" cy="0"/>
+        </a:xfrm>
+      </p:grpSpPr>
       <p:sp>
         <p:nvSpPr>
           <p:cNvPr id="2" name="Rectangle 1"/>
@@ -6736,6 +6965,7 @@
           <a:lstStyle/>
           <a:p>
             <a:pPr algn="ctr"/>
+            <a:endParaRPr/>
           </a:p>
         </p:txBody>
       </p:sp>
@@ -6780,6 +7010,7 @@
           <a:lstStyle/>
           <a:p>
             <a:pPr algn="ctr"/>
+            <a:endParaRPr/>
           </a:p>
         </p:txBody>
       </p:sp>
@@ -6806,7 +7037,7 @@
           <a:lstStyle/>
           <a:p>
             <a:r>
-              <a:rPr b="1" sz="2400">
+              <a:rPr sz="2400" b="1">
                 <a:solidFill>
                   <a:srgbClr val="FFFFFF"/>
                 </a:solidFill>
@@ -7156,7 +7387,7 @@
 </file>
 
 <file path=ppt/slides/slide18.xml><?xml version="1.0" encoding="utf-8"?>
-<p:sld xmlns:a="http://schemas.openxmlformats.org/drawingml/2006/main" xmlns:p="http://schemas.openxmlformats.org/presentationml/2006/main" xmlns:r="http://schemas.openxmlformats.org/officeDocument/2006/relationships">
+<p:sld xmlns:a="http://schemas.openxmlformats.org/drawingml/2006/main" xmlns:r="http://schemas.openxmlformats.org/officeDocument/2006/relationships" xmlns:p="http://schemas.openxmlformats.org/presentationml/2006/main">
   <p:cSld>
     <p:spTree>
       <p:nvGrpSpPr>
@@ -7164,7 +7395,14 @@
         <p:cNvGrpSpPr/>
         <p:nvPr/>
       </p:nvGrpSpPr>
-      <p:grpSpPr/>
+      <p:grpSpPr>
+        <a:xfrm>
+          <a:off x="0" y="0"/>
+          <a:ext cx="0" cy="0"/>
+          <a:chOff x="0" y="0"/>
+          <a:chExt cx="0" cy="0"/>
+        </a:xfrm>
+      </p:grpSpPr>
       <p:sp>
         <p:nvSpPr>
           <p:cNvPr id="2" name="Rectangle 1"/>
@@ -7206,6 +7444,7 @@
           <a:lstStyle/>
           <a:p>
             <a:pPr algn="ctr"/>
+            <a:endParaRPr/>
           </a:p>
         </p:txBody>
       </p:sp>
@@ -7250,6 +7489,7 @@
           <a:lstStyle/>
           <a:p>
             <a:pPr algn="ctr"/>
+            <a:endParaRPr/>
           </a:p>
         </p:txBody>
       </p:sp>
@@ -7276,7 +7516,7 @@
           <a:lstStyle/>
           <a:p>
             <a:r>
-              <a:rPr b="1" sz="2400">
+              <a:rPr sz="2400" b="1">
                 <a:solidFill>
                   <a:srgbClr val="FFFFFF"/>
                 </a:solidFill>
@@ -7494,15 +7734,12 @@
             </a:r>
           </a:p>
           <a:p>
-            <a:r>
-              <a:rPr sz="1000">
-                <a:solidFill>
-                  <a:srgbClr val="1F2A44"/>
-                </a:solidFill>
-                <a:latin typeface="Menlo"/>
-              </a:rPr>
-              <a:t/>
-            </a:r>
+            <a:endParaRPr sz="1000">
+              <a:solidFill>
+                <a:srgbClr val="1F2A44"/>
+              </a:solidFill>
+              <a:latin typeface="Menlo"/>
+            </a:endParaRPr>
           </a:p>
           <a:p>
             <a:r>
@@ -7639,7 +7876,7 @@
 </file>
 
 <file path=ppt/slides/slide19.xml><?xml version="1.0" encoding="utf-8"?>
-<p:sld xmlns:a="http://schemas.openxmlformats.org/drawingml/2006/main" xmlns:p="http://schemas.openxmlformats.org/presentationml/2006/main" xmlns:r="http://schemas.openxmlformats.org/officeDocument/2006/relationships">
+<p:sld xmlns:a="http://schemas.openxmlformats.org/drawingml/2006/main" xmlns:r="http://schemas.openxmlformats.org/officeDocument/2006/relationships" xmlns:p="http://schemas.openxmlformats.org/presentationml/2006/main">
   <p:cSld>
     <p:spTree>
       <p:nvGrpSpPr>
@@ -7647,7 +7884,14 @@
         <p:cNvGrpSpPr/>
         <p:nvPr/>
       </p:nvGrpSpPr>
-      <p:grpSpPr/>
+      <p:grpSpPr>
+        <a:xfrm>
+          <a:off x="0" y="0"/>
+          <a:ext cx="0" cy="0"/>
+          <a:chOff x="0" y="0"/>
+          <a:chExt cx="0" cy="0"/>
+        </a:xfrm>
+      </p:grpSpPr>
       <p:sp>
         <p:nvSpPr>
           <p:cNvPr id="2" name="Rectangle 1"/>
@@ -7689,6 +7933,7 @@
           <a:lstStyle/>
           <a:p>
             <a:pPr algn="ctr"/>
+            <a:endParaRPr/>
           </a:p>
         </p:txBody>
       </p:sp>
@@ -7733,6 +7978,7 @@
           <a:lstStyle/>
           <a:p>
             <a:pPr algn="ctr"/>
+            <a:endParaRPr/>
           </a:p>
         </p:txBody>
       </p:sp>
@@ -7759,7 +8005,7 @@
           <a:lstStyle/>
           <a:p>
             <a:r>
-              <a:rPr b="1" sz="2400">
+              <a:rPr sz="2400" b="1">
                 <a:solidFill>
                   <a:srgbClr val="FFFFFF"/>
                 </a:solidFill>
@@ -7798,9 +8044,27 @@
                 <a:tableStyleId>{5C22544A-7EE6-4342-B048-85BDC9FD1C3A}</a:tableStyleId>
               </a:tblPr>
               <a:tblGrid>
-                <a:gridCol w="3870960"/>
-                <a:gridCol w="3870960"/>
-                <a:gridCol w="3870960"/>
+                <a:gridCol w="3870960">
+                  <a:extLst>
+                    <a:ext uri="{9D8B030D-6E8A-4147-A177-3AD203B41FA5}">
+                      <a16:colId xmlns:a16="http://schemas.microsoft.com/office/drawing/2014/main" val="20000"/>
+                    </a:ext>
+                  </a:extLst>
+                </a:gridCol>
+                <a:gridCol w="3870960">
+                  <a:extLst>
+                    <a:ext uri="{9D8B030D-6E8A-4147-A177-3AD203B41FA5}">
+                      <a16:colId xmlns:a16="http://schemas.microsoft.com/office/drawing/2014/main" val="20001"/>
+                    </a:ext>
+                  </a:extLst>
+                </a:gridCol>
+                <a:gridCol w="3870960">
+                  <a:extLst>
+                    <a:ext uri="{9D8B030D-6E8A-4147-A177-3AD203B41FA5}">
+                      <a16:colId xmlns:a16="http://schemas.microsoft.com/office/drawing/2014/main" val="20002"/>
+                    </a:ext>
+                  </a:extLst>
+                </a:gridCol>
               </a:tblGrid>
               <a:tr h="744582">
                 <a:tc>
@@ -7866,6 +8130,11 @@
                     </a:solidFill>
                   </a:tcPr>
                 </a:tc>
+                <a:extLst>
+                  <a:ext uri="{0D108BD9-81ED-4DB2-BD59-A6C34878D82A}">
+                    <a16:rowId xmlns:a16="http://schemas.microsoft.com/office/drawing/2014/main" val="10000"/>
+                  </a:ext>
+                </a:extLst>
               </a:tr>
               <a:tr h="744582">
                 <a:tc>
@@ -7931,6 +8200,11 @@
                     </a:solidFill>
                   </a:tcPr>
                 </a:tc>
+                <a:extLst>
+                  <a:ext uri="{0D108BD9-81ED-4DB2-BD59-A6C34878D82A}">
+                    <a16:rowId xmlns:a16="http://schemas.microsoft.com/office/drawing/2014/main" val="10001"/>
+                  </a:ext>
+                </a:extLst>
               </a:tr>
               <a:tr h="744582">
                 <a:tc>
@@ -7996,6 +8270,11 @@
                     </a:solidFill>
                   </a:tcPr>
                 </a:tc>
+                <a:extLst>
+                  <a:ext uri="{0D108BD9-81ED-4DB2-BD59-A6C34878D82A}">
+                    <a16:rowId xmlns:a16="http://schemas.microsoft.com/office/drawing/2014/main" val="10002"/>
+                  </a:ext>
+                </a:extLst>
               </a:tr>
               <a:tr h="744582">
                 <a:tc>
@@ -8061,6 +8340,11 @@
                     </a:solidFill>
                   </a:tcPr>
                 </a:tc>
+                <a:extLst>
+                  <a:ext uri="{0D108BD9-81ED-4DB2-BD59-A6C34878D82A}">
+                    <a16:rowId xmlns:a16="http://schemas.microsoft.com/office/drawing/2014/main" val="10003"/>
+                  </a:ext>
+                </a:extLst>
               </a:tr>
               <a:tr h="744582">
                 <a:tc>
@@ -8126,6 +8410,11 @@
                     </a:solidFill>
                   </a:tcPr>
                 </a:tc>
+                <a:extLst>
+                  <a:ext uri="{0D108BD9-81ED-4DB2-BD59-A6C34878D82A}">
+                    <a16:rowId xmlns:a16="http://schemas.microsoft.com/office/drawing/2014/main" val="10004"/>
+                  </a:ext>
+                </a:extLst>
               </a:tr>
               <a:tr h="744582">
                 <a:tc>
@@ -8191,6 +8480,11 @@
                     </a:solidFill>
                   </a:tcPr>
                 </a:tc>
+                <a:extLst>
+                  <a:ext uri="{0D108BD9-81ED-4DB2-BD59-A6C34878D82A}">
+                    <a16:rowId xmlns:a16="http://schemas.microsoft.com/office/drawing/2014/main" val="10005"/>
+                  </a:ext>
+                </a:extLst>
               </a:tr>
               <a:tr h="744588">
                 <a:tc>
@@ -8256,6 +8550,11 @@
                     </a:solidFill>
                   </a:tcPr>
                 </a:tc>
+                <a:extLst>
+                  <a:ext uri="{0D108BD9-81ED-4DB2-BD59-A6C34878D82A}">
+                    <a16:rowId xmlns:a16="http://schemas.microsoft.com/office/drawing/2014/main" val="10006"/>
+                  </a:ext>
+                </a:extLst>
               </a:tr>
             </a:tbl>
           </a:graphicData>
@@ -8304,7 +8603,7 @@
 </file>
 
 <file path=ppt/slides/slide2.xml><?xml version="1.0" encoding="utf-8"?>
-<p:sld xmlns:a="http://schemas.openxmlformats.org/drawingml/2006/main" xmlns:p="http://schemas.openxmlformats.org/presentationml/2006/main" xmlns:r="http://schemas.openxmlformats.org/officeDocument/2006/relationships">
+<p:sld xmlns:a="http://schemas.openxmlformats.org/drawingml/2006/main" xmlns:r="http://schemas.openxmlformats.org/officeDocument/2006/relationships" xmlns:p="http://schemas.openxmlformats.org/presentationml/2006/main">
   <p:cSld>
     <p:spTree>
       <p:nvGrpSpPr>
@@ -8312,7 +8611,14 @@
         <p:cNvGrpSpPr/>
         <p:nvPr/>
       </p:nvGrpSpPr>
-      <p:grpSpPr/>
+      <p:grpSpPr>
+        <a:xfrm>
+          <a:off x="0" y="0"/>
+          <a:ext cx="0" cy="0"/>
+          <a:chOff x="0" y="0"/>
+          <a:chExt cx="0" cy="0"/>
+        </a:xfrm>
+      </p:grpSpPr>
       <p:sp>
         <p:nvSpPr>
           <p:cNvPr id="2" name="Rectangle 1"/>
@@ -8354,6 +8660,7 @@
           <a:lstStyle/>
           <a:p>
             <a:pPr algn="ctr"/>
+            <a:endParaRPr/>
           </a:p>
         </p:txBody>
       </p:sp>
@@ -8398,6 +8705,7 @@
           <a:lstStyle/>
           <a:p>
             <a:pPr algn="ctr"/>
+            <a:endParaRPr/>
           </a:p>
         </p:txBody>
       </p:sp>
@@ -8424,7 +8732,7 @@
           <a:lstStyle/>
           <a:p>
             <a:r>
-              <a:rPr b="1" sz="2400">
+              <a:rPr sz="2400" b="1">
                 <a:solidFill>
                   <a:srgbClr val="FFFFFF"/>
                 </a:solidFill>
@@ -8560,7 +8868,7 @@
 </file>
 
 <file path=ppt/slides/slide20.xml><?xml version="1.0" encoding="utf-8"?>
-<p:sld xmlns:a="http://schemas.openxmlformats.org/drawingml/2006/main" xmlns:p="http://schemas.openxmlformats.org/presentationml/2006/main" xmlns:r="http://schemas.openxmlformats.org/officeDocument/2006/relationships">
+<p:sld xmlns:a="http://schemas.openxmlformats.org/drawingml/2006/main" xmlns:r="http://schemas.openxmlformats.org/officeDocument/2006/relationships" xmlns:p="http://schemas.openxmlformats.org/presentationml/2006/main">
   <p:cSld>
     <p:spTree>
       <p:nvGrpSpPr>
@@ -8568,7 +8876,14 @@
         <p:cNvGrpSpPr/>
         <p:nvPr/>
       </p:nvGrpSpPr>
-      <p:grpSpPr/>
+      <p:grpSpPr>
+        <a:xfrm>
+          <a:off x="0" y="0"/>
+          <a:ext cx="0" cy="0"/>
+          <a:chOff x="0" y="0"/>
+          <a:chExt cx="0" cy="0"/>
+        </a:xfrm>
+      </p:grpSpPr>
       <p:sp>
         <p:nvSpPr>
           <p:cNvPr id="2" name="Rectangle 1"/>
@@ -8610,6 +8925,7 @@
           <a:lstStyle/>
           <a:p>
             <a:pPr algn="ctr"/>
+            <a:endParaRPr/>
           </a:p>
         </p:txBody>
       </p:sp>
@@ -8654,6 +8970,7 @@
           <a:lstStyle/>
           <a:p>
             <a:pPr algn="ctr"/>
+            <a:endParaRPr/>
           </a:p>
         </p:txBody>
       </p:sp>
@@ -8680,7 +8997,7 @@
           <a:lstStyle/>
           <a:p>
             <a:r>
-              <a:rPr b="1" sz="2400">
+              <a:rPr sz="2400" b="1">
                 <a:solidFill>
                   <a:srgbClr val="FFFFFF"/>
                 </a:solidFill>
@@ -8719,10 +9036,34 @@
                 <a:tableStyleId>{5C22544A-7EE6-4342-B048-85BDC9FD1C3A}</a:tableStyleId>
               </a:tblPr>
               <a:tblGrid>
-                <a:gridCol w="2932938"/>
-                <a:gridCol w="2932938"/>
-                <a:gridCol w="2932938"/>
-                <a:gridCol w="2932938"/>
+                <a:gridCol w="2932938">
+                  <a:extLst>
+                    <a:ext uri="{9D8B030D-6E8A-4147-A177-3AD203B41FA5}">
+                      <a16:colId xmlns:a16="http://schemas.microsoft.com/office/drawing/2014/main" val="20000"/>
+                    </a:ext>
+                  </a:extLst>
+                </a:gridCol>
+                <a:gridCol w="2932938">
+                  <a:extLst>
+                    <a:ext uri="{9D8B030D-6E8A-4147-A177-3AD203B41FA5}">
+                      <a16:colId xmlns:a16="http://schemas.microsoft.com/office/drawing/2014/main" val="20001"/>
+                    </a:ext>
+                  </a:extLst>
+                </a:gridCol>
+                <a:gridCol w="2932938">
+                  <a:extLst>
+                    <a:ext uri="{9D8B030D-6E8A-4147-A177-3AD203B41FA5}">
+                      <a16:colId xmlns:a16="http://schemas.microsoft.com/office/drawing/2014/main" val="20002"/>
+                    </a:ext>
+                  </a:extLst>
+                </a:gridCol>
+                <a:gridCol w="2932938">
+                  <a:extLst>
+                    <a:ext uri="{9D8B030D-6E8A-4147-A177-3AD203B41FA5}">
+                      <a16:colId xmlns:a16="http://schemas.microsoft.com/office/drawing/2014/main" val="20003"/>
+                    </a:ext>
+                  </a:extLst>
+                </a:gridCol>
               </a:tblGrid>
               <a:tr h="589280">
                 <a:tc>
@@ -8809,6 +9150,11 @@
                     </a:solidFill>
                   </a:tcPr>
                 </a:tc>
+                <a:extLst>
+                  <a:ext uri="{0D108BD9-81ED-4DB2-BD59-A6C34878D82A}">
+                    <a16:rowId xmlns:a16="http://schemas.microsoft.com/office/drawing/2014/main" val="10000"/>
+                  </a:ext>
+                </a:extLst>
               </a:tr>
               <a:tr h="589280">
                 <a:tc>
@@ -8895,6 +9241,11 @@
                     </a:solidFill>
                   </a:tcPr>
                 </a:tc>
+                <a:extLst>
+                  <a:ext uri="{0D108BD9-81ED-4DB2-BD59-A6C34878D82A}">
+                    <a16:rowId xmlns:a16="http://schemas.microsoft.com/office/drawing/2014/main" val="10001"/>
+                  </a:ext>
+                </a:extLst>
               </a:tr>
               <a:tr h="589280">
                 <a:tc>
@@ -8981,6 +9332,11 @@
                     </a:solidFill>
                   </a:tcPr>
                 </a:tc>
+                <a:extLst>
+                  <a:ext uri="{0D108BD9-81ED-4DB2-BD59-A6C34878D82A}">
+                    <a16:rowId xmlns:a16="http://schemas.microsoft.com/office/drawing/2014/main" val="10002"/>
+                  </a:ext>
+                </a:extLst>
               </a:tr>
               <a:tr h="589280">
                 <a:tc>
@@ -9067,6 +9423,11 @@
                     </a:solidFill>
                   </a:tcPr>
                 </a:tc>
+                <a:extLst>
+                  <a:ext uri="{0D108BD9-81ED-4DB2-BD59-A6C34878D82A}">
+                    <a16:rowId xmlns:a16="http://schemas.microsoft.com/office/drawing/2014/main" val="10003"/>
+                  </a:ext>
+                </a:extLst>
               </a:tr>
               <a:tr h="589280">
                 <a:tc>
@@ -9153,6 +9514,11 @@
                     </a:solidFill>
                   </a:tcPr>
                 </a:tc>
+                <a:extLst>
+                  <a:ext uri="{0D108BD9-81ED-4DB2-BD59-A6C34878D82A}">
+                    <a16:rowId xmlns:a16="http://schemas.microsoft.com/office/drawing/2014/main" val="10004"/>
+                  </a:ext>
+                </a:extLst>
               </a:tr>
               <a:tr h="589280">
                 <a:tc>
@@ -9239,6 +9605,11 @@
                     </a:solidFill>
                   </a:tcPr>
                 </a:tc>
+                <a:extLst>
+                  <a:ext uri="{0D108BD9-81ED-4DB2-BD59-A6C34878D82A}">
+                    <a16:rowId xmlns:a16="http://schemas.microsoft.com/office/drawing/2014/main" val="10005"/>
+                  </a:ext>
+                </a:extLst>
               </a:tr>
               <a:tr h="589280">
                 <a:tc>
@@ -9325,6 +9696,11 @@
                     </a:solidFill>
                   </a:tcPr>
                 </a:tc>
+                <a:extLst>
+                  <a:ext uri="{0D108BD9-81ED-4DB2-BD59-A6C34878D82A}">
+                    <a16:rowId xmlns:a16="http://schemas.microsoft.com/office/drawing/2014/main" val="10006"/>
+                  </a:ext>
+                </a:extLst>
               </a:tr>
               <a:tr h="589280">
                 <a:tc>
@@ -9411,6 +9787,11 @@
                     </a:solidFill>
                   </a:tcPr>
                 </a:tc>
+                <a:extLst>
+                  <a:ext uri="{0D108BD9-81ED-4DB2-BD59-A6C34878D82A}">
+                    <a16:rowId xmlns:a16="http://schemas.microsoft.com/office/drawing/2014/main" val="10007"/>
+                  </a:ext>
+                </a:extLst>
               </a:tr>
               <a:tr h="589280">
                 <a:tc>
@@ -9497,6 +9878,11 @@
                     </a:solidFill>
                   </a:tcPr>
                 </a:tc>
+                <a:extLst>
+                  <a:ext uri="{0D108BD9-81ED-4DB2-BD59-A6C34878D82A}">
+                    <a16:rowId xmlns:a16="http://schemas.microsoft.com/office/drawing/2014/main" val="10008"/>
+                  </a:ext>
+                </a:extLst>
               </a:tr>
             </a:tbl>
           </a:graphicData>
@@ -9545,7 +9931,7 @@
 </file>
 
 <file path=ppt/slides/slide21.xml><?xml version="1.0" encoding="utf-8"?>
-<p:sld xmlns:a="http://schemas.openxmlformats.org/drawingml/2006/main" xmlns:p="http://schemas.openxmlformats.org/presentationml/2006/main" xmlns:r="http://schemas.openxmlformats.org/officeDocument/2006/relationships">
+<p:sld xmlns:a="http://schemas.openxmlformats.org/drawingml/2006/main" xmlns:r="http://schemas.openxmlformats.org/officeDocument/2006/relationships" xmlns:p="http://schemas.openxmlformats.org/presentationml/2006/main">
   <p:cSld>
     <p:spTree>
       <p:nvGrpSpPr>
@@ -9553,7 +9939,14 @@
         <p:cNvGrpSpPr/>
         <p:nvPr/>
       </p:nvGrpSpPr>
-      <p:grpSpPr/>
+      <p:grpSpPr>
+        <a:xfrm>
+          <a:off x="0" y="0"/>
+          <a:ext cx="0" cy="0"/>
+          <a:chOff x="0" y="0"/>
+          <a:chExt cx="0" cy="0"/>
+        </a:xfrm>
+      </p:grpSpPr>
       <p:sp>
         <p:nvSpPr>
           <p:cNvPr id="2" name="Rectangle 1"/>
@@ -9595,6 +9988,7 @@
           <a:lstStyle/>
           <a:p>
             <a:pPr algn="ctr"/>
+            <a:endParaRPr/>
           </a:p>
         </p:txBody>
       </p:sp>
@@ -9639,6 +10033,7 @@
           <a:lstStyle/>
           <a:p>
             <a:pPr algn="ctr"/>
+            <a:endParaRPr/>
           </a:p>
         </p:txBody>
       </p:sp>
@@ -9665,7 +10060,7 @@
           <a:lstStyle/>
           <a:p>
             <a:r>
-              <a:rPr b="1" sz="4800">
+              <a:rPr sz="4800" b="1">
                 <a:solidFill>
                   <a:srgbClr val="FFFFFF"/>
                 </a:solidFill>
@@ -9684,7 +10079,7 @@
 </file>
 
 <file path=ppt/slides/slide22.xml><?xml version="1.0" encoding="utf-8"?>
-<p:sld xmlns:a="http://schemas.openxmlformats.org/drawingml/2006/main" xmlns:p="http://schemas.openxmlformats.org/presentationml/2006/main" xmlns:r="http://schemas.openxmlformats.org/officeDocument/2006/relationships">
+<p:sld xmlns:a="http://schemas.openxmlformats.org/drawingml/2006/main" xmlns:r="http://schemas.openxmlformats.org/officeDocument/2006/relationships" xmlns:p="http://schemas.openxmlformats.org/presentationml/2006/main">
   <p:cSld>
     <p:spTree>
       <p:nvGrpSpPr>
@@ -9692,7 +10087,14 @@
         <p:cNvGrpSpPr/>
         <p:nvPr/>
       </p:nvGrpSpPr>
-      <p:grpSpPr/>
+      <p:grpSpPr>
+        <a:xfrm>
+          <a:off x="0" y="0"/>
+          <a:ext cx="0" cy="0"/>
+          <a:chOff x="0" y="0"/>
+          <a:chExt cx="0" cy="0"/>
+        </a:xfrm>
+      </p:grpSpPr>
       <p:sp>
         <p:nvSpPr>
           <p:cNvPr id="2" name="Rectangle 1"/>
@@ -9734,6 +10136,7 @@
           <a:lstStyle/>
           <a:p>
             <a:pPr algn="ctr"/>
+            <a:endParaRPr/>
           </a:p>
         </p:txBody>
       </p:sp>
@@ -9778,6 +10181,7 @@
           <a:lstStyle/>
           <a:p>
             <a:pPr algn="ctr"/>
+            <a:endParaRPr/>
           </a:p>
         </p:txBody>
       </p:sp>
@@ -9804,7 +10208,7 @@
           <a:lstStyle/>
           <a:p>
             <a:r>
-              <a:rPr b="1" sz="2400">
+              <a:rPr sz="2400" b="1">
                 <a:solidFill>
                   <a:srgbClr val="FFFFFF"/>
                 </a:solidFill>
@@ -9843,9 +10247,27 @@
                 <a:tableStyleId>{5C22544A-7EE6-4342-B048-85BDC9FD1C3A}</a:tableStyleId>
               </a:tblPr>
               <a:tblGrid>
-                <a:gridCol w="3810000"/>
-                <a:gridCol w="3810000"/>
-                <a:gridCol w="3810000"/>
+                <a:gridCol w="3810000">
+                  <a:extLst>
+                    <a:ext uri="{9D8B030D-6E8A-4147-A177-3AD203B41FA5}">
+                      <a16:colId xmlns:a16="http://schemas.microsoft.com/office/drawing/2014/main" val="20000"/>
+                    </a:ext>
+                  </a:extLst>
+                </a:gridCol>
+                <a:gridCol w="3810000">
+                  <a:extLst>
+                    <a:ext uri="{9D8B030D-6E8A-4147-A177-3AD203B41FA5}">
+                      <a16:colId xmlns:a16="http://schemas.microsoft.com/office/drawing/2014/main" val="20001"/>
+                    </a:ext>
+                  </a:extLst>
+                </a:gridCol>
+                <a:gridCol w="3810000">
+                  <a:extLst>
+                    <a:ext uri="{9D8B030D-6E8A-4147-A177-3AD203B41FA5}">
+                      <a16:colId xmlns:a16="http://schemas.microsoft.com/office/drawing/2014/main" val="20002"/>
+                    </a:ext>
+                  </a:extLst>
+                </a:gridCol>
               </a:tblGrid>
               <a:tr h="548640">
                 <a:tc>
@@ -9911,6 +10333,11 @@
                     </a:solidFill>
                   </a:tcPr>
                 </a:tc>
+                <a:extLst>
+                  <a:ext uri="{0D108BD9-81ED-4DB2-BD59-A6C34878D82A}">
+                    <a16:rowId xmlns:a16="http://schemas.microsoft.com/office/drawing/2014/main" val="10000"/>
+                  </a:ext>
+                </a:extLst>
               </a:tr>
               <a:tr h="548640">
                 <a:tc>
@@ -9976,6 +10403,11 @@
                     </a:solidFill>
                   </a:tcPr>
                 </a:tc>
+                <a:extLst>
+                  <a:ext uri="{0D108BD9-81ED-4DB2-BD59-A6C34878D82A}">
+                    <a16:rowId xmlns:a16="http://schemas.microsoft.com/office/drawing/2014/main" val="10001"/>
+                  </a:ext>
+                </a:extLst>
               </a:tr>
               <a:tr h="548640">
                 <a:tc>
@@ -10041,6 +10473,11 @@
                     </a:solidFill>
                   </a:tcPr>
                 </a:tc>
+                <a:extLst>
+                  <a:ext uri="{0D108BD9-81ED-4DB2-BD59-A6C34878D82A}">
+                    <a16:rowId xmlns:a16="http://schemas.microsoft.com/office/drawing/2014/main" val="10002"/>
+                  </a:ext>
+                </a:extLst>
               </a:tr>
               <a:tr h="548640">
                 <a:tc>
@@ -10106,6 +10543,11 @@
                     </a:solidFill>
                   </a:tcPr>
                 </a:tc>
+                <a:extLst>
+                  <a:ext uri="{0D108BD9-81ED-4DB2-BD59-A6C34878D82A}">
+                    <a16:rowId xmlns:a16="http://schemas.microsoft.com/office/drawing/2014/main" val="10003"/>
+                  </a:ext>
+                </a:extLst>
               </a:tr>
               <a:tr h="548640">
                 <a:tc>
@@ -10171,6 +10613,11 @@
                     </a:solidFill>
                   </a:tcPr>
                 </a:tc>
+                <a:extLst>
+                  <a:ext uri="{0D108BD9-81ED-4DB2-BD59-A6C34878D82A}">
+                    <a16:rowId xmlns:a16="http://schemas.microsoft.com/office/drawing/2014/main" val="10004"/>
+                  </a:ext>
+                </a:extLst>
               </a:tr>
               <a:tr h="548640">
                 <a:tc>
@@ -10236,6 +10683,11 @@
                     </a:solidFill>
                   </a:tcPr>
                 </a:tc>
+                <a:extLst>
+                  <a:ext uri="{0D108BD9-81ED-4DB2-BD59-A6C34878D82A}">
+                    <a16:rowId xmlns:a16="http://schemas.microsoft.com/office/drawing/2014/main" val="10005"/>
+                  </a:ext>
+                </a:extLst>
               </a:tr>
               <a:tr h="548640">
                 <a:tc>
@@ -10301,6 +10753,11 @@
                     </a:solidFill>
                   </a:tcPr>
                 </a:tc>
+                <a:extLst>
+                  <a:ext uri="{0D108BD9-81ED-4DB2-BD59-A6C34878D82A}">
+                    <a16:rowId xmlns:a16="http://schemas.microsoft.com/office/drawing/2014/main" val="10006"/>
+                  </a:ext>
+                </a:extLst>
               </a:tr>
             </a:tbl>
           </a:graphicData>
@@ -10450,7 +10907,7 @@
 </file>
 
 <file path=ppt/slides/slide23.xml><?xml version="1.0" encoding="utf-8"?>
-<p:sld xmlns:a="http://schemas.openxmlformats.org/drawingml/2006/main" xmlns:p="http://schemas.openxmlformats.org/presentationml/2006/main" xmlns:r="http://schemas.openxmlformats.org/officeDocument/2006/relationships">
+<p:sld xmlns:a="http://schemas.openxmlformats.org/drawingml/2006/main" xmlns:r="http://schemas.openxmlformats.org/officeDocument/2006/relationships" xmlns:p="http://schemas.openxmlformats.org/presentationml/2006/main">
   <p:cSld>
     <p:spTree>
       <p:nvGrpSpPr>
@@ -10458,7 +10915,14 @@
         <p:cNvGrpSpPr/>
         <p:nvPr/>
       </p:nvGrpSpPr>
-      <p:grpSpPr/>
+      <p:grpSpPr>
+        <a:xfrm>
+          <a:off x="0" y="0"/>
+          <a:ext cx="0" cy="0"/>
+          <a:chOff x="0" y="0"/>
+          <a:chExt cx="0" cy="0"/>
+        </a:xfrm>
+      </p:grpSpPr>
       <p:sp>
         <p:nvSpPr>
           <p:cNvPr id="2" name="Rectangle 1"/>
@@ -10500,6 +10964,7 @@
           <a:lstStyle/>
           <a:p>
             <a:pPr algn="ctr"/>
+            <a:endParaRPr/>
           </a:p>
         </p:txBody>
       </p:sp>
@@ -10544,6 +11009,7 @@
           <a:lstStyle/>
           <a:p>
             <a:pPr algn="ctr"/>
+            <a:endParaRPr/>
           </a:p>
         </p:txBody>
       </p:sp>
@@ -10570,7 +11036,7 @@
           <a:lstStyle/>
           <a:p>
             <a:r>
-              <a:rPr b="1" sz="2400">
+              <a:rPr sz="2400" b="1">
                 <a:solidFill>
                   <a:srgbClr val="FFFFFF"/>
                 </a:solidFill>
@@ -10764,6 +11230,7 @@
           <a:lstStyle/>
           <a:p>
             <a:pPr algn="ctr"/>
+            <a:endParaRPr/>
           </a:p>
         </p:txBody>
       </p:sp>
@@ -10856,7 +11323,7 @@
 </file>
 
 <file path=ppt/slides/slide24.xml><?xml version="1.0" encoding="utf-8"?>
-<p:sld xmlns:a="http://schemas.openxmlformats.org/drawingml/2006/main" xmlns:p="http://schemas.openxmlformats.org/presentationml/2006/main" xmlns:r="http://schemas.openxmlformats.org/officeDocument/2006/relationships">
+<p:sld xmlns:a="http://schemas.openxmlformats.org/drawingml/2006/main" xmlns:r="http://schemas.openxmlformats.org/officeDocument/2006/relationships" xmlns:p="http://schemas.openxmlformats.org/presentationml/2006/main">
   <p:cSld>
     <p:spTree>
       <p:nvGrpSpPr>
@@ -10864,7 +11331,14 @@
         <p:cNvGrpSpPr/>
         <p:nvPr/>
       </p:nvGrpSpPr>
-      <p:grpSpPr/>
+      <p:grpSpPr>
+        <a:xfrm>
+          <a:off x="0" y="0"/>
+          <a:ext cx="0" cy="0"/>
+          <a:chOff x="0" y="0"/>
+          <a:chExt cx="0" cy="0"/>
+        </a:xfrm>
+      </p:grpSpPr>
       <p:sp>
         <p:nvSpPr>
           <p:cNvPr id="2" name="Rectangle 1"/>
@@ -10906,6 +11380,7 @@
           <a:lstStyle/>
           <a:p>
             <a:pPr algn="ctr"/>
+            <a:endParaRPr/>
           </a:p>
         </p:txBody>
       </p:sp>
@@ -10950,6 +11425,7 @@
           <a:lstStyle/>
           <a:p>
             <a:pPr algn="ctr"/>
+            <a:endParaRPr/>
           </a:p>
         </p:txBody>
       </p:sp>
@@ -10976,7 +11452,7 @@
           <a:lstStyle/>
           <a:p>
             <a:r>
-              <a:rPr b="1" sz="2400">
+              <a:rPr sz="2400" b="1">
                 <a:solidFill>
                   <a:srgbClr val="FFFFFF"/>
                 </a:solidFill>
@@ -11015,10 +11491,34 @@
                 <a:tableStyleId>{5C22544A-7EE6-4342-B048-85BDC9FD1C3A}</a:tableStyleId>
               </a:tblPr>
               <a:tblGrid>
-                <a:gridCol w="2903220"/>
-                <a:gridCol w="2903220"/>
-                <a:gridCol w="2903220"/>
-                <a:gridCol w="2903220"/>
+                <a:gridCol w="2903220">
+                  <a:extLst>
+                    <a:ext uri="{9D8B030D-6E8A-4147-A177-3AD203B41FA5}">
+                      <a16:colId xmlns:a16="http://schemas.microsoft.com/office/drawing/2014/main" val="20000"/>
+                    </a:ext>
+                  </a:extLst>
+                </a:gridCol>
+                <a:gridCol w="2903220">
+                  <a:extLst>
+                    <a:ext uri="{9D8B030D-6E8A-4147-A177-3AD203B41FA5}">
+                      <a16:colId xmlns:a16="http://schemas.microsoft.com/office/drawing/2014/main" val="20001"/>
+                    </a:ext>
+                  </a:extLst>
+                </a:gridCol>
+                <a:gridCol w="2903220">
+                  <a:extLst>
+                    <a:ext uri="{9D8B030D-6E8A-4147-A177-3AD203B41FA5}">
+                      <a16:colId xmlns:a16="http://schemas.microsoft.com/office/drawing/2014/main" val="20002"/>
+                    </a:ext>
+                  </a:extLst>
+                </a:gridCol>
+                <a:gridCol w="2903220">
+                  <a:extLst>
+                    <a:ext uri="{9D8B030D-6E8A-4147-A177-3AD203B41FA5}">
+                      <a16:colId xmlns:a16="http://schemas.microsoft.com/office/drawing/2014/main" val="20003"/>
+                    </a:ext>
+                  </a:extLst>
+                </a:gridCol>
               </a:tblGrid>
               <a:tr h="496388">
                 <a:tc>
@@ -11105,6 +11605,11 @@
                     </a:solidFill>
                   </a:tcPr>
                 </a:tc>
+                <a:extLst>
+                  <a:ext uri="{0D108BD9-81ED-4DB2-BD59-A6C34878D82A}">
+                    <a16:rowId xmlns:a16="http://schemas.microsoft.com/office/drawing/2014/main" val="10000"/>
+                  </a:ext>
+                </a:extLst>
               </a:tr>
               <a:tr h="496388">
                 <a:tc>
@@ -11191,6 +11696,11 @@
                     </a:solidFill>
                   </a:tcPr>
                 </a:tc>
+                <a:extLst>
+                  <a:ext uri="{0D108BD9-81ED-4DB2-BD59-A6C34878D82A}">
+                    <a16:rowId xmlns:a16="http://schemas.microsoft.com/office/drawing/2014/main" val="10001"/>
+                  </a:ext>
+                </a:extLst>
               </a:tr>
               <a:tr h="496388">
                 <a:tc>
@@ -11277,6 +11787,11 @@
                     </a:solidFill>
                   </a:tcPr>
                 </a:tc>
+                <a:extLst>
+                  <a:ext uri="{0D108BD9-81ED-4DB2-BD59-A6C34878D82A}">
+                    <a16:rowId xmlns:a16="http://schemas.microsoft.com/office/drawing/2014/main" val="10002"/>
+                  </a:ext>
+                </a:extLst>
               </a:tr>
               <a:tr h="496388">
                 <a:tc>
@@ -11363,6 +11878,11 @@
                     </a:solidFill>
                   </a:tcPr>
                 </a:tc>
+                <a:extLst>
+                  <a:ext uri="{0D108BD9-81ED-4DB2-BD59-A6C34878D82A}">
+                    <a16:rowId xmlns:a16="http://schemas.microsoft.com/office/drawing/2014/main" val="10003"/>
+                  </a:ext>
+                </a:extLst>
               </a:tr>
               <a:tr h="496388">
                 <a:tc>
@@ -11449,6 +11969,11 @@
                     </a:solidFill>
                   </a:tcPr>
                 </a:tc>
+                <a:extLst>
+                  <a:ext uri="{0D108BD9-81ED-4DB2-BD59-A6C34878D82A}">
+                    <a16:rowId xmlns:a16="http://schemas.microsoft.com/office/drawing/2014/main" val="10004"/>
+                  </a:ext>
+                </a:extLst>
               </a:tr>
               <a:tr h="496388">
                 <a:tc>
@@ -11535,6 +12060,11 @@
                     </a:solidFill>
                   </a:tcPr>
                 </a:tc>
+                <a:extLst>
+                  <a:ext uri="{0D108BD9-81ED-4DB2-BD59-A6C34878D82A}">
+                    <a16:rowId xmlns:a16="http://schemas.microsoft.com/office/drawing/2014/main" val="10005"/>
+                  </a:ext>
+                </a:extLst>
               </a:tr>
               <a:tr h="496392">
                 <a:tc>
@@ -11621,6 +12151,11 @@
                     </a:solidFill>
                   </a:tcPr>
                 </a:tc>
+                <a:extLst>
+                  <a:ext uri="{0D108BD9-81ED-4DB2-BD59-A6C34878D82A}">
+                    <a16:rowId xmlns:a16="http://schemas.microsoft.com/office/drawing/2014/main" val="10006"/>
+                  </a:ext>
+                </a:extLst>
               </a:tr>
             </a:tbl>
           </a:graphicData>
@@ -11669,6 +12204,7 @@
           <a:lstStyle/>
           <a:p>
             <a:pPr algn="ctr"/>
+            <a:endParaRPr/>
           </a:p>
         </p:txBody>
       </p:sp>
@@ -11759,7 +12295,7 @@
 </file>
 
 <file path=ppt/slides/slide25.xml><?xml version="1.0" encoding="utf-8"?>
-<p:sld xmlns:a="http://schemas.openxmlformats.org/drawingml/2006/main" xmlns:p="http://schemas.openxmlformats.org/presentationml/2006/main" xmlns:r="http://schemas.openxmlformats.org/officeDocument/2006/relationships">
+<p:sld xmlns:a="http://schemas.openxmlformats.org/drawingml/2006/main" xmlns:r="http://schemas.openxmlformats.org/officeDocument/2006/relationships" xmlns:p="http://schemas.openxmlformats.org/presentationml/2006/main">
   <p:cSld>
     <p:spTree>
       <p:nvGrpSpPr>
@@ -11767,7 +12303,14 @@
         <p:cNvGrpSpPr/>
         <p:nvPr/>
       </p:nvGrpSpPr>
-      <p:grpSpPr/>
+      <p:grpSpPr>
+        <a:xfrm>
+          <a:off x="0" y="0"/>
+          <a:ext cx="0" cy="0"/>
+          <a:chOff x="0" y="0"/>
+          <a:chExt cx="0" cy="0"/>
+        </a:xfrm>
+      </p:grpSpPr>
       <p:sp>
         <p:nvSpPr>
           <p:cNvPr id="2" name="Rectangle 1"/>
@@ -11809,6 +12352,7 @@
           <a:lstStyle/>
           <a:p>
             <a:pPr algn="ctr"/>
+            <a:endParaRPr/>
           </a:p>
         </p:txBody>
       </p:sp>
@@ -11853,6 +12397,7 @@
           <a:lstStyle/>
           <a:p>
             <a:pPr algn="ctr"/>
+            <a:endParaRPr/>
           </a:p>
         </p:txBody>
       </p:sp>
@@ -11879,7 +12424,7 @@
           <a:lstStyle/>
           <a:p>
             <a:r>
-              <a:rPr b="1" sz="2400">
+              <a:rPr sz="2400" b="1">
                 <a:solidFill>
                   <a:srgbClr val="FFFFFF"/>
                 </a:solidFill>
@@ -12088,6 +12633,7 @@
           <a:lstStyle/>
           <a:p>
             <a:pPr algn="ctr"/>
+            <a:endParaRPr/>
           </a:p>
         </p:txBody>
       </p:sp>
@@ -12180,7 +12726,7 @@
 </file>
 
 <file path=ppt/slides/slide26.xml><?xml version="1.0" encoding="utf-8"?>
-<p:sld xmlns:a="http://schemas.openxmlformats.org/drawingml/2006/main" xmlns:p="http://schemas.openxmlformats.org/presentationml/2006/main" xmlns:r="http://schemas.openxmlformats.org/officeDocument/2006/relationships">
+<p:sld xmlns:a="http://schemas.openxmlformats.org/drawingml/2006/main" xmlns:r="http://schemas.openxmlformats.org/officeDocument/2006/relationships" xmlns:p="http://schemas.openxmlformats.org/presentationml/2006/main">
   <p:cSld>
     <p:spTree>
       <p:nvGrpSpPr>
@@ -12188,7 +12734,14 @@
         <p:cNvGrpSpPr/>
         <p:nvPr/>
       </p:nvGrpSpPr>
-      <p:grpSpPr/>
+      <p:grpSpPr>
+        <a:xfrm>
+          <a:off x="0" y="0"/>
+          <a:ext cx="0" cy="0"/>
+          <a:chOff x="0" y="0"/>
+          <a:chExt cx="0" cy="0"/>
+        </a:xfrm>
+      </p:grpSpPr>
       <p:sp>
         <p:nvSpPr>
           <p:cNvPr id="2" name="Rectangle 1"/>
@@ -12230,6 +12783,7 @@
           <a:lstStyle/>
           <a:p>
             <a:pPr algn="ctr"/>
+            <a:endParaRPr/>
           </a:p>
         </p:txBody>
       </p:sp>
@@ -12295,7 +12849,7 @@
 </file>
 
 <file path=ppt/slides/slide3.xml><?xml version="1.0" encoding="utf-8"?>
-<p:sld xmlns:a="http://schemas.openxmlformats.org/drawingml/2006/main" xmlns:p="http://schemas.openxmlformats.org/presentationml/2006/main" xmlns:r="http://schemas.openxmlformats.org/officeDocument/2006/relationships">
+<p:sld xmlns:a="http://schemas.openxmlformats.org/drawingml/2006/main" xmlns:r="http://schemas.openxmlformats.org/officeDocument/2006/relationships" xmlns:p="http://schemas.openxmlformats.org/presentationml/2006/main">
   <p:cSld>
     <p:spTree>
       <p:nvGrpSpPr>
@@ -12303,7 +12857,14 @@
         <p:cNvGrpSpPr/>
         <p:nvPr/>
       </p:nvGrpSpPr>
-      <p:grpSpPr/>
+      <p:grpSpPr>
+        <a:xfrm>
+          <a:off x="0" y="0"/>
+          <a:ext cx="0" cy="0"/>
+          <a:chOff x="0" y="0"/>
+          <a:chExt cx="0" cy="0"/>
+        </a:xfrm>
+      </p:grpSpPr>
       <p:sp>
         <p:nvSpPr>
           <p:cNvPr id="2" name="Rectangle 1"/>
@@ -12345,6 +12906,7 @@
           <a:lstStyle/>
           <a:p>
             <a:pPr algn="ctr"/>
+            <a:endParaRPr/>
           </a:p>
         </p:txBody>
       </p:sp>
@@ -12389,6 +12951,7 @@
           <a:lstStyle/>
           <a:p>
             <a:pPr algn="ctr"/>
+            <a:endParaRPr/>
           </a:p>
         </p:txBody>
       </p:sp>
@@ -12415,7 +12978,7 @@
           <a:lstStyle/>
           <a:p>
             <a:r>
-              <a:rPr b="1" sz="4800">
+              <a:rPr sz="4800" b="1">
                 <a:solidFill>
                   <a:srgbClr val="FFFFFF"/>
                 </a:solidFill>
@@ -12434,7 +12997,7 @@
 </file>
 
 <file path=ppt/slides/slide4.xml><?xml version="1.0" encoding="utf-8"?>
-<p:sld xmlns:a="http://schemas.openxmlformats.org/drawingml/2006/main" xmlns:p="http://schemas.openxmlformats.org/presentationml/2006/main" xmlns:r="http://schemas.openxmlformats.org/officeDocument/2006/relationships">
+<p:sld xmlns:a="http://schemas.openxmlformats.org/drawingml/2006/main" xmlns:r="http://schemas.openxmlformats.org/officeDocument/2006/relationships" xmlns:p="http://schemas.openxmlformats.org/presentationml/2006/main">
   <p:cSld>
     <p:spTree>
       <p:nvGrpSpPr>
@@ -12442,7 +13005,14 @@
         <p:cNvGrpSpPr/>
         <p:nvPr/>
       </p:nvGrpSpPr>
-      <p:grpSpPr/>
+      <p:grpSpPr>
+        <a:xfrm>
+          <a:off x="0" y="0"/>
+          <a:ext cx="0" cy="0"/>
+          <a:chOff x="0" y="0"/>
+          <a:chExt cx="0" cy="0"/>
+        </a:xfrm>
+      </p:grpSpPr>
       <p:sp>
         <p:nvSpPr>
           <p:cNvPr id="2" name="Rectangle 1"/>
@@ -12484,6 +13054,7 @@
           <a:lstStyle/>
           <a:p>
             <a:pPr algn="ctr"/>
+            <a:endParaRPr/>
           </a:p>
         </p:txBody>
       </p:sp>
@@ -12528,6 +13099,7 @@
           <a:lstStyle/>
           <a:p>
             <a:pPr algn="ctr"/>
+            <a:endParaRPr/>
           </a:p>
         </p:txBody>
       </p:sp>
@@ -12554,7 +13126,7 @@
           <a:lstStyle/>
           <a:p>
             <a:r>
-              <a:rPr b="1" sz="2400">
+              <a:rPr sz="2400" b="1">
                 <a:solidFill>
                   <a:srgbClr val="FFFFFF"/>
                 </a:solidFill>
@@ -12730,7 +13302,7 @@
 </file>
 
 <file path=ppt/slides/slide5.xml><?xml version="1.0" encoding="utf-8"?>
-<p:sld xmlns:a="http://schemas.openxmlformats.org/drawingml/2006/main" xmlns:p="http://schemas.openxmlformats.org/presentationml/2006/main" xmlns:r="http://schemas.openxmlformats.org/officeDocument/2006/relationships">
+<p:sld xmlns:a="http://schemas.openxmlformats.org/drawingml/2006/main" xmlns:r="http://schemas.openxmlformats.org/officeDocument/2006/relationships" xmlns:p="http://schemas.openxmlformats.org/presentationml/2006/main">
   <p:cSld>
     <p:spTree>
       <p:nvGrpSpPr>
@@ -12738,7 +13310,14 @@
         <p:cNvGrpSpPr/>
         <p:nvPr/>
       </p:nvGrpSpPr>
-      <p:grpSpPr/>
+      <p:grpSpPr>
+        <a:xfrm>
+          <a:off x="0" y="0"/>
+          <a:ext cx="0" cy="0"/>
+          <a:chOff x="0" y="0"/>
+          <a:chExt cx="0" cy="0"/>
+        </a:xfrm>
+      </p:grpSpPr>
       <p:sp>
         <p:nvSpPr>
           <p:cNvPr id="2" name="Rectangle 1"/>
@@ -12780,6 +13359,7 @@
           <a:lstStyle/>
           <a:p>
             <a:pPr algn="ctr"/>
+            <a:endParaRPr/>
           </a:p>
         </p:txBody>
       </p:sp>
@@ -12824,6 +13404,7 @@
           <a:lstStyle/>
           <a:p>
             <a:pPr algn="ctr"/>
+            <a:endParaRPr/>
           </a:p>
         </p:txBody>
       </p:sp>
@@ -12850,7 +13431,7 @@
           <a:lstStyle/>
           <a:p>
             <a:r>
-              <a:rPr b="1" sz="2400">
+              <a:rPr sz="2400" b="1">
                 <a:solidFill>
                   <a:srgbClr val="FFFFFF"/>
                 </a:solidFill>
@@ -12889,9 +13470,27 @@
                 <a:tableStyleId>{5C22544A-7EE6-4342-B048-85BDC9FD1C3A}</a:tableStyleId>
               </a:tblPr>
               <a:tblGrid>
-                <a:gridCol w="3688080"/>
-                <a:gridCol w="3688080"/>
-                <a:gridCol w="3688080"/>
+                <a:gridCol w="3688080">
+                  <a:extLst>
+                    <a:ext uri="{9D8B030D-6E8A-4147-A177-3AD203B41FA5}">
+                      <a16:colId xmlns:a16="http://schemas.microsoft.com/office/drawing/2014/main" val="20000"/>
+                    </a:ext>
+                  </a:extLst>
+                </a:gridCol>
+                <a:gridCol w="3688080">
+                  <a:extLst>
+                    <a:ext uri="{9D8B030D-6E8A-4147-A177-3AD203B41FA5}">
+                      <a16:colId xmlns:a16="http://schemas.microsoft.com/office/drawing/2014/main" val="20001"/>
+                    </a:ext>
+                  </a:extLst>
+                </a:gridCol>
+                <a:gridCol w="3688080">
+                  <a:extLst>
+                    <a:ext uri="{9D8B030D-6E8A-4147-A177-3AD203B41FA5}">
+                      <a16:colId xmlns:a16="http://schemas.microsoft.com/office/drawing/2014/main" val="20002"/>
+                    </a:ext>
+                  </a:extLst>
+                </a:gridCol>
               </a:tblGrid>
               <a:tr h="585216">
                 <a:tc>
@@ -12957,6 +13556,11 @@
                     </a:solidFill>
                   </a:tcPr>
                 </a:tc>
+                <a:extLst>
+                  <a:ext uri="{0D108BD9-81ED-4DB2-BD59-A6C34878D82A}">
+                    <a16:rowId xmlns:a16="http://schemas.microsoft.com/office/drawing/2014/main" val="10000"/>
+                  </a:ext>
+                </a:extLst>
               </a:tr>
               <a:tr h="585216">
                 <a:tc>
@@ -13022,6 +13626,11 @@
                     </a:solidFill>
                   </a:tcPr>
                 </a:tc>
+                <a:extLst>
+                  <a:ext uri="{0D108BD9-81ED-4DB2-BD59-A6C34878D82A}">
+                    <a16:rowId xmlns:a16="http://schemas.microsoft.com/office/drawing/2014/main" val="10001"/>
+                  </a:ext>
+                </a:extLst>
               </a:tr>
               <a:tr h="585216">
                 <a:tc>
@@ -13087,6 +13696,11 @@
                     </a:solidFill>
                   </a:tcPr>
                 </a:tc>
+                <a:extLst>
+                  <a:ext uri="{0D108BD9-81ED-4DB2-BD59-A6C34878D82A}">
+                    <a16:rowId xmlns:a16="http://schemas.microsoft.com/office/drawing/2014/main" val="10002"/>
+                  </a:ext>
+                </a:extLst>
               </a:tr>
               <a:tr h="585216">
                 <a:tc>
@@ -13152,6 +13766,11 @@
                     </a:solidFill>
                   </a:tcPr>
                 </a:tc>
+                <a:extLst>
+                  <a:ext uri="{0D108BD9-81ED-4DB2-BD59-A6C34878D82A}">
+                    <a16:rowId xmlns:a16="http://schemas.microsoft.com/office/drawing/2014/main" val="10003"/>
+                  </a:ext>
+                </a:extLst>
               </a:tr>
               <a:tr h="585216">
                 <a:tc>
@@ -13217,6 +13836,11 @@
                     </a:solidFill>
                   </a:tcPr>
                 </a:tc>
+                <a:extLst>
+                  <a:ext uri="{0D108BD9-81ED-4DB2-BD59-A6C34878D82A}">
+                    <a16:rowId xmlns:a16="http://schemas.microsoft.com/office/drawing/2014/main" val="10004"/>
+                  </a:ext>
+                </a:extLst>
               </a:tr>
             </a:tbl>
           </a:graphicData>
@@ -13308,7 +13932,7 @@
 </file>
 
 <file path=ppt/slides/slide6.xml><?xml version="1.0" encoding="utf-8"?>
-<p:sld xmlns:a="http://schemas.openxmlformats.org/drawingml/2006/main" xmlns:p="http://schemas.openxmlformats.org/presentationml/2006/main" xmlns:r="http://schemas.openxmlformats.org/officeDocument/2006/relationships">
+<p:sld xmlns:a="http://schemas.openxmlformats.org/drawingml/2006/main" xmlns:r="http://schemas.openxmlformats.org/officeDocument/2006/relationships" xmlns:p="http://schemas.openxmlformats.org/presentationml/2006/main">
   <p:cSld>
     <p:spTree>
       <p:nvGrpSpPr>
@@ -13316,7 +13940,14 @@
         <p:cNvGrpSpPr/>
         <p:nvPr/>
       </p:nvGrpSpPr>
-      <p:grpSpPr/>
+      <p:grpSpPr>
+        <a:xfrm>
+          <a:off x="0" y="0"/>
+          <a:ext cx="0" cy="0"/>
+          <a:chOff x="0" y="0"/>
+          <a:chExt cx="0" cy="0"/>
+        </a:xfrm>
+      </p:grpSpPr>
       <p:sp>
         <p:nvSpPr>
           <p:cNvPr id="2" name="Rectangle 1"/>
@@ -13358,6 +13989,7 @@
           <a:lstStyle/>
           <a:p>
             <a:pPr algn="ctr"/>
+            <a:endParaRPr/>
           </a:p>
         </p:txBody>
       </p:sp>
@@ -13402,6 +14034,7 @@
           <a:lstStyle/>
           <a:p>
             <a:pPr algn="ctr"/>
+            <a:endParaRPr/>
           </a:p>
         </p:txBody>
       </p:sp>
@@ -13428,7 +14061,7 @@
           <a:lstStyle/>
           <a:p>
             <a:r>
-              <a:rPr b="1" sz="4800">
+              <a:rPr sz="4800" b="1">
                 <a:solidFill>
                   <a:srgbClr val="FFFFFF"/>
                 </a:solidFill>
@@ -13447,7 +14080,7 @@
 </file>
 
 <file path=ppt/slides/slide7.xml><?xml version="1.0" encoding="utf-8"?>
-<p:sld xmlns:a="http://schemas.openxmlformats.org/drawingml/2006/main" xmlns:p="http://schemas.openxmlformats.org/presentationml/2006/main" xmlns:r="http://schemas.openxmlformats.org/officeDocument/2006/relationships">
+<p:sld xmlns:a="http://schemas.openxmlformats.org/drawingml/2006/main" xmlns:r="http://schemas.openxmlformats.org/officeDocument/2006/relationships" xmlns:p="http://schemas.openxmlformats.org/presentationml/2006/main">
   <p:cSld>
     <p:spTree>
       <p:nvGrpSpPr>
@@ -13455,7 +14088,14 @@
         <p:cNvGrpSpPr/>
         <p:nvPr/>
       </p:nvGrpSpPr>
-      <p:grpSpPr/>
+      <p:grpSpPr>
+        <a:xfrm>
+          <a:off x="0" y="0"/>
+          <a:ext cx="0" cy="0"/>
+          <a:chOff x="0" y="0"/>
+          <a:chExt cx="0" cy="0"/>
+        </a:xfrm>
+      </p:grpSpPr>
       <p:sp>
         <p:nvSpPr>
           <p:cNvPr id="2" name="Rectangle 1"/>
@@ -13497,6 +14137,7 @@
           <a:lstStyle/>
           <a:p>
             <a:pPr algn="ctr"/>
+            <a:endParaRPr/>
           </a:p>
         </p:txBody>
       </p:sp>
@@ -13541,6 +14182,7 @@
           <a:lstStyle/>
           <a:p>
             <a:pPr algn="ctr"/>
+            <a:endParaRPr/>
           </a:p>
         </p:txBody>
       </p:sp>
@@ -13567,7 +14209,7 @@
           <a:lstStyle/>
           <a:p>
             <a:r>
-              <a:rPr b="1" sz="2400">
+              <a:rPr sz="2400" b="1">
                 <a:solidFill>
                   <a:srgbClr val="FFFFFF"/>
                 </a:solidFill>
@@ -13606,11 +14248,41 @@
                 <a:tableStyleId>{5C22544A-7EE6-4342-B048-85BDC9FD1C3A}</a:tableStyleId>
               </a:tblPr>
               <a:tblGrid>
-                <a:gridCol w="2249424"/>
-                <a:gridCol w="2249424"/>
-                <a:gridCol w="2249424"/>
-                <a:gridCol w="2249424"/>
-                <a:gridCol w="2249424"/>
+                <a:gridCol w="2249424">
+                  <a:extLst>
+                    <a:ext uri="{9D8B030D-6E8A-4147-A177-3AD203B41FA5}">
+                      <a16:colId xmlns:a16="http://schemas.microsoft.com/office/drawing/2014/main" val="20000"/>
+                    </a:ext>
+                  </a:extLst>
+                </a:gridCol>
+                <a:gridCol w="2249424">
+                  <a:extLst>
+                    <a:ext uri="{9D8B030D-6E8A-4147-A177-3AD203B41FA5}">
+                      <a16:colId xmlns:a16="http://schemas.microsoft.com/office/drawing/2014/main" val="20001"/>
+                    </a:ext>
+                  </a:extLst>
+                </a:gridCol>
+                <a:gridCol w="2249424">
+                  <a:extLst>
+                    <a:ext uri="{9D8B030D-6E8A-4147-A177-3AD203B41FA5}">
+                      <a16:colId xmlns:a16="http://schemas.microsoft.com/office/drawing/2014/main" val="20002"/>
+                    </a:ext>
+                  </a:extLst>
+                </a:gridCol>
+                <a:gridCol w="2249424">
+                  <a:extLst>
+                    <a:ext uri="{9D8B030D-6E8A-4147-A177-3AD203B41FA5}">
+                      <a16:colId xmlns:a16="http://schemas.microsoft.com/office/drawing/2014/main" val="20003"/>
+                    </a:ext>
+                  </a:extLst>
+                </a:gridCol>
+                <a:gridCol w="2249424">
+                  <a:extLst>
+                    <a:ext uri="{9D8B030D-6E8A-4147-A177-3AD203B41FA5}">
+                      <a16:colId xmlns:a16="http://schemas.microsoft.com/office/drawing/2014/main" val="20004"/>
+                    </a:ext>
+                  </a:extLst>
+                </a:gridCol>
               </a:tblGrid>
               <a:tr h="548640">
                 <a:tc>
@@ -13718,6 +14390,11 @@
                     </a:solidFill>
                   </a:tcPr>
                 </a:tc>
+                <a:extLst>
+                  <a:ext uri="{0D108BD9-81ED-4DB2-BD59-A6C34878D82A}">
+                    <a16:rowId xmlns:a16="http://schemas.microsoft.com/office/drawing/2014/main" val="10000"/>
+                  </a:ext>
+                </a:extLst>
               </a:tr>
               <a:tr h="548640">
                 <a:tc>
@@ -13825,6 +14502,11 @@
                     </a:solidFill>
                   </a:tcPr>
                 </a:tc>
+                <a:extLst>
+                  <a:ext uri="{0D108BD9-81ED-4DB2-BD59-A6C34878D82A}">
+                    <a16:rowId xmlns:a16="http://schemas.microsoft.com/office/drawing/2014/main" val="10001"/>
+                  </a:ext>
+                </a:extLst>
               </a:tr>
               <a:tr h="548640">
                 <a:tc>
@@ -13932,6 +14614,11 @@
                     </a:solidFill>
                   </a:tcPr>
                 </a:tc>
+                <a:extLst>
+                  <a:ext uri="{0D108BD9-81ED-4DB2-BD59-A6C34878D82A}">
+                    <a16:rowId xmlns:a16="http://schemas.microsoft.com/office/drawing/2014/main" val="10002"/>
+                  </a:ext>
+                </a:extLst>
               </a:tr>
               <a:tr h="548640">
                 <a:tc>
@@ -14039,6 +14726,11 @@
                     </a:solidFill>
                   </a:tcPr>
                 </a:tc>
+                <a:extLst>
+                  <a:ext uri="{0D108BD9-81ED-4DB2-BD59-A6C34878D82A}">
+                    <a16:rowId xmlns:a16="http://schemas.microsoft.com/office/drawing/2014/main" val="10003"/>
+                  </a:ext>
+                </a:extLst>
               </a:tr>
               <a:tr h="548640">
                 <a:tc>
@@ -14146,6 +14838,11 @@
                     </a:solidFill>
                   </a:tcPr>
                 </a:tc>
+                <a:extLst>
+                  <a:ext uri="{0D108BD9-81ED-4DB2-BD59-A6C34878D82A}">
+                    <a16:rowId xmlns:a16="http://schemas.microsoft.com/office/drawing/2014/main" val="10004"/>
+                  </a:ext>
+                </a:extLst>
               </a:tr>
               <a:tr h="548640">
                 <a:tc>
@@ -14253,6 +14950,11 @@
                     </a:solidFill>
                   </a:tcPr>
                 </a:tc>
+                <a:extLst>
+                  <a:ext uri="{0D108BD9-81ED-4DB2-BD59-A6C34878D82A}">
+                    <a16:rowId xmlns:a16="http://schemas.microsoft.com/office/drawing/2014/main" val="10005"/>
+                  </a:ext>
+                </a:extLst>
               </a:tr>
             </a:tbl>
           </a:graphicData>
@@ -14334,7 +15036,7 @@
 </file>
 
 <file path=ppt/slides/slide8.xml><?xml version="1.0" encoding="utf-8"?>
-<p:sld xmlns:a="http://schemas.openxmlformats.org/drawingml/2006/main" xmlns:p="http://schemas.openxmlformats.org/presentationml/2006/main" xmlns:r="http://schemas.openxmlformats.org/officeDocument/2006/relationships">
+<p:sld xmlns:a="http://schemas.openxmlformats.org/drawingml/2006/main" xmlns:r="http://schemas.openxmlformats.org/officeDocument/2006/relationships" xmlns:p="http://schemas.openxmlformats.org/presentationml/2006/main">
   <p:cSld>
     <p:spTree>
       <p:nvGrpSpPr>
@@ -14342,7 +15044,14 @@
         <p:cNvGrpSpPr/>
         <p:nvPr/>
       </p:nvGrpSpPr>
-      <p:grpSpPr/>
+      <p:grpSpPr>
+        <a:xfrm>
+          <a:off x="0" y="0"/>
+          <a:ext cx="0" cy="0"/>
+          <a:chOff x="0" y="0"/>
+          <a:chExt cx="0" cy="0"/>
+        </a:xfrm>
+      </p:grpSpPr>
       <p:sp>
         <p:nvSpPr>
           <p:cNvPr id="2" name="Rectangle 1"/>
@@ -14384,6 +15093,7 @@
           <a:lstStyle/>
           <a:p>
             <a:pPr algn="ctr"/>
+            <a:endParaRPr/>
           </a:p>
         </p:txBody>
       </p:sp>
@@ -14428,6 +15138,7 @@
           <a:lstStyle/>
           <a:p>
             <a:pPr algn="ctr"/>
+            <a:endParaRPr/>
           </a:p>
         </p:txBody>
       </p:sp>
@@ -14454,7 +15165,7 @@
           <a:lstStyle/>
           <a:p>
             <a:r>
-              <a:rPr b="1" sz="2400">
+              <a:rPr sz="2400" b="1">
                 <a:solidFill>
                   <a:srgbClr val="FFFFFF"/>
                 </a:solidFill>
@@ -14615,7 +15326,7 @@
 </file>
 
 <file path=ppt/slides/slide9.xml><?xml version="1.0" encoding="utf-8"?>
-<p:sld xmlns:a="http://schemas.openxmlformats.org/drawingml/2006/main" xmlns:p="http://schemas.openxmlformats.org/presentationml/2006/main" xmlns:r="http://schemas.openxmlformats.org/officeDocument/2006/relationships">
+<p:sld xmlns:a="http://schemas.openxmlformats.org/drawingml/2006/main" xmlns:r="http://schemas.openxmlformats.org/officeDocument/2006/relationships" xmlns:p="http://schemas.openxmlformats.org/presentationml/2006/main">
   <p:cSld>
     <p:spTree>
       <p:nvGrpSpPr>
@@ -14623,7 +15334,14 @@
         <p:cNvGrpSpPr/>
         <p:nvPr/>
       </p:nvGrpSpPr>
-      <p:grpSpPr/>
+      <p:grpSpPr>
+        <a:xfrm>
+          <a:off x="0" y="0"/>
+          <a:ext cx="0" cy="0"/>
+          <a:chOff x="0" y="0"/>
+          <a:chExt cx="0" cy="0"/>
+        </a:xfrm>
+      </p:grpSpPr>
       <p:sp>
         <p:nvSpPr>
           <p:cNvPr id="2" name="Rectangle 1"/>
@@ -14665,6 +15383,7 @@
           <a:lstStyle/>
           <a:p>
             <a:pPr algn="ctr"/>
+            <a:endParaRPr/>
           </a:p>
         </p:txBody>
       </p:sp>
@@ -14709,6 +15428,7 @@
           <a:lstStyle/>
           <a:p>
             <a:pPr algn="ctr"/>
+            <a:endParaRPr/>
           </a:p>
         </p:txBody>
       </p:sp>
@@ -14735,7 +15455,7 @@
           <a:lstStyle/>
           <a:p>
             <a:r>
-              <a:rPr b="1" sz="2400">
+              <a:rPr sz="2400" b="1">
                 <a:solidFill>
                   <a:srgbClr val="FFFFFF"/>
                 </a:solidFill>
@@ -14796,7 +15516,7 @@
         </p:nvSpPr>
         <p:spPr>
           <a:xfrm>
-            <a:off x="1097280" y="1005840"/>
+            <a:off x="457200" y="1005840"/>
             <a:ext cx="5760720" cy="4846320"/>
           </a:xfrm>
           <a:prstGeom prst="rect">
@@ -14816,7 +15536,7 @@
               </a:spcAft>
             </a:pPr>
             <a:r>
-              <a:rPr sz="1400">
+              <a:rPr sz="1400" dirty="0">
                 <a:solidFill>
                   <a:srgbClr val="1F2A44"/>
                 </a:solidFill>
@@ -14831,7 +15551,7 @@
               </a:spcAft>
             </a:pPr>
             <a:r>
-              <a:rPr sz="1400">
+              <a:rPr sz="1400" dirty="0">
                 <a:solidFill>
                   <a:srgbClr val="1F2A44"/>
                 </a:solidFill>
@@ -14846,7 +15566,7 @@
               </a:spcAft>
             </a:pPr>
             <a:r>
-              <a:rPr sz="1400">
+              <a:rPr sz="1400" dirty="0">
                 <a:solidFill>
                   <a:srgbClr val="1F2A44"/>
                 </a:solidFill>
@@ -14861,7 +15581,7 @@
               </a:spcAft>
             </a:pPr>
             <a:r>
-              <a:rPr sz="1400">
+              <a:rPr sz="1400" dirty="0">
                 <a:solidFill>
                   <a:srgbClr val="1F2A44"/>
                 </a:solidFill>
@@ -14876,7 +15596,7 @@
               </a:spcAft>
             </a:pPr>
             <a:r>
-              <a:rPr sz="1400">
+              <a:rPr sz="1400" dirty="0">
                 <a:solidFill>
                   <a:srgbClr val="1F2A44"/>
                 </a:solidFill>
@@ -14891,7 +15611,7 @@
               </a:spcAft>
             </a:pPr>
             <a:r>
-              <a:rPr sz="1400">
+              <a:rPr sz="1400" dirty="0">
                 <a:solidFill>
                   <a:srgbClr val="1F2A44"/>
                 </a:solidFill>
@@ -14906,7 +15626,7 @@
               </a:spcAft>
             </a:pPr>
             <a:r>
-              <a:rPr sz="1400">
+              <a:rPr sz="1400" dirty="0">
                 <a:solidFill>
                   <a:srgbClr val="1F2A44"/>
                 </a:solidFill>
@@ -14921,7 +15641,7 @@
               </a:spcAft>
             </a:pPr>
             <a:r>
-              <a:rPr sz="1400">
+              <a:rPr sz="1400" dirty="0">
                 <a:solidFill>
                   <a:srgbClr val="1F2A44"/>
                 </a:solidFill>
@@ -14974,6 +15694,7 @@
           <a:lstStyle/>
           <a:p>
             <a:pPr algn="ctr"/>
+            <a:endParaRPr/>
           </a:p>
         </p:txBody>
       </p:sp>
@@ -15000,7 +15721,7 @@
           <a:lstStyle/>
           <a:p>
             <a:r>
-              <a:rPr sz="1400" b="1">
+              <a:rPr sz="1400" b="1" dirty="0">
                 <a:solidFill>
                   <a:srgbClr val="1F2A44"/>
                 </a:solidFill>
@@ -15010,7 +15731,7 @@
           </a:p>
           <a:p>
             <a:r>
-              <a:rPr sz="1100">
+              <a:rPr sz="1100" dirty="0">
                 <a:solidFill>
                   <a:srgbClr val="5A6A7A"/>
                 </a:solidFill>

</xml_diff>

<commit_message>
docs: update Atlas AI solution proposal deck
Co-Authored-By: Claude Opus 4.8 (1M context) <noreply@anthropic.com>
</commit_message>
<xml_diff>
--- a/proposal/Atlas_AI_Solution_Proposal.pptx
+++ b/proposal/Atlas_AI_Solution_Proposal.pptx
@@ -21,8 +21,8 @@
     <p:sldId id="269" r:id="rId15"/>
     <p:sldId id="270" r:id="rId16"/>
     <p:sldId id="271" r:id="rId17"/>
-    <p:sldId id="272" r:id="rId18"/>
-    <p:sldId id="273" r:id="rId19"/>
+    <p:sldId id="282" r:id="rId18"/>
+    <p:sldId id="283" r:id="rId19"/>
     <p:sldId id="274" r:id="rId20"/>
     <p:sldId id="275" r:id="rId21"/>
     <p:sldId id="276" r:id="rId22"/>
@@ -327,7 +327,7 @@
           <a:p>
             <a:fld id="{5BCAD085-E8A6-8845-BD4E-CB4CCA059FC4}" type="datetimeFigureOut">
               <a:rPr lang="en-US" smtClean="0"/>
-              <a:t>5/26/26</a:t>
+              <a:t>6/2/26</a:t>
             </a:fld>
             <a:endParaRPr lang="en-US"/>
           </a:p>
@@ -495,7 +495,7 @@
           <a:p>
             <a:fld id="{5BCAD085-E8A6-8845-BD4E-CB4CCA059FC4}" type="datetimeFigureOut">
               <a:rPr lang="en-US" smtClean="0"/>
-              <a:t>5/26/26</a:t>
+              <a:t>6/2/26</a:t>
             </a:fld>
             <a:endParaRPr lang="en-US"/>
           </a:p>
@@ -673,7 +673,7 @@
           <a:p>
             <a:fld id="{5BCAD085-E8A6-8845-BD4E-CB4CCA059FC4}" type="datetimeFigureOut">
               <a:rPr lang="en-US" smtClean="0"/>
-              <a:t>5/26/26</a:t>
+              <a:t>6/2/26</a:t>
             </a:fld>
             <a:endParaRPr lang="en-US"/>
           </a:p>
@@ -841,7 +841,7 @@
           <a:p>
             <a:fld id="{5BCAD085-E8A6-8845-BD4E-CB4CCA059FC4}" type="datetimeFigureOut">
               <a:rPr lang="en-US" smtClean="0"/>
-              <a:t>5/26/26</a:t>
+              <a:t>6/2/26</a:t>
             </a:fld>
             <a:endParaRPr lang="en-US"/>
           </a:p>
@@ -1086,7 +1086,7 @@
           <a:p>
             <a:fld id="{5BCAD085-E8A6-8845-BD4E-CB4CCA059FC4}" type="datetimeFigureOut">
               <a:rPr lang="en-US" smtClean="0"/>
-              <a:t>5/26/26</a:t>
+              <a:t>6/2/26</a:t>
             </a:fld>
             <a:endParaRPr lang="en-US"/>
           </a:p>
@@ -1371,7 +1371,7 @@
           <a:p>
             <a:fld id="{5BCAD085-E8A6-8845-BD4E-CB4CCA059FC4}" type="datetimeFigureOut">
               <a:rPr lang="en-US" smtClean="0"/>
-              <a:t>5/26/26</a:t>
+              <a:t>6/2/26</a:t>
             </a:fld>
             <a:endParaRPr lang="en-US"/>
           </a:p>
@@ -1790,7 +1790,7 @@
           <a:p>
             <a:fld id="{5BCAD085-E8A6-8845-BD4E-CB4CCA059FC4}" type="datetimeFigureOut">
               <a:rPr lang="en-US" smtClean="0"/>
-              <a:t>5/26/26</a:t>
+              <a:t>6/2/26</a:t>
             </a:fld>
             <a:endParaRPr lang="en-US"/>
           </a:p>
@@ -1907,7 +1907,7 @@
           <a:p>
             <a:fld id="{5BCAD085-E8A6-8845-BD4E-CB4CCA059FC4}" type="datetimeFigureOut">
               <a:rPr lang="en-US" smtClean="0"/>
-              <a:t>5/26/26</a:t>
+              <a:t>6/2/26</a:t>
             </a:fld>
             <a:endParaRPr lang="en-US"/>
           </a:p>
@@ -2002,7 +2002,7 @@
           <a:p>
             <a:fld id="{5BCAD085-E8A6-8845-BD4E-CB4CCA059FC4}" type="datetimeFigureOut">
               <a:rPr lang="en-US" smtClean="0"/>
-              <a:t>5/26/26</a:t>
+              <a:t>6/2/26</a:t>
             </a:fld>
             <a:endParaRPr lang="en-US"/>
           </a:p>
@@ -2277,7 +2277,7 @@
           <a:p>
             <a:fld id="{5BCAD085-E8A6-8845-BD4E-CB4CCA059FC4}" type="datetimeFigureOut">
               <a:rPr lang="en-US" smtClean="0"/>
-              <a:t>5/26/26</a:t>
+              <a:t>6/2/26</a:t>
             </a:fld>
             <a:endParaRPr lang="en-US"/>
           </a:p>
@@ -2529,7 +2529,7 @@
           <a:p>
             <a:fld id="{5BCAD085-E8A6-8845-BD4E-CB4CCA059FC4}" type="datetimeFigureOut">
               <a:rPr lang="en-US" smtClean="0"/>
-              <a:t>5/26/26</a:t>
+              <a:t>6/2/26</a:t>
             </a:fld>
             <a:endParaRPr lang="en-US"/>
           </a:p>
@@ -2740,7 +2740,7 @@
           <a:p>
             <a:fld id="{5BCAD085-E8A6-8845-BD4E-CB4CCA059FC4}" type="datetimeFigureOut">
               <a:rPr lang="en-US" smtClean="0"/>
-              <a:t>5/26/26</a:t>
+              <a:t>6/2/26</a:t>
             </a:fld>
             <a:endParaRPr lang="en-US"/>
           </a:p>
@@ -3468,7 +3468,7 @@
         </p:nvSpPr>
         <p:spPr>
           <a:xfrm>
-            <a:off x="1097280" y="731520"/>
+            <a:off x="457200" y="1188720"/>
             <a:ext cx="10698480" cy="5303520"/>
           </a:xfrm>
           <a:prstGeom prst="rect">
@@ -3488,7 +3488,7 @@
               </a:spcAft>
             </a:pPr>
             <a:r>
-              <a:rPr sz="1400">
+              <a:rPr sz="1400" dirty="0">
                 <a:solidFill>
                   <a:srgbClr val="1F2A44"/>
                 </a:solidFill>
@@ -3503,7 +3503,7 @@
               </a:spcAft>
             </a:pPr>
             <a:r>
-              <a:rPr sz="1400">
+              <a:rPr sz="1400" dirty="0">
                 <a:solidFill>
                   <a:srgbClr val="1F2A44"/>
                 </a:solidFill>
@@ -3518,7 +3518,7 @@
               </a:spcAft>
             </a:pPr>
             <a:r>
-              <a:rPr sz="1400">
+              <a:rPr sz="1400" dirty="0">
                 <a:solidFill>
                   <a:srgbClr val="1F2A44"/>
                 </a:solidFill>
@@ -3533,7 +3533,7 @@
               </a:spcAft>
             </a:pPr>
             <a:r>
-              <a:rPr sz="1400">
+              <a:rPr sz="1400" dirty="0">
                 <a:solidFill>
                   <a:srgbClr val="1F2A44"/>
                 </a:solidFill>
@@ -3548,12 +3548,28 @@
               </a:spcAft>
             </a:pPr>
             <a:r>
-              <a:rPr sz="1400">
+              <a:rPr sz="1400" dirty="0">
                 <a:solidFill>
                   <a:srgbClr val="1F2A44"/>
                 </a:solidFill>
               </a:rPr>
-              <a:t>• Backtest MAPE + stockout-days tracking dashboard for continuous improvement.</a:t>
+              <a:t>• </a:t>
+            </a:r>
+            <a:r>
+              <a:rPr sz="1400" dirty="0" err="1">
+                <a:solidFill>
+                  <a:srgbClr val="1F2A44"/>
+                </a:solidFill>
+              </a:rPr>
+              <a:t>Backtest</a:t>
+            </a:r>
+            <a:r>
+              <a:rPr sz="1400" dirty="0">
+                <a:solidFill>
+                  <a:srgbClr val="1F2A44"/>
+                </a:solidFill>
+              </a:rPr>
+              <a:t> MAPE + stockout-days tracking dashboard for continuous improvement.</a:t>
             </a:r>
           </a:p>
           <a:p>
@@ -3563,7 +3579,7 @@
               </a:spcAft>
             </a:pPr>
             <a:r>
-              <a:rPr sz="1400">
+              <a:rPr sz="1400" dirty="0">
                 <a:solidFill>
                   <a:srgbClr val="1F2A44"/>
                 </a:solidFill>
@@ -3773,7 +3789,7 @@
         </p:nvSpPr>
         <p:spPr>
           <a:xfrm>
-            <a:off x="1097280" y="731520"/>
+            <a:off x="457200" y="1255043"/>
             <a:ext cx="10698480" cy="5303520"/>
           </a:xfrm>
           <a:prstGeom prst="rect">
@@ -3793,7 +3809,7 @@
               </a:spcAft>
             </a:pPr>
             <a:r>
-              <a:rPr sz="1400">
+              <a:rPr sz="1400" dirty="0">
                 <a:solidFill>
                   <a:srgbClr val="1F2A44"/>
                 </a:solidFill>
@@ -3808,7 +3824,7 @@
               </a:spcAft>
             </a:pPr>
             <a:r>
-              <a:rPr sz="1400">
+              <a:rPr sz="1400" dirty="0">
                 <a:solidFill>
                   <a:srgbClr val="1F2A44"/>
                 </a:solidFill>
@@ -3823,7 +3839,7 @@
               </a:spcAft>
             </a:pPr>
             <a:r>
-              <a:rPr sz="1400">
+              <a:rPr sz="1400" dirty="0">
                 <a:solidFill>
                   <a:srgbClr val="1F2A44"/>
                 </a:solidFill>
@@ -3838,7 +3854,7 @@
               </a:spcAft>
             </a:pPr>
             <a:r>
-              <a:rPr sz="1400">
+              <a:rPr sz="1400" dirty="0">
                 <a:solidFill>
                   <a:srgbClr val="1F2A44"/>
                 </a:solidFill>
@@ -3853,7 +3869,7 @@
               </a:spcAft>
             </a:pPr>
             <a:r>
-              <a:rPr sz="1400">
+              <a:rPr sz="1400" dirty="0">
                 <a:solidFill>
                   <a:srgbClr val="1F2A44"/>
                 </a:solidFill>
@@ -4096,8 +4112,8 @@
         </p:nvSpPr>
         <p:spPr>
           <a:xfrm>
-            <a:off x="1097280" y="1005840"/>
-            <a:ext cx="5669280" cy="4846320"/>
+            <a:off x="426567" y="1085705"/>
+            <a:ext cx="5669280" cy="2841804"/>
           </a:xfrm>
           <a:prstGeom prst="rect">
             <a:avLst/>
@@ -4116,7 +4132,7 @@
               </a:spcAft>
             </a:pPr>
             <a:r>
-              <a:rPr sz="1200">
+              <a:rPr sz="1200" dirty="0">
                 <a:solidFill>
                   <a:srgbClr val="1F2A44"/>
                 </a:solidFill>
@@ -4131,7 +4147,7 @@
               </a:spcAft>
             </a:pPr>
             <a:r>
-              <a:rPr sz="1000">
+              <a:rPr sz="1000" dirty="0">
                 <a:solidFill>
                   <a:srgbClr val="5A6A7A"/>
                 </a:solidFill>
@@ -4146,12 +4162,28 @@
               </a:spcAft>
             </a:pPr>
             <a:r>
-              <a:rPr sz="1200">
+              <a:rPr sz="1200" dirty="0">
                 <a:solidFill>
                   <a:srgbClr val="1F2A44"/>
                 </a:solidFill>
               </a:rPr>
-              <a:t>• Deseasonalize trailing 180 days → baseline daily demand; reinflate over horizon.</a:t>
+              <a:t>• </a:t>
+            </a:r>
+            <a:r>
+              <a:rPr sz="1200" dirty="0" err="1">
+                <a:solidFill>
+                  <a:srgbClr val="1F2A44"/>
+                </a:solidFill>
+              </a:rPr>
+              <a:t>Deseasonalize</a:t>
+            </a:r>
+            <a:r>
+              <a:rPr sz="1200" dirty="0">
+                <a:solidFill>
+                  <a:srgbClr val="1F2A44"/>
+                </a:solidFill>
+              </a:rPr>
+              <a:t> trailing 180 days → baseline daily demand; reinflate over horizon.</a:t>
             </a:r>
           </a:p>
           <a:p>
@@ -4161,7 +4193,7 @@
               </a:spcAft>
             </a:pPr>
             <a:r>
-              <a:rPr sz="1000">
+              <a:rPr sz="1000" dirty="0">
                 <a:solidFill>
                   <a:srgbClr val="5A6A7A"/>
                 </a:solidFill>
@@ -4176,12 +4208,60 @@
               </a:spcAft>
             </a:pPr>
             <a:r>
-              <a:rPr sz="1200">
+              <a:rPr sz="1200" dirty="0">
                 <a:solidFill>
                   <a:srgbClr val="1F2A44"/>
                 </a:solidFill>
               </a:rPr>
-              <a:t>• Reorder: ROP = avg_daily_demand × lead_time + safety_stock.</a:t>
+              <a:t>• Reorder: ROP = </a:t>
+            </a:r>
+            <a:r>
+              <a:rPr sz="1200" dirty="0" err="1">
+                <a:solidFill>
+                  <a:srgbClr val="1F2A44"/>
+                </a:solidFill>
+              </a:rPr>
+              <a:t>avg_daily_demand</a:t>
+            </a:r>
+            <a:r>
+              <a:rPr sz="1200" dirty="0">
+                <a:solidFill>
+                  <a:srgbClr val="1F2A44"/>
+                </a:solidFill>
+              </a:rPr>
+              <a:t> × </a:t>
+            </a:r>
+            <a:r>
+              <a:rPr sz="1200" dirty="0" err="1">
+                <a:solidFill>
+                  <a:srgbClr val="1F2A44"/>
+                </a:solidFill>
+              </a:rPr>
+              <a:t>lead_time</a:t>
+            </a:r>
+            <a:r>
+              <a:rPr sz="1200" dirty="0">
+                <a:solidFill>
+                  <a:srgbClr val="1F2A44"/>
+                </a:solidFill>
+              </a:rPr>
+              <a:t> + </a:t>
+            </a:r>
+            <a:r>
+              <a:rPr sz="1200" dirty="0" err="1">
+                <a:solidFill>
+                  <a:srgbClr val="1F2A44"/>
+                </a:solidFill>
+              </a:rPr>
+              <a:t>safety_stock</a:t>
+            </a:r>
+            <a:r>
+              <a:rPr sz="1200" dirty="0">
+                <a:solidFill>
+                  <a:srgbClr val="1F2A44"/>
+                </a:solidFill>
+              </a:rPr>
+              <a:t>.</a:t>
             </a:r>
           </a:p>
           <a:p>
@@ -4191,7 +4271,7 @@
               </a:spcAft>
             </a:pPr>
             <a:r>
-              <a:rPr sz="1000">
+              <a:rPr sz="1000" dirty="0">
                 <a:solidFill>
                   <a:srgbClr val="5A6A7A"/>
                 </a:solidFill>
@@ -4206,12 +4286,44 @@
               </a:spcAft>
             </a:pPr>
             <a:r>
-              <a:rPr sz="1200">
+              <a:rPr sz="1200" dirty="0">
                 <a:solidFill>
                   <a:srgbClr val="1F2A44"/>
                 </a:solidFill>
               </a:rPr>
-              <a:t>• Buffer: safety_stock = z(SL) × σ × √LT.</a:t>
+              <a:t>• Buffer: </a:t>
+            </a:r>
+            <a:r>
+              <a:rPr sz="1200" dirty="0" err="1">
+                <a:solidFill>
+                  <a:srgbClr val="1F2A44"/>
+                </a:solidFill>
+              </a:rPr>
+              <a:t>safety_stock</a:t>
+            </a:r>
+            <a:r>
+              <a:rPr sz="1200" dirty="0">
+                <a:solidFill>
+                  <a:srgbClr val="1F2A44"/>
+                </a:solidFill>
+              </a:rPr>
+              <a:t> = z(SL) × </a:t>
+            </a:r>
+            <a:r>
+              <a:rPr sz="1200" dirty="0" err="1">
+                <a:solidFill>
+                  <a:srgbClr val="1F2A44"/>
+                </a:solidFill>
+              </a:rPr>
+              <a:t>σ</a:t>
+            </a:r>
+            <a:r>
+              <a:rPr sz="1200" dirty="0">
+                <a:solidFill>
+                  <a:srgbClr val="1F2A44"/>
+                </a:solidFill>
+              </a:rPr>
+              <a:t> × √LT.</a:t>
             </a:r>
           </a:p>
           <a:p>
@@ -4221,7 +4333,7 @@
               </a:spcAft>
             </a:pPr>
             <a:r>
-              <a:rPr sz="1000">
+              <a:rPr sz="1000" dirty="0">
                 <a:solidFill>
                   <a:srgbClr val="5A6A7A"/>
                 </a:solidFill>
@@ -4236,7 +4348,7 @@
               </a:spcAft>
             </a:pPr>
             <a:r>
-              <a:rPr sz="1200">
+              <a:rPr sz="1200" dirty="0">
                 <a:solidFill>
                   <a:srgbClr val="1F2A44"/>
                 </a:solidFill>
@@ -4251,7 +4363,7 @@
               </a:spcAft>
             </a:pPr>
             <a:r>
-              <a:rPr sz="1000">
+              <a:rPr sz="1000" dirty="0">
                 <a:solidFill>
                   <a:srgbClr val="5A6A7A"/>
                 </a:solidFill>
@@ -4266,7 +4378,7 @@
               </a:spcAft>
             </a:pPr>
             <a:r>
-              <a:rPr sz="1200">
+              <a:rPr sz="1200" dirty="0">
                 <a:solidFill>
                   <a:srgbClr val="1F2A44"/>
                 </a:solidFill>
@@ -4281,12 +4393,28 @@
               </a:spcAft>
             </a:pPr>
             <a:r>
-              <a:rPr sz="1000">
+              <a:rPr sz="1000" dirty="0">
                 <a:solidFill>
                   <a:srgbClr val="5A6A7A"/>
                 </a:solidFill>
               </a:rPr>
-              <a:t>– synthesises act-now / defer / consolidate; a grounding check rejects any invented figure → template fallback.</a:t>
+              <a:t>– </a:t>
+            </a:r>
+            <a:r>
+              <a:rPr sz="1000" dirty="0" err="1">
+                <a:solidFill>
+                  <a:srgbClr val="5A6A7A"/>
+                </a:solidFill>
+              </a:rPr>
+              <a:t>synthesises</a:t>
+            </a:r>
+            <a:r>
+              <a:rPr sz="1000" dirty="0">
+                <a:solidFill>
+                  <a:srgbClr val="5A6A7A"/>
+                </a:solidFill>
+              </a:rPr>
+              <a:t> act-now / defer / consolidate; a grounding check rejects any invented figure → template fallback.</a:t>
             </a:r>
           </a:p>
         </p:txBody>
@@ -4346,8 +4474,8 @@
         </p:nvSpPr>
         <p:spPr>
           <a:xfrm>
-            <a:off x="6583680" y="1234440"/>
-            <a:ext cx="5029200" cy="5029200"/>
+            <a:off x="6766560" y="1435608"/>
+            <a:ext cx="4565055" cy="2492990"/>
           </a:xfrm>
           <a:prstGeom prst="rect">
             <a:avLst/>
@@ -4361,7 +4489,7 @@
           <a:lstStyle/>
           <a:p>
             <a:r>
-              <a:rPr sz="1300" b="1">
+              <a:rPr sz="1300" b="1" dirty="0">
                 <a:solidFill>
                   <a:srgbClr val="1F2A44"/>
                 </a:solidFill>
@@ -4371,7 +4499,7 @@
           </a:p>
           <a:p>
             <a:r>
-              <a:rPr sz="1100">
+              <a:rPr sz="1100" dirty="0">
                 <a:solidFill>
                   <a:srgbClr val="5A6A7A"/>
                 </a:solidFill>
@@ -5122,8 +5250,8 @@
         </p:nvSpPr>
         <p:spPr>
           <a:xfrm>
-            <a:off x="4754880" y="548640"/>
-            <a:ext cx="11155680" cy="365760"/>
+            <a:off x="457200" y="4749800"/>
+            <a:ext cx="11252200" cy="304800"/>
           </a:xfrm>
           <a:prstGeom prst="rect">
             <a:avLst/>
@@ -5155,8 +5283,8 @@
         </p:nvSpPr>
         <p:spPr>
           <a:xfrm>
-            <a:off x="4754880" y="1005840"/>
-            <a:ext cx="11155680" cy="1371600"/>
+            <a:off x="457200" y="5080000"/>
+            <a:ext cx="11252200" cy="1333500"/>
           </a:xfrm>
           <a:prstGeom prst="rect">
             <a:avLst/>
@@ -5175,7 +5303,7 @@
               </a:spcAft>
             </a:pPr>
             <a:r>
-              <a:rPr sz="1100">
+              <a:rPr sz="1100" dirty="0">
                 <a:solidFill>
                   <a:srgbClr val="1F2A44"/>
                 </a:solidFill>
@@ -5190,7 +5318,7 @@
               </a:spcAft>
             </a:pPr>
             <a:r>
-              <a:rPr sz="1100">
+              <a:rPr sz="1100" dirty="0">
                 <a:solidFill>
                   <a:srgbClr val="1F2A44"/>
                 </a:solidFill>
@@ -5205,7 +5333,7 @@
               </a:spcAft>
             </a:pPr>
             <a:r>
-              <a:rPr sz="1100">
+              <a:rPr sz="1100" dirty="0">
                 <a:solidFill>
                   <a:srgbClr val="1F2A44"/>
                 </a:solidFill>
@@ -5220,7 +5348,7 @@
               </a:spcAft>
             </a:pPr>
             <a:r>
-              <a:rPr sz="1100">
+              <a:rPr sz="1100" dirty="0">
                 <a:solidFill>
                   <a:srgbClr val="1F2A44"/>
                 </a:solidFill>
@@ -7092,14 +7220,14 @@
       </p:sp>
       <p:sp>
         <p:nvSpPr>
-          <p:cNvPr id="6" name="TextBox 5"/>
+          <p:cNvPr id="7" name="TextBox 6"/>
           <p:cNvSpPr txBox="1"/>
           <p:nvPr/>
         </p:nvSpPr>
         <p:spPr>
           <a:xfrm>
-            <a:off x="365760" y="1371600"/>
-            <a:ext cx="11430000" cy="4663440"/>
+            <a:off x="365760" y="6126480"/>
+            <a:ext cx="11430000" cy="365760"/>
           </a:xfrm>
           <a:prstGeom prst="rect">
             <a:avLst/>
@@ -7107,220 +7235,32 @@
           <a:noFill/>
         </p:spPr>
         <p:txBody>
-          <a:bodyPr wrap="square">
+          <a:bodyPr wrap="none">
             <a:spAutoFit/>
           </a:bodyPr>
           <a:lstStyle/>
           <a:p>
             <a:r>
-              <a:rPr sz="1100">
-                <a:solidFill>
-                  <a:srgbClr val="1F2A44"/>
-                </a:solidFill>
-                <a:latin typeface="Menlo"/>
-              </a:rPr>
-              <a:t>ERP (SQL, read-only)                     5 tables, 10+ yr history, ~200–500 active SKUs (subject to S2 velocity analysis)</a:t>
-            </a:r>
-          </a:p>
-          <a:p>
-            <a:r>
-              <a:rPr sz="1100">
-                <a:solidFill>
-                  <a:srgbClr val="1F2A44"/>
-                </a:solidFill>
-                <a:latin typeface="Menlo"/>
-              </a:rPr>
-              <a:t>      │  weekly extract (SELECT only, no writes)</a:t>
-            </a:r>
-          </a:p>
-          <a:p>
-            <a:r>
-              <a:rPr sz="1100">
-                <a:solidFill>
-                  <a:srgbClr val="1F2A44"/>
-                </a:solidFill>
-                <a:latin typeface="Menlo"/>
-              </a:rPr>
-              <a:t>      ▼</a:t>
-            </a:r>
-          </a:p>
-          <a:p>
-            <a:r>
-              <a:rPr sz="1100">
-                <a:solidFill>
-                  <a:srgbClr val="1F2A44"/>
-                </a:solidFill>
-                <a:latin typeface="Menlo"/>
-              </a:rPr>
-              <a:t>Local SQLite cache (≈10 MB)              refreshed weekly on the on-prem server</a:t>
-            </a:r>
-          </a:p>
-          <a:p>
-            <a:r>
-              <a:rPr sz="1100">
-                <a:solidFill>
-                  <a:srgbClr val="1F2A44"/>
-                </a:solidFill>
-                <a:latin typeface="Menlo"/>
-              </a:rPr>
-              <a:t>      │</a:t>
-            </a:r>
-          </a:p>
-          <a:p>
-            <a:r>
-              <a:rPr sz="1100">
-                <a:solidFill>
-                  <a:srgbClr val="1F2A44"/>
-                </a:solidFill>
-                <a:latin typeface="Menlo"/>
-              </a:rPr>
-              <a:t>      ▼</a:t>
-            </a:r>
-          </a:p>
-          <a:p>
-            <a:r>
-              <a:rPr sz="1100">
-                <a:solidFill>
-                  <a:srgbClr val="1F2A44"/>
-                </a:solidFill>
-                <a:latin typeface="Menlo"/>
-              </a:rPr>
-              <a:t>Forecasting engine  ─── moving avg + multiplicative seasonality   (pandas + numpy)</a:t>
-            </a:r>
-          </a:p>
-          <a:p>
-            <a:r>
-              <a:rPr sz="1100">
-                <a:solidFill>
-                  <a:srgbClr val="1F2A44"/>
-                </a:solidFill>
-                <a:latin typeface="Menlo"/>
-              </a:rPr>
-              <a:t>      │  (forecast + uncertainty + seasonal factor)</a:t>
-            </a:r>
-          </a:p>
-          <a:p>
-            <a:r>
-              <a:rPr sz="1100">
-                <a:solidFill>
-                  <a:srgbClr val="1F2A44"/>
-                </a:solidFill>
-                <a:latin typeface="Menlo"/>
-              </a:rPr>
-              <a:t>      ▼</a:t>
-            </a:r>
-          </a:p>
-          <a:p>
-            <a:r>
-              <a:rPr sz="1100">
-                <a:solidFill>
-                  <a:srgbClr val="1F2A44"/>
-                </a:solidFill>
-                <a:latin typeface="Menlo"/>
-              </a:rPr>
-              <a:t>Reorder engine      ─── Reorder point + buffer (ROP + safety stock)</a:t>
-            </a:r>
-          </a:p>
-          <a:p>
-            <a:r>
-              <a:rPr sz="1100">
-                <a:solidFill>
-                  <a:srgbClr val="1F2A44"/>
-                </a:solidFill>
-                <a:latin typeface="Menlo"/>
-              </a:rPr>
-              <a:t>      │</a:t>
-            </a:r>
-          </a:p>
-          <a:p>
-            <a:r>
-              <a:rPr sz="1100">
-                <a:solidFill>
-                  <a:srgbClr val="1F2A44"/>
-                </a:solidFill>
-                <a:latin typeface="Menlo"/>
-              </a:rPr>
-              <a:t>      ├─────────▶  LLM (Claude Haiku)    optional, cloud — weekly briefing + per-SKU explanation</a:t>
-            </a:r>
-          </a:p>
-          <a:p>
-            <a:r>
-              <a:rPr sz="1100">
-                <a:solidFill>
-                  <a:srgbClr val="1F2A44"/>
-                </a:solidFill>
-                <a:latin typeface="Menlo"/>
-              </a:rPr>
-              <a:t>      │◀─────────   OR offline template  deterministic fallback; grounding check guards every figure</a:t>
-            </a:r>
-          </a:p>
-          <a:p>
-            <a:r>
-              <a:rPr sz="1100">
-                <a:solidFill>
-                  <a:srgbClr val="1F2A44"/>
-                </a:solidFill>
-                <a:latin typeface="Menlo"/>
-              </a:rPr>
-              <a:t>      ▼</a:t>
-            </a:r>
-          </a:p>
-          <a:p>
-            <a:r>
-              <a:rPr sz="1100">
-                <a:solidFill>
-                  <a:srgbClr val="1F2A44"/>
-                </a:solidFill>
-                <a:latin typeface="Menlo"/>
-              </a:rPr>
-              <a:t>Streamlit UI  (LAN-only)   Dashboard · SKU Drilldown · What-if     1–3 concurrent users</a:t>
-            </a:r>
-          </a:p>
-          <a:p>
-            <a:r>
-              <a:rPr sz="1100">
-                <a:solidFill>
-                  <a:srgbClr val="1F2A44"/>
-                </a:solidFill>
-                <a:latin typeface="Menlo"/>
-              </a:rPr>
-              <a:t>      │</a:t>
-            </a:r>
-          </a:p>
-          <a:p>
-            <a:r>
-              <a:rPr sz="1100">
-                <a:solidFill>
-                  <a:srgbClr val="1F2A44"/>
-                </a:solidFill>
-                <a:latin typeface="Menlo"/>
-              </a:rPr>
-              <a:t>      ▼</a:t>
-            </a:r>
-          </a:p>
-          <a:p>
-            <a:r>
-              <a:rPr sz="1100">
-                <a:solidFill>
-                  <a:srgbClr val="1F2A44"/>
-                </a:solidFill>
-                <a:latin typeface="Menlo"/>
-              </a:rPr>
-              <a:t>Human sign-off  ─▶  Manual PO to supplier  ─▶  ERP update  (existing workflow, unchanged)</a:t>
-            </a:r>
-          </a:p>
-        </p:txBody>
-      </p:sp>
-      <p:sp>
-        <p:nvSpPr>
-          <p:cNvPr id="7" name="TextBox 6"/>
+              <a:rPr sz="1100" i="1">
+                <a:solidFill>
+                  <a:srgbClr val="5A6A7A"/>
+                </a:solidFill>
+              </a:rPr>
+              <a:t>Every arrow is read-only against the ERP except the final step — a human places the PO through the existing process.</a:t>
+            </a:r>
+          </a:p>
+        </p:txBody>
+      </p:sp>
+      <p:sp>
+        <p:nvSpPr>
+          <p:cNvPr id="8" name="TextBox 7"/>
           <p:cNvSpPr txBox="1"/>
           <p:nvPr/>
         </p:nvSpPr>
         <p:spPr>
           <a:xfrm>
-            <a:off x="365760" y="6126480"/>
-            <a:ext cx="11430000" cy="365760"/>
+            <a:off x="457200" y="6492240"/>
+            <a:ext cx="11277295" cy="274320"/>
           </a:xfrm>
           <a:prstGeom prst="rect">
             <a:avLst/>
@@ -7333,27 +7273,111 @@
           </a:bodyPr>
           <a:lstStyle/>
           <a:p>
-            <a:r>
-              <a:rPr sz="1100" i="1">
+            <a:pPr algn="r"/>
+            <a:r>
+              <a:rPr sz="900">
                 <a:solidFill>
                   <a:srgbClr val="5A6A7A"/>
                 </a:solidFill>
               </a:rPr>
-              <a:t>Every arrow is read-only against the ERP except the final step — a human places the PO through the existing process.</a:t>
-            </a:r>
-          </a:p>
-        </p:txBody>
-      </p:sp>
-      <p:sp>
-        <p:nvSpPr>
-          <p:cNvPr id="8" name="TextBox 7"/>
+              <a:t>Atlas Paints &amp; Tools — AI Transformation Proposal  ·  17/26</a:t>
+            </a:r>
+          </a:p>
+        </p:txBody>
+      </p:sp>
+      <p:sp>
+        <p:nvSpPr>
+          <p:cNvPr id="100" name="card100"/>
+          <p:cNvSpPr/>
+          <p:nvPr/>
+        </p:nvSpPr>
+        <p:spPr>
+          <a:xfrm>
+            <a:off x="3175000" y="1397000"/>
+            <a:ext cx="5842000" cy="508000"/>
+          </a:xfrm>
+          <a:prstGeom prst="roundRect">
+            <a:avLst>
+              <a:gd name="adj" fmla="val 8000"/>
+            </a:avLst>
+          </a:prstGeom>
+          <a:solidFill>
+            <a:srgbClr val="E9EDF2"/>
+          </a:solidFill>
+          <a:ln w="12700">
+            <a:solidFill>
+              <a:srgbClr val="C7CFD9"/>
+            </a:solidFill>
+          </a:ln>
+        </p:spPr>
+        <p:txBody>
+          <a:bodyPr lIns="91440" tIns="45720" rIns="91440" bIns="45720" rtlCol="0" anchor="ctr">
+            <a:normAutofit lnSpcReduction="10000"/>
+          </a:bodyPr>
+          <a:lstStyle/>
+          <a:p>
+            <a:pPr algn="l"/>
+            <a:r>
+              <a:rPr lang="en-US" sz="1500" b="1" dirty="0">
+                <a:solidFill>
+                  <a:srgbClr val="1F2A44"/>
+                </a:solidFill>
+              </a:rPr>
+              <a:t>ERP — SQL, read-only</a:t>
+            </a:r>
+          </a:p>
+          <a:p>
+            <a:pPr algn="l"/>
+            <a:r>
+              <a:rPr lang="en-US" sz="1100" dirty="0">
+                <a:solidFill>
+                  <a:srgbClr val="1F2A44"/>
+                </a:solidFill>
+              </a:rPr>
+              <a:t>5 tables · 10+ yr history · ~200–500 active SKUs</a:t>
+            </a:r>
+          </a:p>
+        </p:txBody>
+      </p:sp>
+      <p:sp>
+        <p:nvSpPr>
+          <p:cNvPr id="101" name="arr101"/>
+          <p:cNvSpPr/>
+          <p:nvPr/>
+        </p:nvSpPr>
+        <p:spPr>
+          <a:xfrm>
+            <a:off x="6007100" y="1905000"/>
+            <a:ext cx="177800" cy="139700"/>
+          </a:xfrm>
+          <a:prstGeom prst="downArrow">
+            <a:avLst/>
+          </a:prstGeom>
+          <a:solidFill>
+            <a:srgbClr val="E8833A"/>
+          </a:solidFill>
+          <a:ln>
+            <a:noFill/>
+          </a:ln>
+        </p:spPr>
+        <p:txBody>
+          <a:bodyPr/>
+          <a:lstStyle/>
+          <a:p>
+            <a:endParaRPr/>
+          </a:p>
+        </p:txBody>
+      </p:sp>
+      <p:sp>
+        <p:nvSpPr>
+          <p:cNvPr id="102" name="lbl102"/>
           <p:cNvSpPr txBox="1"/>
           <p:nvPr/>
         </p:nvSpPr>
         <p:spPr>
           <a:xfrm>
-            <a:off x="457200" y="6492240"/>
-            <a:ext cx="11277295" cy="274320"/>
+            <a:off x="6248400" y="1860550"/>
+            <a:ext cx="2921000" cy="228600"/>
           </a:xfrm>
           <a:prstGeom prst="rect">
             <a:avLst/>
@@ -7361,24 +7385,528 @@
           <a:noFill/>
         </p:spPr>
         <p:txBody>
-          <a:bodyPr wrap="none">
-            <a:spAutoFit/>
+          <a:bodyPr lIns="0" tIns="0" rIns="0" bIns="0" rtlCol="0" anchor="ctr"/>
+          <a:lstStyle/>
+          <a:p>
+            <a:pPr algn="l"/>
+            <a:r>
+              <a:rPr lang="en-US" sz="1000" i="1" dirty="0">
+                <a:solidFill>
+                  <a:srgbClr val="6B7687"/>
+                </a:solidFill>
+              </a:rPr>
+              <a:t>weekly extract — SELECT only, no writes</a:t>
+            </a:r>
+          </a:p>
+        </p:txBody>
+      </p:sp>
+      <p:sp>
+        <p:nvSpPr>
+          <p:cNvPr id="103" name="card103"/>
+          <p:cNvSpPr/>
+          <p:nvPr/>
+        </p:nvSpPr>
+        <p:spPr>
+          <a:xfrm>
+            <a:off x="3175000" y="2044700"/>
+            <a:ext cx="5842000" cy="508000"/>
+          </a:xfrm>
+          <a:prstGeom prst="roundRect">
+            <a:avLst>
+              <a:gd name="adj" fmla="val 8000"/>
+            </a:avLst>
+          </a:prstGeom>
+          <a:solidFill>
+            <a:srgbClr val="E9EDF2"/>
+          </a:solidFill>
+          <a:ln w="12700">
+            <a:solidFill>
+              <a:srgbClr val="C7CFD9"/>
+            </a:solidFill>
+          </a:ln>
+        </p:spPr>
+        <p:txBody>
+          <a:bodyPr lIns="91440" tIns="45720" rIns="91440" bIns="45720" rtlCol="0" anchor="ctr">
+            <a:normAutofit lnSpcReduction="10000"/>
           </a:bodyPr>
           <a:lstStyle/>
           <a:p>
-            <a:pPr algn="r"/>
-            <a:r>
-              <a:rPr sz="900">
-                <a:solidFill>
-                  <a:srgbClr val="5A6A7A"/>
-                </a:solidFill>
-              </a:rPr>
-              <a:t>Atlas Paints &amp; Tools — AI Transformation Proposal  ·  17/26</a:t>
+            <a:pPr algn="l"/>
+            <a:r>
+              <a:rPr lang="en-US" sz="1500" b="1" dirty="0">
+                <a:solidFill>
+                  <a:srgbClr val="1F2A44"/>
+                </a:solidFill>
+              </a:rPr>
+              <a:t>Local SQLite cache (~10 MB)</a:t>
+            </a:r>
+          </a:p>
+          <a:p>
+            <a:pPr algn="l"/>
+            <a:r>
+              <a:rPr lang="en-US" sz="1100" dirty="0">
+                <a:solidFill>
+                  <a:srgbClr val="1F2A44"/>
+                </a:solidFill>
+              </a:rPr>
+              <a:t>Refreshed weekly on the on-prem server</a:t>
+            </a:r>
+          </a:p>
+        </p:txBody>
+      </p:sp>
+      <p:sp>
+        <p:nvSpPr>
+          <p:cNvPr id="104" name="arr104"/>
+          <p:cNvSpPr/>
+          <p:nvPr/>
+        </p:nvSpPr>
+        <p:spPr>
+          <a:xfrm>
+            <a:off x="6007100" y="2552700"/>
+            <a:ext cx="177800" cy="139700"/>
+          </a:xfrm>
+          <a:prstGeom prst="downArrow">
+            <a:avLst/>
+          </a:prstGeom>
+          <a:solidFill>
+            <a:srgbClr val="E8833A"/>
+          </a:solidFill>
+          <a:ln>
+            <a:noFill/>
+          </a:ln>
+        </p:spPr>
+        <p:txBody>
+          <a:bodyPr/>
+          <a:lstStyle/>
+          <a:p>
+            <a:endParaRPr/>
+          </a:p>
+        </p:txBody>
+      </p:sp>
+      <p:sp>
+        <p:nvSpPr>
+          <p:cNvPr id="105" name="card105"/>
+          <p:cNvSpPr/>
+          <p:nvPr/>
+        </p:nvSpPr>
+        <p:spPr>
+          <a:xfrm>
+            <a:off x="3175000" y="2692400"/>
+            <a:ext cx="5842000" cy="508000"/>
+          </a:xfrm>
+          <a:prstGeom prst="roundRect">
+            <a:avLst>
+              <a:gd name="adj" fmla="val 8000"/>
+            </a:avLst>
+          </a:prstGeom>
+          <a:solidFill>
+            <a:srgbClr val="E9EDF2"/>
+          </a:solidFill>
+          <a:ln w="12700">
+            <a:solidFill>
+              <a:srgbClr val="C7CFD9"/>
+            </a:solidFill>
+          </a:ln>
+        </p:spPr>
+        <p:txBody>
+          <a:bodyPr lIns="91440" tIns="45720" rIns="91440" bIns="45720" rtlCol="0" anchor="ctr">
+            <a:normAutofit lnSpcReduction="10000"/>
+          </a:bodyPr>
+          <a:lstStyle/>
+          <a:p>
+            <a:pPr algn="l"/>
+            <a:r>
+              <a:rPr lang="en-US" sz="1500" b="1" dirty="0">
+                <a:solidFill>
+                  <a:srgbClr val="1F2A44"/>
+                </a:solidFill>
+              </a:rPr>
+              <a:t>Forecasting engine</a:t>
+            </a:r>
+          </a:p>
+          <a:p>
+            <a:pPr algn="l"/>
+            <a:r>
+              <a:rPr lang="en-US" sz="1100" dirty="0">
+                <a:solidFill>
+                  <a:srgbClr val="1F2A44"/>
+                </a:solidFill>
+              </a:rPr>
+              <a:t>Moving avg + multiplicative seasonality (pandas + numpy)</a:t>
+            </a:r>
+          </a:p>
+        </p:txBody>
+      </p:sp>
+      <p:sp>
+        <p:nvSpPr>
+          <p:cNvPr id="106" name="arr106"/>
+          <p:cNvSpPr/>
+          <p:nvPr/>
+        </p:nvSpPr>
+        <p:spPr>
+          <a:xfrm>
+            <a:off x="6007100" y="3200400"/>
+            <a:ext cx="177800" cy="139700"/>
+          </a:xfrm>
+          <a:prstGeom prst="downArrow">
+            <a:avLst/>
+          </a:prstGeom>
+          <a:solidFill>
+            <a:srgbClr val="E8833A"/>
+          </a:solidFill>
+          <a:ln>
+            <a:noFill/>
+          </a:ln>
+        </p:spPr>
+        <p:txBody>
+          <a:bodyPr/>
+          <a:lstStyle/>
+          <a:p>
+            <a:endParaRPr/>
+          </a:p>
+        </p:txBody>
+      </p:sp>
+      <p:sp>
+        <p:nvSpPr>
+          <p:cNvPr id="107" name="lbl107"/>
+          <p:cNvSpPr txBox="1"/>
+          <p:nvPr/>
+        </p:nvSpPr>
+        <p:spPr>
+          <a:xfrm>
+            <a:off x="6248400" y="3155950"/>
+            <a:ext cx="2921000" cy="228600"/>
+          </a:xfrm>
+          <a:prstGeom prst="rect">
+            <a:avLst/>
+          </a:prstGeom>
+          <a:noFill/>
+        </p:spPr>
+        <p:txBody>
+          <a:bodyPr lIns="0" tIns="0" rIns="0" bIns="0" rtlCol="0" anchor="ctr"/>
+          <a:lstStyle/>
+          <a:p>
+            <a:pPr algn="l"/>
+            <a:r>
+              <a:rPr lang="en-US" sz="1000" i="1" dirty="0">
+                <a:solidFill>
+                  <a:srgbClr val="6B7687"/>
+                </a:solidFill>
+              </a:rPr>
+              <a:t>forecast + uncertainty + seasonal factor</a:t>
+            </a:r>
+          </a:p>
+        </p:txBody>
+      </p:sp>
+      <p:sp>
+        <p:nvSpPr>
+          <p:cNvPr id="108" name="card108"/>
+          <p:cNvSpPr/>
+          <p:nvPr/>
+        </p:nvSpPr>
+        <p:spPr>
+          <a:xfrm>
+            <a:off x="3175000" y="3340100"/>
+            <a:ext cx="5842000" cy="508000"/>
+          </a:xfrm>
+          <a:prstGeom prst="roundRect">
+            <a:avLst>
+              <a:gd name="adj" fmla="val 8000"/>
+            </a:avLst>
+          </a:prstGeom>
+          <a:solidFill>
+            <a:srgbClr val="E9EDF2"/>
+          </a:solidFill>
+          <a:ln w="12700">
+            <a:solidFill>
+              <a:srgbClr val="C7CFD9"/>
+            </a:solidFill>
+          </a:ln>
+        </p:spPr>
+        <p:txBody>
+          <a:bodyPr lIns="91440" tIns="45720" rIns="91440" bIns="45720" rtlCol="0" anchor="ctr">
+            <a:normAutofit lnSpcReduction="10000"/>
+          </a:bodyPr>
+          <a:lstStyle/>
+          <a:p>
+            <a:pPr algn="l"/>
+            <a:r>
+              <a:rPr lang="en-US" sz="1500" b="1" dirty="0">
+                <a:solidFill>
+                  <a:srgbClr val="1F2A44"/>
+                </a:solidFill>
+              </a:rPr>
+              <a:t>Reorder engine</a:t>
+            </a:r>
+          </a:p>
+          <a:p>
+            <a:pPr algn="l"/>
+            <a:r>
+              <a:rPr lang="en-US" sz="1100" dirty="0">
+                <a:solidFill>
+                  <a:srgbClr val="1F2A44"/>
+                </a:solidFill>
+              </a:rPr>
+              <a:t>Reorder point + buffer (ROP + safety stock)</a:t>
+            </a:r>
+          </a:p>
+        </p:txBody>
+      </p:sp>
+      <p:sp>
+        <p:nvSpPr>
+          <p:cNvPr id="109" name="arr109"/>
+          <p:cNvSpPr/>
+          <p:nvPr/>
+        </p:nvSpPr>
+        <p:spPr>
+          <a:xfrm>
+            <a:off x="6007100" y="3848100"/>
+            <a:ext cx="177800" cy="139700"/>
+          </a:xfrm>
+          <a:prstGeom prst="downArrow">
+            <a:avLst/>
+          </a:prstGeom>
+          <a:solidFill>
+            <a:srgbClr val="E8833A"/>
+          </a:solidFill>
+          <a:ln>
+            <a:noFill/>
+          </a:ln>
+        </p:spPr>
+        <p:txBody>
+          <a:bodyPr/>
+          <a:lstStyle/>
+          <a:p>
+            <a:endParaRPr/>
+          </a:p>
+        </p:txBody>
+      </p:sp>
+      <p:sp>
+        <p:nvSpPr>
+          <p:cNvPr id="110" name="card110"/>
+          <p:cNvSpPr/>
+          <p:nvPr/>
+        </p:nvSpPr>
+        <p:spPr>
+          <a:xfrm>
+            <a:off x="3175000" y="3987800"/>
+            <a:ext cx="5842000" cy="508000"/>
+          </a:xfrm>
+          <a:prstGeom prst="roundRect">
+            <a:avLst>
+              <a:gd name="adj" fmla="val 8000"/>
+            </a:avLst>
+          </a:prstGeom>
+          <a:solidFill>
+            <a:srgbClr val="FBEEE2"/>
+          </a:solidFill>
+          <a:ln w="12700">
+            <a:solidFill>
+              <a:srgbClr val="C7CFD9"/>
+            </a:solidFill>
+          </a:ln>
+        </p:spPr>
+        <p:txBody>
+          <a:bodyPr lIns="91440" tIns="45720" rIns="91440" bIns="45720" rtlCol="0" anchor="ctr">
+            <a:normAutofit lnSpcReduction="10000"/>
+          </a:bodyPr>
+          <a:lstStyle/>
+          <a:p>
+            <a:pPr algn="l"/>
+            <a:r>
+              <a:rPr lang="en-US" sz="1500" b="1" dirty="0">
+                <a:solidFill>
+                  <a:srgbClr val="E8833A"/>
+                </a:solidFill>
+              </a:rPr>
+              <a:t>LLM briefing (Claude Haiku)</a:t>
+            </a:r>
+          </a:p>
+          <a:p>
+            <a:pPr algn="l"/>
+            <a:r>
+              <a:rPr lang="en-US" sz="1100" dirty="0">
+                <a:solidFill>
+                  <a:srgbClr val="1F2A44"/>
+                </a:solidFill>
+              </a:rPr>
+              <a:t>Optional cloud step · offline template fallback · grounding check on every figure</a:t>
+            </a:r>
+          </a:p>
+        </p:txBody>
+      </p:sp>
+      <p:sp>
+        <p:nvSpPr>
+          <p:cNvPr id="111" name="arr111"/>
+          <p:cNvSpPr/>
+          <p:nvPr/>
+        </p:nvSpPr>
+        <p:spPr>
+          <a:xfrm>
+            <a:off x="6007100" y="4495800"/>
+            <a:ext cx="177800" cy="139700"/>
+          </a:xfrm>
+          <a:prstGeom prst="downArrow">
+            <a:avLst/>
+          </a:prstGeom>
+          <a:solidFill>
+            <a:srgbClr val="E8833A"/>
+          </a:solidFill>
+          <a:ln>
+            <a:noFill/>
+          </a:ln>
+        </p:spPr>
+        <p:txBody>
+          <a:bodyPr/>
+          <a:lstStyle/>
+          <a:p>
+            <a:endParaRPr/>
+          </a:p>
+        </p:txBody>
+      </p:sp>
+      <p:sp>
+        <p:nvSpPr>
+          <p:cNvPr id="112" name="card112"/>
+          <p:cNvSpPr/>
+          <p:nvPr/>
+        </p:nvSpPr>
+        <p:spPr>
+          <a:xfrm>
+            <a:off x="3175000" y="4635500"/>
+            <a:ext cx="5842000" cy="508000"/>
+          </a:xfrm>
+          <a:prstGeom prst="roundRect">
+            <a:avLst>
+              <a:gd name="adj" fmla="val 8000"/>
+            </a:avLst>
+          </a:prstGeom>
+          <a:solidFill>
+            <a:srgbClr val="E9EDF2"/>
+          </a:solidFill>
+          <a:ln w="12700">
+            <a:solidFill>
+              <a:srgbClr val="C7CFD9"/>
+            </a:solidFill>
+          </a:ln>
+        </p:spPr>
+        <p:txBody>
+          <a:bodyPr lIns="91440" tIns="45720" rIns="91440" bIns="45720" rtlCol="0" anchor="ctr">
+            <a:normAutofit lnSpcReduction="10000"/>
+          </a:bodyPr>
+          <a:lstStyle/>
+          <a:p>
+            <a:pPr algn="l"/>
+            <a:r>
+              <a:rPr lang="en-US" sz="1500" b="1" dirty="0">
+                <a:solidFill>
+                  <a:srgbClr val="1F2A44"/>
+                </a:solidFill>
+              </a:rPr>
+              <a:t>Streamlit UI (LAN-only)</a:t>
+            </a:r>
+          </a:p>
+          <a:p>
+            <a:pPr algn="l"/>
+            <a:r>
+              <a:rPr lang="en-US" sz="1100" dirty="0">
+                <a:solidFill>
+                  <a:srgbClr val="1F2A44"/>
+                </a:solidFill>
+              </a:rPr>
+              <a:t>Dashboard · SKU Drilldown · What-if · 1–3 concurrent users</a:t>
+            </a:r>
+          </a:p>
+        </p:txBody>
+      </p:sp>
+      <p:sp>
+        <p:nvSpPr>
+          <p:cNvPr id="113" name="arr113"/>
+          <p:cNvSpPr/>
+          <p:nvPr/>
+        </p:nvSpPr>
+        <p:spPr>
+          <a:xfrm>
+            <a:off x="6007100" y="5143500"/>
+            <a:ext cx="177800" cy="139700"/>
+          </a:xfrm>
+          <a:prstGeom prst="downArrow">
+            <a:avLst/>
+          </a:prstGeom>
+          <a:solidFill>
+            <a:srgbClr val="E8833A"/>
+          </a:solidFill>
+          <a:ln>
+            <a:noFill/>
+          </a:ln>
+        </p:spPr>
+        <p:txBody>
+          <a:bodyPr/>
+          <a:lstStyle/>
+          <a:p>
+            <a:endParaRPr/>
+          </a:p>
+        </p:txBody>
+      </p:sp>
+      <p:sp>
+        <p:nvSpPr>
+          <p:cNvPr id="114" name="card114"/>
+          <p:cNvSpPr/>
+          <p:nvPr/>
+        </p:nvSpPr>
+        <p:spPr>
+          <a:xfrm>
+            <a:off x="3175000" y="5283200"/>
+            <a:ext cx="5842000" cy="508000"/>
+          </a:xfrm>
+          <a:prstGeom prst="roundRect">
+            <a:avLst>
+              <a:gd name="adj" fmla="val 8000"/>
+            </a:avLst>
+          </a:prstGeom>
+          <a:solidFill>
+            <a:srgbClr val="DCE7DA"/>
+          </a:solidFill>
+          <a:ln w="12700">
+            <a:solidFill>
+              <a:srgbClr val="C7CFD9"/>
+            </a:solidFill>
+          </a:ln>
+        </p:spPr>
+        <p:txBody>
+          <a:bodyPr lIns="91440" tIns="45720" rIns="91440" bIns="45720" rtlCol="0" anchor="ctr">
+            <a:normAutofit lnSpcReduction="10000"/>
+          </a:bodyPr>
+          <a:lstStyle/>
+          <a:p>
+            <a:pPr algn="l"/>
+            <a:r>
+              <a:rPr lang="en-US" sz="1500" b="1" dirty="0">
+                <a:solidFill>
+                  <a:srgbClr val="2E5A33"/>
+                </a:solidFill>
+              </a:rPr>
+              <a:t>Human sign-off</a:t>
+            </a:r>
+          </a:p>
+          <a:p>
+            <a:pPr algn="l"/>
+            <a:r>
+              <a:rPr lang="en-US" sz="1100" dirty="0">
+                <a:solidFill>
+                  <a:srgbClr val="1F2A44"/>
+                </a:solidFill>
+              </a:rPr>
+              <a:t>Manual PO to supplier → ERP update (existing workflow, unchanged)</a:t>
             </a:r>
           </a:p>
         </p:txBody>
       </p:sp>
     </p:spTree>
+    <p:extLst>
+      <p:ext uri="{BB962C8B-B14F-4D97-AF65-F5344CB8AC3E}">
+        <p14:creationId xmlns:p14="http://schemas.microsoft.com/office/powerpoint/2010/main" val="1594724254"/>
+      </p:ext>
+    </p:extLst>
   </p:cSld>
   <p:clrMapOvr>
     <a:masterClrMapping/>
@@ -7571,210 +8099,14 @@
       </p:sp>
       <p:sp>
         <p:nvSpPr>
-          <p:cNvPr id="6" name="TextBox 5"/>
-          <p:cNvSpPr txBox="1"/>
-          <p:nvPr/>
-        </p:nvSpPr>
-        <p:spPr>
-          <a:xfrm>
-            <a:off x="365760" y="1325880"/>
-            <a:ext cx="11430000" cy="3931920"/>
-          </a:xfrm>
-          <a:prstGeom prst="rect">
-            <a:avLst/>
-          </a:prstGeom>
-          <a:noFill/>
-        </p:spPr>
-        <p:txBody>
-          <a:bodyPr wrap="square">
-            <a:spAutoFit/>
-          </a:bodyPr>
-          <a:lstStyle/>
-          <a:p>
-            <a:r>
-              <a:rPr sz="1000">
-                <a:solidFill>
-                  <a:srgbClr val="1F2A44"/>
-                </a:solidFill>
-                <a:latin typeface="Menlo"/>
-              </a:rPr>
-              <a:t>┌─────────────────────────── Atlas on-prem server ──────────────────────────┐</a:t>
-            </a:r>
-          </a:p>
-          <a:p>
-            <a:r>
-              <a:rPr sz="1000">
-                <a:solidFill>
-                  <a:srgbClr val="1F2A44"/>
-                </a:solidFill>
-                <a:latin typeface="Menlo"/>
-              </a:rPr>
-              <a:t>│                                                                              │</a:t>
-            </a:r>
-          </a:p>
-          <a:p>
-            <a:r>
-              <a:rPr sz="1000">
-                <a:solidFill>
-                  <a:srgbClr val="1F2A44"/>
-                </a:solidFill>
-                <a:latin typeface="Menlo"/>
-              </a:rPr>
-              <a:t>│   ERP DB  ──▶  Python service  (venv, scheduled)  ──▶  SQLite cache         │</a:t>
-            </a:r>
-          </a:p>
-          <a:p>
-            <a:r>
-              <a:rPr sz="1000">
-                <a:solidFill>
-                  <a:srgbClr val="1F2A44"/>
-                </a:solidFill>
-                <a:latin typeface="Menlo"/>
-              </a:rPr>
-              <a:t>│   MSSQL/       • extract   • forecasting                                    │</a:t>
-            </a:r>
-          </a:p>
-          <a:p>
-            <a:r>
-              <a:rPr sz="1000">
-                <a:solidFill>
-                  <a:srgbClr val="1F2A44"/>
-                </a:solidFill>
-                <a:latin typeface="Menlo"/>
-              </a:rPr>
-              <a:t>│   custom       • reorder   • explain                                        │</a:t>
-            </a:r>
-          </a:p>
-          <a:p>
-            <a:r>
-              <a:rPr sz="1000">
-                <a:solidFill>
-                  <a:srgbClr val="1F2A44"/>
-                </a:solidFill>
-                <a:latin typeface="Menlo"/>
-              </a:rPr>
-              <a:t>│                       │                                                     │</a:t>
-            </a:r>
-          </a:p>
-          <a:p>
-            <a:r>
-              <a:rPr sz="1000">
-                <a:solidFill>
-                  <a:srgbClr val="1F2A44"/>
-                </a:solidFill>
-                <a:latin typeface="Menlo"/>
-              </a:rPr>
-              <a:t>│                       ▼                                                     │</a:t>
-            </a:r>
-          </a:p>
-          <a:p>
-            <a:r>
-              <a:rPr sz="1000">
-                <a:solidFill>
-                  <a:srgbClr val="1F2A44"/>
-                </a:solidFill>
-                <a:latin typeface="Menlo"/>
-              </a:rPr>
-              <a:t>│              Streamlit app  (port 8501, LAN-only)                           │</a:t>
-            </a:r>
-          </a:p>
-          <a:p>
-            <a:r>
-              <a:rPr sz="1000">
-                <a:solidFill>
-                  <a:srgbClr val="1F2A44"/>
-                </a:solidFill>
-                <a:latin typeface="Menlo"/>
-              </a:rPr>
-              <a:t>│                       │                                                     │</a:t>
-            </a:r>
-          </a:p>
-          <a:p>
-            <a:r>
-              <a:rPr sz="1000">
-                <a:solidFill>
-                  <a:srgbClr val="1F2A44"/>
-                </a:solidFill>
-                <a:latin typeface="Menlo"/>
-              </a:rPr>
-              <a:t>└───────────────────────┼─────────────────────────────────────────────────────┘</a:t>
-            </a:r>
-          </a:p>
-          <a:p>
-            <a:r>
-              <a:rPr sz="1000">
-                <a:solidFill>
-                  <a:srgbClr val="1F2A44"/>
-                </a:solidFill>
-                <a:latin typeface="Menlo"/>
-              </a:rPr>
-              <a:t>                        │  LAN</a:t>
-            </a:r>
-          </a:p>
-          <a:p>
-            <a:r>
-              <a:rPr sz="1000">
-                <a:solidFill>
-                  <a:srgbClr val="1F2A44"/>
-                </a:solidFill>
-                <a:latin typeface="Menlo"/>
-              </a:rPr>
-              <a:t>                        ▼</a:t>
-            </a:r>
-          </a:p>
-          <a:p>
-            <a:r>
-              <a:rPr sz="1000">
-                <a:solidFill>
-                  <a:srgbClr val="1F2A44"/>
-                </a:solidFill>
-                <a:latin typeface="Menlo"/>
-              </a:rPr>
-              <a:t>              GM + Procurement browsers</a:t>
-            </a:r>
-          </a:p>
-          <a:p>
-            <a:endParaRPr sz="1000">
-              <a:solidFill>
-                <a:srgbClr val="1F2A44"/>
-              </a:solidFill>
-              <a:latin typeface="Menlo"/>
-            </a:endParaRPr>
-          </a:p>
-          <a:p>
-            <a:r>
-              <a:rPr sz="1000">
-                <a:solidFill>
-                  <a:srgbClr val="1F2A44"/>
-                </a:solidFill>
-                <a:latin typeface="Menlo"/>
-              </a:rPr>
-              <a:t>OPTIONAL  ·  Python service  ── HTTPS ──▶  Anthropic API   (weekly briefing + explanations)</a:t>
-            </a:r>
-          </a:p>
-          <a:p>
-            <a:r>
-              <a:rPr sz="1000">
-                <a:solidFill>
-                  <a:srgbClr val="1F2A44"/>
-                </a:solidFill>
-                <a:latin typeface="Menlo"/>
-              </a:rPr>
-              <a:t>             grounding-checked; falls back to deterministic template whenever unreachable</a:t>
-            </a:r>
-          </a:p>
-        </p:txBody>
-      </p:sp>
-      <p:sp>
-        <p:nvSpPr>
           <p:cNvPr id="7" name="TextBox 6"/>
           <p:cNvSpPr txBox="1"/>
           <p:nvPr/>
         </p:nvSpPr>
         <p:spPr>
           <a:xfrm>
-            <a:off x="5349240" y="548640"/>
-            <a:ext cx="11155680" cy="1371600"/>
+            <a:off x="457200" y="5486400"/>
+            <a:ext cx="11277600" cy="1066800"/>
           </a:xfrm>
           <a:prstGeom prst="rect">
             <a:avLst/>
@@ -7867,7 +8199,602 @@
           </a:p>
         </p:txBody>
       </p:sp>
+      <p:sp>
+        <p:nvSpPr>
+          <p:cNvPr id="200" name="box200"/>
+          <p:cNvSpPr/>
+          <p:nvPr/>
+        </p:nvSpPr>
+        <p:spPr>
+          <a:xfrm>
+            <a:off x="508000" y="1320800"/>
+            <a:ext cx="7620000" cy="3458446"/>
+          </a:xfrm>
+          <a:prstGeom prst="roundRect">
+            <a:avLst>
+              <a:gd name="adj" fmla="val 10000"/>
+            </a:avLst>
+          </a:prstGeom>
+          <a:solidFill>
+            <a:srgbClr val="F4F7FA"/>
+          </a:solidFill>
+          <a:ln w="12700">
+            <a:solidFill>
+              <a:srgbClr val="9FB0C3"/>
+            </a:solidFill>
+          </a:ln>
+        </p:spPr>
+        <p:txBody>
+          <a:bodyPr lIns="64008" tIns="32004" rIns="64008" bIns="32004" rtlCol="0" anchor="ctr">
+            <a:normAutofit/>
+          </a:bodyPr>
+          <a:lstStyle/>
+          <a:p>
+            <a:pPr algn="ctr"/>
+            <a:endParaRPr/>
+          </a:p>
+        </p:txBody>
+      </p:sp>
+      <p:sp>
+        <p:nvSpPr>
+          <p:cNvPr id="201" name="lb201"/>
+          <p:cNvSpPr txBox="1"/>
+          <p:nvPr/>
+        </p:nvSpPr>
+        <p:spPr>
+          <a:xfrm>
+            <a:off x="711200" y="1426670"/>
+            <a:ext cx="3556000" cy="282322"/>
+          </a:xfrm>
+          <a:prstGeom prst="rect">
+            <a:avLst/>
+          </a:prstGeom>
+          <a:noFill/>
+        </p:spPr>
+        <p:txBody>
+          <a:bodyPr lIns="0" tIns="0" rIns="0" bIns="0" rtlCol="0" anchor="ctr"/>
+          <a:lstStyle/>
+          <a:p>
+            <a:pPr algn="l"/>
+            <a:r>
+              <a:rPr lang="en-US" sz="1100" i="1" dirty="0">
+                <a:solidFill>
+                  <a:srgbClr val="5A6A7A"/>
+                </a:solidFill>
+              </a:rPr>
+              <a:t>Atlas on-prem server</a:t>
+            </a:r>
+          </a:p>
+        </p:txBody>
+      </p:sp>
+      <p:sp>
+        <p:nvSpPr>
+          <p:cNvPr id="202" name="box202"/>
+          <p:cNvSpPr/>
+          <p:nvPr/>
+        </p:nvSpPr>
+        <p:spPr>
+          <a:xfrm>
+            <a:off x="762000" y="2061895"/>
+            <a:ext cx="1905000" cy="1235159"/>
+          </a:xfrm>
+          <a:prstGeom prst="roundRect">
+            <a:avLst>
+              <a:gd name="adj" fmla="val 10000"/>
+            </a:avLst>
+          </a:prstGeom>
+          <a:solidFill>
+            <a:srgbClr val="E9EDF2"/>
+          </a:solidFill>
+          <a:ln w="12700">
+            <a:solidFill>
+              <a:srgbClr val="C7CFD9"/>
+            </a:solidFill>
+          </a:ln>
+        </p:spPr>
+        <p:txBody>
+          <a:bodyPr lIns="64008" tIns="32004" rIns="64008" bIns="32004" rtlCol="0" anchor="ctr">
+            <a:normAutofit/>
+          </a:bodyPr>
+          <a:lstStyle/>
+          <a:p>
+            <a:pPr algn="ctr"/>
+            <a:r>
+              <a:rPr lang="en-US" sz="1300" b="1" dirty="0">
+                <a:solidFill>
+                  <a:srgbClr val="1F2A44"/>
+                </a:solidFill>
+              </a:rPr>
+              <a:t>ERP DB</a:t>
+            </a:r>
+          </a:p>
+          <a:p>
+            <a:pPr algn="ctr"/>
+            <a:r>
+              <a:rPr lang="en-US" sz="1000" dirty="0">
+                <a:solidFill>
+                  <a:srgbClr val="1F2A44"/>
+                </a:solidFill>
+              </a:rPr>
+              <a:t>MSSQL / custom</a:t>
+            </a:r>
+          </a:p>
+        </p:txBody>
+      </p:sp>
+      <p:sp>
+        <p:nvSpPr>
+          <p:cNvPr id="203" name="box203"/>
+          <p:cNvSpPr/>
+          <p:nvPr/>
+        </p:nvSpPr>
+        <p:spPr>
+          <a:xfrm>
+            <a:off x="3149600" y="2061895"/>
+            <a:ext cx="2336800" cy="1235159"/>
+          </a:xfrm>
+          <a:prstGeom prst="roundRect">
+            <a:avLst>
+              <a:gd name="adj" fmla="val 10000"/>
+            </a:avLst>
+          </a:prstGeom>
+          <a:solidFill>
+            <a:srgbClr val="FBEEE2"/>
+          </a:solidFill>
+          <a:ln w="12700">
+            <a:solidFill>
+              <a:srgbClr val="E8833A"/>
+            </a:solidFill>
+          </a:ln>
+        </p:spPr>
+        <p:txBody>
+          <a:bodyPr lIns="64008" tIns="32004" rIns="64008" bIns="32004" rtlCol="0" anchor="ctr">
+            <a:normAutofit/>
+          </a:bodyPr>
+          <a:lstStyle/>
+          <a:p>
+            <a:pPr algn="ctr"/>
+            <a:r>
+              <a:rPr lang="en-US" sz="1300" b="1" dirty="0">
+                <a:solidFill>
+                  <a:srgbClr val="1F2A44"/>
+                </a:solidFill>
+              </a:rPr>
+              <a:t>Python service</a:t>
+            </a:r>
+          </a:p>
+          <a:p>
+            <a:pPr algn="ctr"/>
+            <a:r>
+              <a:rPr lang="en-US" sz="1000" dirty="0">
+                <a:solidFill>
+                  <a:srgbClr val="1F2A44"/>
+                </a:solidFill>
+              </a:rPr>
+              <a:t>extract · forecast · reorder · explain</a:t>
+            </a:r>
+          </a:p>
+        </p:txBody>
+      </p:sp>
+      <p:sp>
+        <p:nvSpPr>
+          <p:cNvPr id="204" name="box204"/>
+          <p:cNvSpPr/>
+          <p:nvPr/>
+        </p:nvSpPr>
+        <p:spPr>
+          <a:xfrm>
+            <a:off x="5969000" y="2061895"/>
+            <a:ext cx="1905000" cy="1235159"/>
+          </a:xfrm>
+          <a:prstGeom prst="roundRect">
+            <a:avLst>
+              <a:gd name="adj" fmla="val 10000"/>
+            </a:avLst>
+          </a:prstGeom>
+          <a:solidFill>
+            <a:srgbClr val="E9EDF2"/>
+          </a:solidFill>
+          <a:ln w="12700">
+            <a:solidFill>
+              <a:srgbClr val="C7CFD9"/>
+            </a:solidFill>
+          </a:ln>
+        </p:spPr>
+        <p:txBody>
+          <a:bodyPr lIns="64008" tIns="32004" rIns="64008" bIns="32004" rtlCol="0" anchor="ctr">
+            <a:normAutofit/>
+          </a:bodyPr>
+          <a:lstStyle/>
+          <a:p>
+            <a:pPr algn="ctr"/>
+            <a:r>
+              <a:rPr lang="en-US" sz="1300" b="1" dirty="0">
+                <a:solidFill>
+                  <a:srgbClr val="1F2A44"/>
+                </a:solidFill>
+              </a:rPr>
+              <a:t>SQLite cache</a:t>
+            </a:r>
+          </a:p>
+          <a:p>
+            <a:pPr algn="ctr"/>
+            <a:r>
+              <a:rPr lang="en-US" sz="1000" dirty="0">
+                <a:solidFill>
+                  <a:srgbClr val="1F2A44"/>
+                </a:solidFill>
+              </a:rPr>
+              <a:t>venv, scheduled</a:t>
+            </a:r>
+          </a:p>
+        </p:txBody>
+      </p:sp>
+      <p:sp>
+        <p:nvSpPr>
+          <p:cNvPr id="205" name="ar205"/>
+          <p:cNvSpPr/>
+          <p:nvPr/>
+        </p:nvSpPr>
+        <p:spPr>
+          <a:xfrm>
+            <a:off x="2692400" y="2503023"/>
+            <a:ext cx="431800" cy="352902"/>
+          </a:xfrm>
+          <a:prstGeom prst="rightArrow">
+            <a:avLst/>
+          </a:prstGeom>
+          <a:solidFill>
+            <a:srgbClr val="E8833A"/>
+          </a:solidFill>
+          <a:ln>
+            <a:noFill/>
+          </a:ln>
+        </p:spPr>
+        <p:txBody>
+          <a:bodyPr/>
+          <a:lstStyle/>
+          <a:p>
+            <a:endParaRPr/>
+          </a:p>
+        </p:txBody>
+      </p:sp>
+      <p:sp>
+        <p:nvSpPr>
+          <p:cNvPr id="206" name="ar206"/>
+          <p:cNvSpPr/>
+          <p:nvPr/>
+        </p:nvSpPr>
+        <p:spPr>
+          <a:xfrm>
+            <a:off x="5511800" y="2503023"/>
+            <a:ext cx="431800" cy="352902"/>
+          </a:xfrm>
+          <a:prstGeom prst="rightArrow">
+            <a:avLst/>
+          </a:prstGeom>
+          <a:solidFill>
+            <a:srgbClr val="E8833A"/>
+          </a:solidFill>
+          <a:ln>
+            <a:noFill/>
+          </a:ln>
+        </p:spPr>
+        <p:txBody>
+          <a:bodyPr/>
+          <a:lstStyle/>
+          <a:p>
+            <a:endParaRPr/>
+          </a:p>
+        </p:txBody>
+      </p:sp>
+      <p:sp>
+        <p:nvSpPr>
+          <p:cNvPr id="207" name="ar207"/>
+          <p:cNvSpPr/>
+          <p:nvPr/>
+        </p:nvSpPr>
+        <p:spPr>
+          <a:xfrm>
+            <a:off x="4229100" y="3332345"/>
+            <a:ext cx="177800" cy="317612"/>
+          </a:xfrm>
+          <a:prstGeom prst="downArrow">
+            <a:avLst/>
+          </a:prstGeom>
+          <a:solidFill>
+            <a:srgbClr val="E8833A"/>
+          </a:solidFill>
+          <a:ln>
+            <a:noFill/>
+          </a:ln>
+        </p:spPr>
+        <p:txBody>
+          <a:bodyPr/>
+          <a:lstStyle/>
+          <a:p>
+            <a:endParaRPr/>
+          </a:p>
+        </p:txBody>
+      </p:sp>
+      <p:sp>
+        <p:nvSpPr>
+          <p:cNvPr id="208" name="box208"/>
+          <p:cNvSpPr/>
+          <p:nvPr/>
+        </p:nvSpPr>
+        <p:spPr>
+          <a:xfrm>
+            <a:off x="1905000" y="3685247"/>
+            <a:ext cx="4826000" cy="846966"/>
+          </a:xfrm>
+          <a:prstGeom prst="roundRect">
+            <a:avLst>
+              <a:gd name="adj" fmla="val 10000"/>
+            </a:avLst>
+          </a:prstGeom>
+          <a:solidFill>
+            <a:srgbClr val="E9EDF2"/>
+          </a:solidFill>
+          <a:ln w="12700">
+            <a:solidFill>
+              <a:srgbClr val="C7CFD9"/>
+            </a:solidFill>
+          </a:ln>
+        </p:spPr>
+        <p:txBody>
+          <a:bodyPr lIns="64008" tIns="32004" rIns="64008" bIns="32004" rtlCol="0" anchor="ctr">
+            <a:normAutofit/>
+          </a:bodyPr>
+          <a:lstStyle/>
+          <a:p>
+            <a:pPr algn="ctr"/>
+            <a:r>
+              <a:rPr lang="en-US" sz="1300" b="1" dirty="0">
+                <a:solidFill>
+                  <a:srgbClr val="1F2A44"/>
+                </a:solidFill>
+              </a:rPr>
+              <a:t>Streamlit app</a:t>
+            </a:r>
+          </a:p>
+          <a:p>
+            <a:pPr algn="ctr"/>
+            <a:r>
+              <a:rPr lang="en-US" sz="1000" dirty="0">
+                <a:solidFill>
+                  <a:srgbClr val="1F2A44"/>
+                </a:solidFill>
+              </a:rPr>
+              <a:t>port 8501 · LAN-only</a:t>
+            </a:r>
+          </a:p>
+        </p:txBody>
+      </p:sp>
+      <p:sp>
+        <p:nvSpPr>
+          <p:cNvPr id="209" name="ar209"/>
+          <p:cNvSpPr/>
+          <p:nvPr/>
+        </p:nvSpPr>
+        <p:spPr>
+          <a:xfrm>
+            <a:off x="4229100" y="4532214"/>
+            <a:ext cx="177800" cy="211741"/>
+          </a:xfrm>
+          <a:prstGeom prst="downArrow">
+            <a:avLst/>
+          </a:prstGeom>
+          <a:solidFill>
+            <a:srgbClr val="9FB0C3"/>
+          </a:solidFill>
+          <a:ln>
+            <a:noFill/>
+          </a:ln>
+        </p:spPr>
+        <p:txBody>
+          <a:bodyPr/>
+          <a:lstStyle/>
+          <a:p>
+            <a:endParaRPr/>
+          </a:p>
+        </p:txBody>
+      </p:sp>
+      <p:sp>
+        <p:nvSpPr>
+          <p:cNvPr id="210" name="lb210"/>
+          <p:cNvSpPr txBox="1"/>
+          <p:nvPr/>
+        </p:nvSpPr>
+        <p:spPr>
+          <a:xfrm>
+            <a:off x="4406900" y="4496923"/>
+            <a:ext cx="1016000" cy="282322"/>
+          </a:xfrm>
+          <a:prstGeom prst="rect">
+            <a:avLst/>
+          </a:prstGeom>
+          <a:noFill/>
+        </p:spPr>
+        <p:txBody>
+          <a:bodyPr lIns="0" tIns="0" rIns="0" bIns="0" rtlCol="0" anchor="ctr"/>
+          <a:lstStyle/>
+          <a:p>
+            <a:pPr algn="l"/>
+            <a:r>
+              <a:rPr lang="en-US" sz="1000" i="1" dirty="0">
+                <a:solidFill>
+                  <a:srgbClr val="6B7687"/>
+                </a:solidFill>
+              </a:rPr>
+              <a:t>LAN</a:t>
+            </a:r>
+          </a:p>
+        </p:txBody>
+      </p:sp>
+      <p:sp>
+        <p:nvSpPr>
+          <p:cNvPr id="211" name="box211"/>
+          <p:cNvSpPr/>
+          <p:nvPr/>
+        </p:nvSpPr>
+        <p:spPr>
+          <a:xfrm>
+            <a:off x="1905000" y="4779246"/>
+            <a:ext cx="4826000" cy="529353"/>
+          </a:xfrm>
+          <a:prstGeom prst="roundRect">
+            <a:avLst>
+              <a:gd name="adj" fmla="val 10000"/>
+            </a:avLst>
+          </a:prstGeom>
+          <a:solidFill>
+            <a:srgbClr val="EAF0EA"/>
+          </a:solidFill>
+          <a:ln w="12700">
+            <a:solidFill>
+              <a:srgbClr val="9DBBA0"/>
+            </a:solidFill>
+          </a:ln>
+        </p:spPr>
+        <p:txBody>
+          <a:bodyPr lIns="64008" tIns="32004" rIns="64008" bIns="32004" rtlCol="0" anchor="ctr">
+            <a:normAutofit/>
+          </a:bodyPr>
+          <a:lstStyle/>
+          <a:p>
+            <a:pPr algn="ctr"/>
+            <a:r>
+              <a:rPr lang="en-US" sz="1300" b="1" dirty="0">
+                <a:solidFill>
+                  <a:srgbClr val="2E5A33"/>
+                </a:solidFill>
+              </a:rPr>
+              <a:t>GM + Procurement browsers</a:t>
+            </a:r>
+          </a:p>
+        </p:txBody>
+      </p:sp>
+      <p:sp>
+        <p:nvSpPr>
+          <p:cNvPr id="212" name="box212"/>
+          <p:cNvSpPr/>
+          <p:nvPr/>
+        </p:nvSpPr>
+        <p:spPr>
+          <a:xfrm>
+            <a:off x="8534400" y="2061895"/>
+            <a:ext cx="3124200" cy="1235159"/>
+          </a:xfrm>
+          <a:prstGeom prst="roundRect">
+            <a:avLst>
+              <a:gd name="adj" fmla="val 10000"/>
+            </a:avLst>
+          </a:prstGeom>
+          <a:solidFill>
+            <a:srgbClr val="FBEEE2"/>
+          </a:solidFill>
+          <a:ln w="12700">
+            <a:solidFill>
+              <a:srgbClr val="E8833A"/>
+            </a:solidFill>
+          </a:ln>
+        </p:spPr>
+        <p:txBody>
+          <a:bodyPr lIns="64008" tIns="32004" rIns="64008" bIns="32004" rtlCol="0" anchor="ctr">
+            <a:normAutofit/>
+          </a:bodyPr>
+          <a:lstStyle/>
+          <a:p>
+            <a:pPr algn="ctr"/>
+            <a:r>
+              <a:rPr lang="en-US" sz="1300" b="1" dirty="0">
+                <a:solidFill>
+                  <a:srgbClr val="E8833A"/>
+                </a:solidFill>
+              </a:rPr>
+              <a:t>Anthropic API  (optional)</a:t>
+            </a:r>
+          </a:p>
+          <a:p>
+            <a:pPr algn="ctr"/>
+            <a:r>
+              <a:rPr lang="en-US" sz="1000" dirty="0">
+                <a:solidFill>
+                  <a:srgbClr val="1F2A44"/>
+                </a:solidFill>
+              </a:rPr>
+              <a:t>weekly briefing + per-SKU explanations · grounding-checked · offline template fallback</a:t>
+            </a:r>
+          </a:p>
+        </p:txBody>
+      </p:sp>
+      <p:sp>
+        <p:nvSpPr>
+          <p:cNvPr id="213" name="ar213"/>
+          <p:cNvSpPr/>
+          <p:nvPr/>
+        </p:nvSpPr>
+        <p:spPr>
+          <a:xfrm>
+            <a:off x="7899400" y="2538314"/>
+            <a:ext cx="609600" cy="282322"/>
+          </a:xfrm>
+          <a:prstGeom prst="rightArrow">
+            <a:avLst/>
+          </a:prstGeom>
+          <a:solidFill>
+            <a:srgbClr val="E8833A"/>
+          </a:solidFill>
+          <a:ln>
+            <a:noFill/>
+          </a:ln>
+        </p:spPr>
+        <p:txBody>
+          <a:bodyPr/>
+          <a:lstStyle/>
+          <a:p>
+            <a:endParaRPr/>
+          </a:p>
+        </p:txBody>
+      </p:sp>
+      <p:sp>
+        <p:nvSpPr>
+          <p:cNvPr id="214" name="lb214"/>
+          <p:cNvSpPr txBox="1"/>
+          <p:nvPr/>
+        </p:nvSpPr>
+        <p:spPr>
+          <a:xfrm>
+            <a:off x="8534400" y="1744283"/>
+            <a:ext cx="3124200" cy="282322"/>
+          </a:xfrm>
+          <a:prstGeom prst="rect">
+            <a:avLst/>
+          </a:prstGeom>
+          <a:noFill/>
+        </p:spPr>
+        <p:txBody>
+          <a:bodyPr lIns="0" tIns="0" rIns="0" bIns="0" rtlCol="0" anchor="ctr"/>
+          <a:lstStyle/>
+          <a:p>
+            <a:pPr algn="l"/>
+            <a:r>
+              <a:rPr lang="en-US" sz="1000" i="1" dirty="0">
+                <a:solidFill>
+                  <a:srgbClr val="6B7687"/>
+                </a:solidFill>
+              </a:rPr>
+              <a:t>HTTPS · optional</a:t>
+            </a:r>
+          </a:p>
+        </p:txBody>
+      </p:sp>
     </p:spTree>
+    <p:extLst>
+      <p:ext uri="{BB962C8B-B14F-4D97-AF65-F5344CB8AC3E}">
+        <p14:creationId xmlns:p14="http://schemas.microsoft.com/office/powerpoint/2010/main" val="936883247"/>
+      </p:ext>
+    </p:extLst>
   </p:cSld>
   <p:clrMapOvr>
     <a:masterClrMapping/>
@@ -9027,7 +9954,7 @@
         </p:nvGraphicFramePr>
         <p:xfrm>
           <a:off x="228600" y="1188720"/>
-          <a:ext cx="11731752" cy="5303520"/>
+          <a:ext cx="11731752" cy="5308600"/>
         </p:xfrm>
         <a:graphic>
           <a:graphicData uri="http://schemas.openxmlformats.org/drawingml/2006/table">
@@ -10771,8 +11698,8 @@
         </p:nvSpPr>
         <p:spPr>
           <a:xfrm>
-            <a:off x="5212080" y="548640"/>
-            <a:ext cx="11155680" cy="365760"/>
+            <a:off x="457200" y="5130800"/>
+            <a:ext cx="11277600" cy="304800"/>
           </a:xfrm>
           <a:prstGeom prst="rect">
             <a:avLst/>
@@ -10804,8 +11731,8 @@
         </p:nvSpPr>
         <p:spPr>
           <a:xfrm>
-            <a:off x="5212080" y="1005840"/>
-            <a:ext cx="11155680" cy="1005840"/>
+            <a:off x="457200" y="5461000"/>
+            <a:ext cx="11277600" cy="990600"/>
           </a:xfrm>
           <a:prstGeom prst="rect">
             <a:avLst/>
@@ -11097,7 +12024,7 @@
         </p:nvSpPr>
         <p:spPr>
           <a:xfrm>
-            <a:off x="1097280" y="1005840"/>
+            <a:off x="457200" y="1211580"/>
             <a:ext cx="5669280" cy="4846320"/>
           </a:xfrm>
           <a:prstGeom prst="rect">
@@ -11117,7 +12044,7 @@
               </a:spcAft>
             </a:pPr>
             <a:r>
-              <a:rPr sz="1200">
+              <a:rPr sz="1200" dirty="0">
                 <a:solidFill>
                   <a:srgbClr val="1F2A44"/>
                 </a:solidFill>
@@ -11132,12 +12059,28 @@
               </a:spcAft>
             </a:pPr>
             <a:r>
-              <a:rPr sz="1200">
+              <a:rPr sz="1200" dirty="0">
                 <a:solidFill>
                   <a:srgbClr val="1F2A44"/>
                 </a:solidFill>
               </a:rPr>
-              <a:t>• Backtest evidence: list of historical stockouts the system would have pre-flagged, with the PO date it would have suggested.</a:t>
+              <a:t>• </a:t>
+            </a:r>
+            <a:r>
+              <a:rPr sz="1200" dirty="0" err="1">
+                <a:solidFill>
+                  <a:srgbClr val="1F2A44"/>
+                </a:solidFill>
+              </a:rPr>
+              <a:t>Backtest</a:t>
+            </a:r>
+            <a:r>
+              <a:rPr sz="1200" dirty="0">
+                <a:solidFill>
+                  <a:srgbClr val="1F2A44"/>
+                </a:solidFill>
+              </a:rPr>
+              <a:t> evidence: list of historical stockouts the system would have pre-flagged, with the PO date it would have suggested.</a:t>
             </a:r>
           </a:p>
           <a:p>
@@ -11147,7 +12090,7 @@
               </a:spcAft>
             </a:pPr>
             <a:r>
-              <a:rPr sz="1200">
+              <a:rPr sz="1200" dirty="0">
                 <a:solidFill>
                   <a:srgbClr val="1F2A44"/>
                 </a:solidFill>
@@ -11162,7 +12105,7 @@
               </a:spcAft>
             </a:pPr>
             <a:r>
-              <a:rPr sz="1200">
+              <a:rPr sz="1200" dirty="0">
                 <a:solidFill>
                   <a:srgbClr val="1F2A44"/>
                 </a:solidFill>
@@ -11177,7 +12120,7 @@
               </a:spcAft>
             </a:pPr>
             <a:r>
-              <a:rPr sz="1200">
+              <a:rPr sz="1200" dirty="0">
                 <a:solidFill>
                   <a:srgbClr val="1F2A44"/>
                 </a:solidFill>
@@ -11242,8 +12185,8 @@
         </p:nvSpPr>
         <p:spPr>
           <a:xfrm>
-            <a:off x="6583680" y="1234440"/>
-            <a:ext cx="5029200" cy="5029200"/>
+            <a:off x="6766560" y="1618488"/>
+            <a:ext cx="4698609" cy="2154436"/>
           </a:xfrm>
           <a:prstGeom prst="rect">
             <a:avLst/>
@@ -11257,7 +12200,7 @@
           <a:lstStyle/>
           <a:p>
             <a:r>
-              <a:rPr sz="1300" b="1">
+              <a:rPr sz="1300" b="1" dirty="0">
                 <a:solidFill>
                   <a:srgbClr val="1F2A44"/>
                 </a:solidFill>
@@ -11267,15 +12210,47 @@
           </a:p>
           <a:p>
             <a:r>
-              <a:rPr sz="1100">
+              <a:rPr sz="1100" dirty="0">
                 <a:solidFill>
                   <a:srgbClr val="5A6A7A"/>
                 </a:solidFill>
               </a:rPr>
               <a:t>• Any change to forecasting parameters, service level, prompt template, or LLM model is version-controlled in the Python package.
-• Monthly override review asks: are recent GM edits signalling parameter drift? If so, we re-fit — we do not silently ignore.
+• Monthly override review asks: are recent GM edits </a:t>
+            </a:r>
+            <a:r>
+              <a:rPr sz="1100" dirty="0" err="1">
+                <a:solidFill>
+                  <a:srgbClr val="5A6A7A"/>
+                </a:solidFill>
+              </a:rPr>
+              <a:t>signalling</a:t>
+            </a:r>
+            <a:r>
+              <a:rPr sz="1100" dirty="0">
+                <a:solidFill>
+                  <a:srgbClr val="5A6A7A"/>
+                </a:solidFill>
+              </a:rPr>
+              <a:t> parameter drift? If so, we re-fit — we do not silently ignore.
 • Recommendation vs. final decision logged per SKU per week, with reason if overridden.
-• Every explanation in the UI is labelled with its source ('llm' or 'template') so that the evaluation loop can detect LLM-path regressions.</a:t>
+• Every explanation in the UI is labelled with its source ('</a:t>
+            </a:r>
+            <a:r>
+              <a:rPr sz="1100" dirty="0" err="1">
+                <a:solidFill>
+                  <a:srgbClr val="5A6A7A"/>
+                </a:solidFill>
+              </a:rPr>
+              <a:t>llm</a:t>
+            </a:r>
+            <a:r>
+              <a:rPr sz="1100" dirty="0">
+                <a:solidFill>
+                  <a:srgbClr val="5A6A7A"/>
+                </a:solidFill>
+              </a:rPr>
+              <a:t>' or 'template') so that the evaluation loop can detect LLM-path regressions.</a:t>
             </a:r>
           </a:p>
         </p:txBody>
@@ -11482,7 +12457,7 @@
         </p:nvGraphicFramePr>
         <p:xfrm>
           <a:off x="274320" y="1143000"/>
-          <a:ext cx="11612880" cy="3474720"/>
+          <a:ext cx="11612880" cy="3572688"/>
         </p:xfrm>
         <a:graphic>
           <a:graphicData uri="http://schemas.openxmlformats.org/drawingml/2006/table">
@@ -12485,7 +13460,7 @@
         </p:nvSpPr>
         <p:spPr>
           <a:xfrm>
-            <a:off x="1097280" y="1005840"/>
+            <a:off x="457200" y="1118382"/>
             <a:ext cx="5669280" cy="4846320"/>
           </a:xfrm>
           <a:prstGeom prst="rect">
@@ -12505,7 +13480,7 @@
               </a:spcAft>
             </a:pPr>
             <a:r>
-              <a:rPr sz="1200">
+              <a:rPr sz="1200" dirty="0">
                 <a:solidFill>
                   <a:srgbClr val="1F2A44"/>
                 </a:solidFill>
@@ -12520,7 +13495,7 @@
               </a:spcAft>
             </a:pPr>
             <a:r>
-              <a:rPr sz="1200">
+              <a:rPr sz="1200" dirty="0">
                 <a:solidFill>
                   <a:srgbClr val="1F2A44"/>
                 </a:solidFill>
@@ -12535,7 +13510,7 @@
               </a:spcAft>
             </a:pPr>
             <a:r>
-              <a:rPr sz="1200">
+              <a:rPr sz="1200" dirty="0">
                 <a:solidFill>
                   <a:srgbClr val="1F2A44"/>
                 </a:solidFill>
@@ -12550,7 +13525,7 @@
               </a:spcAft>
             </a:pPr>
             <a:r>
-              <a:rPr sz="1200">
+              <a:rPr sz="1200" dirty="0">
                 <a:solidFill>
                   <a:srgbClr val="1F2A44"/>
                 </a:solidFill>
@@ -12565,7 +13540,7 @@
               </a:spcAft>
             </a:pPr>
             <a:r>
-              <a:rPr sz="1200">
+              <a:rPr sz="1200" dirty="0">
                 <a:solidFill>
                   <a:srgbClr val="1F2A44"/>
                 </a:solidFill>
@@ -12580,7 +13555,7 @@
               </a:spcAft>
             </a:pPr>
             <a:r>
-              <a:rPr sz="1200">
+              <a:rPr sz="1200" dirty="0">
                 <a:solidFill>
                   <a:srgbClr val="1F2A44"/>
                 </a:solidFill>
@@ -12645,8 +13620,8 @@
         </p:nvSpPr>
         <p:spPr>
           <a:xfrm>
-            <a:off x="6583680" y="1234440"/>
-            <a:ext cx="5029200" cy="5029200"/>
+            <a:off x="6766560" y="1441937"/>
+            <a:ext cx="4681025" cy="2154436"/>
           </a:xfrm>
           <a:prstGeom prst="rect">
             <a:avLst/>
@@ -12660,7 +13635,7 @@
           <a:lstStyle/>
           <a:p>
             <a:r>
-              <a:rPr sz="1300" b="1">
+              <a:rPr sz="1300" b="1" dirty="0">
                 <a:solidFill>
                   <a:srgbClr val="1F2A44"/>
                 </a:solidFill>
@@ -12670,7 +13645,7 @@
           </a:p>
           <a:p>
             <a:r>
-              <a:rPr sz="1100">
+              <a:rPr sz="1100" dirty="0">
                 <a:solidFill>
                   <a:srgbClr val="5A6A7A"/>
                 </a:solidFill>
@@ -13111,7 +14086,7 @@
         </p:nvSpPr>
         <p:spPr>
           <a:xfrm>
-            <a:off x="457200" y="109728"/>
+            <a:off x="457200" y="91440"/>
             <a:ext cx="11277295" cy="685800"/>
           </a:xfrm>
           <a:prstGeom prst="rect">
@@ -13154,7 +14129,7 @@
         </p:nvSpPr>
         <p:spPr>
           <a:xfrm>
-            <a:off x="1188720" y="914400"/>
+            <a:off x="457200" y="1074420"/>
             <a:ext cx="10332720" cy="5120640"/>
           </a:xfrm>
           <a:prstGeom prst="rect">
@@ -13174,7 +14149,7 @@
               </a:spcAft>
             </a:pPr>
             <a:r>
-              <a:rPr sz="1400">
+              <a:rPr sz="1400" dirty="0">
                 <a:solidFill>
                   <a:srgbClr val="1F2A44"/>
                 </a:solidFill>
@@ -13189,7 +14164,7 @@
               </a:spcAft>
             </a:pPr>
             <a:r>
-              <a:rPr sz="1400">
+              <a:rPr sz="1400" dirty="0">
                 <a:solidFill>
                   <a:srgbClr val="1F2A44"/>
                 </a:solidFill>
@@ -13204,7 +14179,7 @@
               </a:spcAft>
             </a:pPr>
             <a:r>
-              <a:rPr sz="1400">
+              <a:rPr sz="1400" dirty="0">
                 <a:solidFill>
                   <a:srgbClr val="1F2A44"/>
                 </a:solidFill>
@@ -13219,7 +14194,7 @@
               </a:spcAft>
             </a:pPr>
             <a:r>
-              <a:rPr sz="1400">
+              <a:rPr sz="1400" dirty="0">
                 <a:solidFill>
                   <a:srgbClr val="1F2A44"/>
                 </a:solidFill>
@@ -13234,7 +14209,7 @@
               </a:spcAft>
             </a:pPr>
             <a:r>
-              <a:rPr sz="1400">
+              <a:rPr sz="1400" dirty="0">
                 <a:solidFill>
                   <a:srgbClr val="1F2A44"/>
                 </a:solidFill>
@@ -13249,7 +14224,7 @@
               </a:spcAft>
             </a:pPr>
             <a:r>
-              <a:rPr sz="1400">
+              <a:rPr sz="1400" dirty="0">
                 <a:solidFill>
                   <a:srgbClr val="1F2A44"/>
                 </a:solidFill>
@@ -14969,7 +15944,7 @@
         <p:spPr>
           <a:xfrm>
             <a:off x="548640" y="4754880"/>
-            <a:ext cx="11064240" cy="1645920"/>
+            <a:ext cx="11155680" cy="461665"/>
           </a:xfrm>
           <a:prstGeom prst="rect">
             <a:avLst/>
@@ -14977,7 +15952,7 @@
           <a:noFill/>
         </p:spPr>
         <p:txBody>
-          <a:bodyPr wrap="none">
+          <a:bodyPr wrap="square">
             <a:spAutoFit/>
           </a:bodyPr>
           <a:lstStyle/>
@@ -15193,7 +16168,7 @@
         </p:nvSpPr>
         <p:spPr>
           <a:xfrm>
-            <a:off x="1097280" y="731520"/>
+            <a:off x="457200" y="1325880"/>
             <a:ext cx="10698480" cy="5303520"/>
           </a:xfrm>
           <a:prstGeom prst="rect">
@@ -15213,7 +16188,7 @@
               </a:spcAft>
             </a:pPr>
             <a:r>
-              <a:rPr sz="1400">
+              <a:rPr sz="1400" dirty="0">
                 <a:solidFill>
                   <a:srgbClr val="1F2A44"/>
                 </a:solidFill>
@@ -15228,7 +16203,7 @@
               </a:spcAft>
             </a:pPr>
             <a:r>
-              <a:rPr sz="1400">
+              <a:rPr sz="1400" dirty="0">
                 <a:solidFill>
                   <a:srgbClr val="1F2A44"/>
                 </a:solidFill>
@@ -15243,7 +16218,7 @@
               </a:spcAft>
             </a:pPr>
             <a:r>
-              <a:rPr sz="1400">
+              <a:rPr sz="1400" dirty="0">
                 <a:solidFill>
                   <a:srgbClr val="1F2A44"/>
                 </a:solidFill>
@@ -15258,7 +16233,7 @@
               </a:spcAft>
             </a:pPr>
             <a:r>
-              <a:rPr sz="1400">
+              <a:rPr sz="1400" dirty="0">
                 <a:solidFill>
                   <a:srgbClr val="1F2A44"/>
                 </a:solidFill>
@@ -15273,7 +16248,7 @@
               </a:spcAft>
             </a:pPr>
             <a:r>
-              <a:rPr sz="1400">
+              <a:rPr sz="1400" dirty="0">
                 <a:solidFill>
                   <a:srgbClr val="1F2A44"/>
                 </a:solidFill>
@@ -15706,8 +16681,8 @@
         </p:nvSpPr>
         <p:spPr>
           <a:xfrm>
-            <a:off x="6675120" y="1234440"/>
-            <a:ext cx="4937760" cy="5029200"/>
+            <a:off x="6858000" y="1435608"/>
+            <a:ext cx="4658810" cy="2339102"/>
           </a:xfrm>
           <a:prstGeom prst="rect">
             <a:avLst/>
@@ -16105,4 +17080,26 @@
   </a:objectDefaults>
   <a:extraClrSchemeLst/>
 </a:theme>
+</file>
+
+<file path=ppt/webextensions/taskpanes.xml><?xml version="1.0" encoding="utf-8"?>
+<wetp:taskpanes xmlns:wetp="http://schemas.microsoft.com/office/webextensions/taskpanes/2010/11">
+  <wetp:taskpane dockstate="right" visibility="0" width="350" row="0">
+    <wetp:webextensionref xmlns:r="http://schemas.openxmlformats.org/officeDocument/2006/relationships" r:id="rId1"/>
+  </wetp:taskpane>
+</wetp:taskpanes>
+</file>
+
+<file path=ppt/webextensions/webextension1.xml><?xml version="1.0" encoding="utf-8"?>
+<we:webextension xmlns:we="http://schemas.microsoft.com/office/webextensions/webextension/2010/11" id="{5234D702-518B-BA44-B8C6-E76E55049235}">
+  <we:reference id="wa200010001" version="1.0.0.1" store="en-US" storeType="OMEX"/>
+  <we:alternateReferences>
+    <we:reference id="wa200010001" version="1.0.0.1" store="en-US" storeType="OMEX"/>
+  </we:alternateReferences>
+  <we:properties>
+    <we:property name="claude.fileId" value="&quot;b179afdc-6d97-40a9-8487-12cf7f9eed91&quot;"/>
+  </we:properties>
+  <we:bindings/>
+  <we:snapshot xmlns:r="http://schemas.openxmlformats.org/officeDocument/2006/relationships"/>
+</we:webextension>
 </file>
</xml_diff>

<commit_message>
feat: clarify open-PO recommendations, widen forecast chart, enforce USD
Co-Authored-By: Claude Opus 4.8 (1M context) <noreply@anthropic.com>
</commit_message>
<xml_diff>
--- a/proposal/Atlas_AI_Solution_Proposal.pptx
+++ b/proposal/Atlas_AI_Solution_Proposal.pptx
@@ -13785,7 +13785,7 @@
           <a:lstStyle/>
           <a:p>
             <a:r>
-              <a:rPr sz="6000" b="1">
+              <a:rPr sz="6000" b="1" dirty="0">
                 <a:solidFill>
                   <a:srgbClr val="FFFFFF"/>
                 </a:solidFill>
@@ -13795,7 +13795,7 @@
           </a:p>
           <a:p>
             <a:r>
-              <a:rPr sz="1600">
+              <a:rPr sz="1600" dirty="0">
                 <a:solidFill>
                   <a:srgbClr val="E67E22"/>
                 </a:solidFill>
@@ -13805,7 +13805,7 @@
           </a:p>
           <a:p>
             <a:r>
-              <a:rPr sz="1400">
+              <a:rPr sz="1400" dirty="0">
                 <a:solidFill>
                   <a:srgbClr val="F4F6F8"/>
                 </a:solidFill>

</xml_diff>